<commit_message>
Include full speaker narration and public sources
Keep internal stage directions and coordination private.

Co-authored-by: Copilot App <223556219+Copilot@users.noreply.github.com>

Copilot-Session: 1eb2797f-3b87-49f8-85d2-d57d82049b02
</commit_message>
<xml_diff>
--- a/downloads/cartea-daliei-ai.pptx
+++ b/downloads/cartea-daliei-ai.pptx
@@ -118,6 +118,1824 @@
     </ns2:lvl9pPr>
   </ns0:defaultTextStyle>
 </ns0:presentation>
+</file>
+
+<file path=ppt/notesMasters/notesMaster1.xml><?xml version="1.0" encoding="utf-8"?>
+<p:notesMaster xmlns:a="http://schemas.openxmlformats.org/drawingml/2006/main" xmlns:p="http://schemas.openxmlformats.org/presentationml/2006/main" xmlns:r="http://schemas.openxmlformats.org/officeDocument/2006/relationships">
+  <p:cSld>
+    <p:bg>
+      <p:bgRef idx="1001">
+        <a:schemeClr val="bg1"/>
+      </p:bgRef>
+    </p:bg>
+    <p:spTree>
+      <p:nvGrpSpPr>
+        <p:cNvPr id="1" name=""/>
+        <p:cNvGrpSpPr/>
+        <p:nvPr/>
+      </p:nvGrpSpPr>
+      <p:grpSpPr>
+        <a:xfrm>
+          <a:off x="0" y="0"/>
+          <a:ext cx="0" cy="0"/>
+          <a:chOff x="0" y="0"/>
+          <a:chExt cx="0" cy="0"/>
+        </a:xfrm>
+      </p:grpSpPr>
+      <p:sp>
+        <p:nvSpPr>
+          <p:cNvPr id="2" name="Header Placeholder 1"/>
+          <p:cNvSpPr>
+            <a:spLocks noGrp="1"/>
+          </p:cNvSpPr>
+          <p:nvPr>
+            <p:ph type="hdr" sz="quarter"/>
+          </p:nvPr>
+        </p:nvSpPr>
+        <p:spPr>
+          <a:xfrm>
+            <a:off x="0" y="0"/>
+            <a:ext cx="2971800" cy="457200"/>
+          </a:xfrm>
+          <a:prstGeom prst="rect">
+            <a:avLst/>
+          </a:prstGeom>
+        </p:spPr>
+        <p:txBody>
+          <a:bodyPr vert="horz" lIns="91440" tIns="45720" rIns="91440" bIns="45720" rtlCol="0"/>
+          <a:lstStyle>
+            <a:lvl1pPr algn="l">
+              <a:defRPr sz="1200"/>
+            </a:lvl1pPr>
+          </a:lstStyle>
+          <a:p>
+            <a:endParaRPr lang="en-US"/>
+          </a:p>
+        </p:txBody>
+      </p:sp>
+      <p:sp>
+        <p:nvSpPr>
+          <p:cNvPr id="3" name="Date Placeholder 2"/>
+          <p:cNvSpPr>
+            <a:spLocks noGrp="1"/>
+          </p:cNvSpPr>
+          <p:nvPr>
+            <p:ph type="dt" idx="1"/>
+          </p:nvPr>
+        </p:nvSpPr>
+        <p:spPr>
+          <a:xfrm>
+            <a:off x="3884613" y="0"/>
+            <a:ext cx="2971800" cy="457200"/>
+          </a:xfrm>
+          <a:prstGeom prst="rect">
+            <a:avLst/>
+          </a:prstGeom>
+        </p:spPr>
+        <p:txBody>
+          <a:bodyPr vert="horz" lIns="91440" tIns="45720" rIns="91440" bIns="45720" rtlCol="0"/>
+          <a:lstStyle>
+            <a:lvl1pPr algn="r">
+              <a:defRPr sz="1200"/>
+            </a:lvl1pPr>
+          </a:lstStyle>
+          <a:p>
+            <a:fld id="{0F89C1C7-3DCD-1040-A9CF-14679D8B5DDD}" type="datetimeFigureOut">
+              <a:rPr lang="en-US" smtClean="0"/>
+              <a:t>10/17/16</a:t>
+            </a:fld>
+            <a:endParaRPr lang="en-US"/>
+          </a:p>
+        </p:txBody>
+      </p:sp>
+      <p:sp>
+        <p:nvSpPr>
+          <p:cNvPr id="4" name="Slide Image Placeholder 3"/>
+          <p:cNvSpPr>
+            <a:spLocks noGrp="1" noRot="1" noChangeAspect="1"/>
+          </p:cNvSpPr>
+          <p:nvPr>
+            <p:ph type="sldImg" idx="2"/>
+          </p:nvPr>
+        </p:nvSpPr>
+        <p:spPr>
+          <a:xfrm>
+            <a:off x="1143000" y="685800"/>
+            <a:ext cx="4572000" cy="3429000"/>
+          </a:xfrm>
+          <a:prstGeom prst="rect">
+            <a:avLst/>
+          </a:prstGeom>
+          <a:noFill/>
+          <a:ln w="12700">
+            <a:solidFill>
+              <a:prstClr val="black"/>
+            </a:solidFill>
+          </a:ln>
+        </p:spPr>
+        <p:txBody>
+          <a:bodyPr vert="horz" lIns="91440" tIns="45720" rIns="91440" bIns="45720" rtlCol="0" anchor="ctr"/>
+          <a:lstStyle/>
+          <a:p>
+            <a:endParaRPr lang="en-US"/>
+          </a:p>
+        </p:txBody>
+      </p:sp>
+      <p:sp>
+        <p:nvSpPr>
+          <p:cNvPr id="5" name="Notes Placeholder 4"/>
+          <p:cNvSpPr>
+            <a:spLocks noGrp="1"/>
+          </p:cNvSpPr>
+          <p:nvPr>
+            <p:ph type="body" sz="quarter" idx="3"/>
+          </p:nvPr>
+        </p:nvSpPr>
+        <p:spPr>
+          <a:xfrm>
+            <a:off x="685800" y="4343400"/>
+            <a:ext cx="5486400" cy="4114800"/>
+          </a:xfrm>
+          <a:prstGeom prst="rect">
+            <a:avLst/>
+          </a:prstGeom>
+        </p:spPr>
+        <p:txBody>
+          <a:bodyPr vert="horz" lIns="91440" tIns="45720" rIns="91440" bIns="45720" rtlCol="0"/>
+          <a:lstStyle/>
+          <a:p>
+            <a:pPr lvl="0"/>
+            <a:r>
+              <a:rPr lang="en-US" smtClean="0"/>
+              <a:t>Click to edit Master text styles</a:t>
+            </a:r>
+          </a:p>
+          <a:p>
+            <a:pPr lvl="1"/>
+            <a:r>
+              <a:rPr lang="en-US" smtClean="0"/>
+              <a:t>Second level</a:t>
+            </a:r>
+          </a:p>
+          <a:p>
+            <a:pPr lvl="2"/>
+            <a:r>
+              <a:rPr lang="en-US" smtClean="0"/>
+              <a:t>Third level</a:t>
+            </a:r>
+          </a:p>
+          <a:p>
+            <a:pPr lvl="3"/>
+            <a:r>
+              <a:rPr lang="en-US" smtClean="0"/>
+              <a:t>Fourth level</a:t>
+            </a:r>
+          </a:p>
+          <a:p>
+            <a:pPr lvl="4"/>
+            <a:r>
+              <a:rPr lang="en-US" smtClean="0"/>
+              <a:t>Fifth level</a:t>
+            </a:r>
+            <a:endParaRPr lang="en-US"/>
+          </a:p>
+        </p:txBody>
+      </p:sp>
+      <p:sp>
+        <p:nvSpPr>
+          <p:cNvPr id="6" name="Footer Placeholder 5"/>
+          <p:cNvSpPr>
+            <a:spLocks noGrp="1"/>
+          </p:cNvSpPr>
+          <p:nvPr>
+            <p:ph type="ftr" sz="quarter" idx="4"/>
+          </p:nvPr>
+        </p:nvSpPr>
+        <p:spPr>
+          <a:xfrm>
+            <a:off x="0" y="8685213"/>
+            <a:ext cx="2971800" cy="457200"/>
+          </a:xfrm>
+          <a:prstGeom prst="rect">
+            <a:avLst/>
+          </a:prstGeom>
+        </p:spPr>
+        <p:txBody>
+          <a:bodyPr vert="horz" lIns="91440" tIns="45720" rIns="91440" bIns="45720" rtlCol="0" anchor="b"/>
+          <a:lstStyle>
+            <a:lvl1pPr algn="l">
+              <a:defRPr sz="1200"/>
+            </a:lvl1pPr>
+          </a:lstStyle>
+          <a:p>
+            <a:endParaRPr lang="en-US"/>
+          </a:p>
+        </p:txBody>
+      </p:sp>
+      <p:sp>
+        <p:nvSpPr>
+          <p:cNvPr id="7" name="Slide Number Placeholder 6"/>
+          <p:cNvSpPr>
+            <a:spLocks noGrp="1"/>
+          </p:cNvSpPr>
+          <p:nvPr>
+            <p:ph type="sldNum" sz="quarter" idx="5"/>
+          </p:nvPr>
+        </p:nvSpPr>
+        <p:spPr>
+          <a:xfrm>
+            <a:off x="3884613" y="8685213"/>
+            <a:ext cx="2971800" cy="457200"/>
+          </a:xfrm>
+          <a:prstGeom prst="rect">
+            <a:avLst/>
+          </a:prstGeom>
+        </p:spPr>
+        <p:txBody>
+          <a:bodyPr vert="horz" lIns="91440" tIns="45720" rIns="91440" bIns="45720" rtlCol="0" anchor="b"/>
+          <a:lstStyle>
+            <a:lvl1pPr algn="r">
+              <a:defRPr sz="1200"/>
+            </a:lvl1pPr>
+          </a:lstStyle>
+          <a:p>
+            <a:fld id="{BB5E49A5-4136-284D-997B-48E1D791AD67}" type="slidenum">
+              <a:rPr lang="en-US" smtClean="0"/>
+              <a:t>‹#›</a:t>
+            </a:fld>
+            <a:endParaRPr lang="en-US"/>
+          </a:p>
+        </p:txBody>
+      </p:sp>
+    </p:spTree>
+    <p:extLst>
+      <p:ext uri="{BB962C8B-B14F-4D97-AF65-F5344CB8AC3E}">
+        <p14:creationId xmlns:p14="http://schemas.microsoft.com/office/powerpoint/2010/main" val="2623252185"/>
+      </p:ext>
+    </p:extLst>
+  </p:cSld>
+  <p:clrMap bg1="lt1" tx1="dk1" bg2="lt2" tx2="dk2" accent1="accent1" accent2="accent2" accent3="accent3" accent4="accent4" accent5="accent5" accent6="accent6" hlink="hlink" folHlink="folHlink"/>
+  <p:notesStyle>
+    <a:lvl1pPr marL="0" algn="l" defTabSz="457200" rtl="0" eaLnBrk="1" latinLnBrk="0" hangingPunct="1">
+      <a:defRPr sz="1200" kern="1200">
+        <a:solidFill>
+          <a:schemeClr val="tx1"/>
+        </a:solidFill>
+        <a:latin typeface="+mn-lt"/>
+        <a:ea typeface="+mn-ea"/>
+        <a:cs typeface="+mn-cs"/>
+      </a:defRPr>
+    </a:lvl1pPr>
+    <a:lvl2pPr marL="457200" algn="l" defTabSz="457200" rtl="0" eaLnBrk="1" latinLnBrk="0" hangingPunct="1">
+      <a:defRPr sz="1200" kern="1200">
+        <a:solidFill>
+          <a:schemeClr val="tx1"/>
+        </a:solidFill>
+        <a:latin typeface="+mn-lt"/>
+        <a:ea typeface="+mn-ea"/>
+        <a:cs typeface="+mn-cs"/>
+      </a:defRPr>
+    </a:lvl2pPr>
+    <a:lvl3pPr marL="914400" algn="l" defTabSz="457200" rtl="0" eaLnBrk="1" latinLnBrk="0" hangingPunct="1">
+      <a:defRPr sz="1200" kern="1200">
+        <a:solidFill>
+          <a:schemeClr val="tx1"/>
+        </a:solidFill>
+        <a:latin typeface="+mn-lt"/>
+        <a:ea typeface="+mn-ea"/>
+        <a:cs typeface="+mn-cs"/>
+      </a:defRPr>
+    </a:lvl3pPr>
+    <a:lvl4pPr marL="1371600" algn="l" defTabSz="457200" rtl="0" eaLnBrk="1" latinLnBrk="0" hangingPunct="1">
+      <a:defRPr sz="1200" kern="1200">
+        <a:solidFill>
+          <a:schemeClr val="tx1"/>
+        </a:solidFill>
+        <a:latin typeface="+mn-lt"/>
+        <a:ea typeface="+mn-ea"/>
+        <a:cs typeface="+mn-cs"/>
+      </a:defRPr>
+    </a:lvl4pPr>
+    <a:lvl5pPr marL="1828800" algn="l" defTabSz="457200" rtl="0" eaLnBrk="1" latinLnBrk="0" hangingPunct="1">
+      <a:defRPr sz="1200" kern="1200">
+        <a:solidFill>
+          <a:schemeClr val="tx1"/>
+        </a:solidFill>
+        <a:latin typeface="+mn-lt"/>
+        <a:ea typeface="+mn-ea"/>
+        <a:cs typeface="+mn-cs"/>
+      </a:defRPr>
+    </a:lvl5pPr>
+    <a:lvl6pPr marL="2286000" algn="l" defTabSz="457200" rtl="0" eaLnBrk="1" latinLnBrk="0" hangingPunct="1">
+      <a:defRPr sz="1200" kern="1200">
+        <a:solidFill>
+          <a:schemeClr val="tx1"/>
+        </a:solidFill>
+        <a:latin typeface="+mn-lt"/>
+        <a:ea typeface="+mn-ea"/>
+        <a:cs typeface="+mn-cs"/>
+      </a:defRPr>
+    </a:lvl6pPr>
+    <a:lvl7pPr marL="2743200" algn="l" defTabSz="457200" rtl="0" eaLnBrk="1" latinLnBrk="0" hangingPunct="1">
+      <a:defRPr sz="1200" kern="1200">
+        <a:solidFill>
+          <a:schemeClr val="tx1"/>
+        </a:solidFill>
+        <a:latin typeface="+mn-lt"/>
+        <a:ea typeface="+mn-ea"/>
+        <a:cs typeface="+mn-cs"/>
+      </a:defRPr>
+    </a:lvl7pPr>
+    <a:lvl8pPr marL="3200400" algn="l" defTabSz="457200" rtl="0" eaLnBrk="1" latinLnBrk="0" hangingPunct="1">
+      <a:defRPr sz="1200" kern="1200">
+        <a:solidFill>
+          <a:schemeClr val="tx1"/>
+        </a:solidFill>
+        <a:latin typeface="+mn-lt"/>
+        <a:ea typeface="+mn-ea"/>
+        <a:cs typeface="+mn-cs"/>
+      </a:defRPr>
+    </a:lvl8pPr>
+    <a:lvl9pPr marL="3657600" algn="l" defTabSz="457200" rtl="0" eaLnBrk="1" latinLnBrk="0" hangingPunct="1">
+      <a:defRPr sz="1200" kern="1200">
+        <a:solidFill>
+          <a:schemeClr val="tx1"/>
+        </a:solidFill>
+        <a:latin typeface="+mn-lt"/>
+        <a:ea typeface="+mn-ea"/>
+        <a:cs typeface="+mn-cs"/>
+      </a:defRPr>
+    </a:lvl9pPr>
+  </p:notesStyle>
+</p:notesMaster>
+</file>
+
+<file path=ppt/notesSlides/notesSlide1.xml><?xml version="1.0" encoding="utf-8"?>
+<p:notes xmlns:a="http://schemas.openxmlformats.org/drawingml/2006/main" xmlns:p="http://schemas.openxmlformats.org/presentationml/2006/main" xmlns:r="http://schemas.openxmlformats.org/officeDocument/2006/relationships">
+  <p:cSld>
+    <p:spTree>
+      <p:nvGrpSpPr>
+        <p:cNvPr id="1" name=""/>
+        <p:cNvGrpSpPr/>
+        <p:nvPr/>
+      </p:nvGrpSpPr>
+      <p:grpSpPr>
+        <a:xfrm>
+          <a:off x="0" y="0"/>
+          <a:ext cx="0" cy="0"/>
+          <a:chOff x="0" y="0"/>
+          <a:chExt cx="0" cy="0"/>
+        </a:xfrm>
+      </p:grpSpPr>
+      <p:sp>
+        <p:nvSpPr>
+          <p:cNvPr id="2" name="Slide Image Placeholder 1"/>
+          <p:cNvSpPr>
+            <a:spLocks noGrp="1"/>
+          </p:cNvSpPr>
+          <p:nvPr>
+            <p:ph type="sldImg" idx="2"/>
+          </p:nvPr>
+        </p:nvSpPr>
+        <p:spPr/>
+      </p:sp>
+      <p:sp>
+        <p:nvSpPr>
+          <p:cNvPr id="3" name="Notes Placeholder 2"/>
+          <p:cNvSpPr>
+            <a:spLocks noGrp="1"/>
+          </p:cNvSpPr>
+          <p:nvPr>
+            <p:ph type="body" idx="3" sz="quarter"/>
+          </p:nvPr>
+        </p:nvSpPr>
+        <p:spPr/>
+        <p:txBody>
+          <a:bodyPr/>
+          <a:lstStyle/>
+          <a:p>
+            <a:r>
+              <a:t>SLIDE 1</a:t>
+            </a:r>
+          </a:p>
+          <a:p/>
+          <a:p>
+            <a:r>
+              <a:t>Cand eram de varsta voastra, auzeam despre calculatoare de la alti copii care aveau unul. Eu nu aveam, dar la un moment dat am primit o foaie cu comenzile unui limbaj de programare, BASIC.</a:t>
+            </a:r>
+          </a:p>
+          <a:p>
+            <a:r>
+              <a:t>Am inceput sa scriu programe pe hartie. Le dadeam unui prieten care avea calculator, iar a doua zi imi aducea notite sau imi povestea ce nu mersese. Eu corectam si incercam din nou. Faceam un fel de remote debugging, doar ca raspunsul venea a doua zi.</a:t>
+            </a:r>
+          </a:p>
+          <a:p>
+            <a:r>
+              <a:t>In timp am avut si eu calculatorul meu si, de atunci, calculatoarele au ramas parte din viata mea.</a:t>
+            </a:r>
+          </a:p>
+          <a:p>
+            <a:r>
+              <a:t>Astazi putem incerca idei mult mai repede. Dar partea care imi place a ramas aceeasi: ai o idee, incerci ceva, observi ce nu merge si imbunatatesti. Astazi o sa facem impreuna exact asta, cu ajutorul AI.</a:t>
+            </a:r>
+          </a:p>
+          <a:p/>
+          <a:p>
+            <a:r>
+              <a:t>SURSE</a:t>
+            </a:r>
+          </a:p>
+          <a:p>
+            <a:r>
+              <a:t>Poveste oferita de Dragos sau exemplu educational original.</a:t>
+            </a:r>
+          </a:p>
+        </p:txBody>
+      </p:sp>
+      <p:sp>
+        <p:nvSpPr>
+          <p:cNvPr id="4" name="Slide Number Placeholder 3"/>
+          <p:cNvSpPr>
+            <a:spLocks noGrp="1"/>
+          </p:cNvSpPr>
+          <p:nvPr>
+            <p:ph type="sldNum" idx="5" sz="quarter"/>
+          </p:nvPr>
+        </p:nvSpPr>
+        <p:spPr/>
+      </p:sp>
+    </p:spTree>
+  </p:cSld>
+  <p:clrMapOvr>
+    <a:masterClrMapping/>
+  </p:clrMapOvr>
+</p:notes>
+</file>
+
+<file path=ppt/notesSlides/notesSlide10.xml><?xml version="1.0" encoding="utf-8"?>
+<p:notes xmlns:a="http://schemas.openxmlformats.org/drawingml/2006/main" xmlns:p="http://schemas.openxmlformats.org/presentationml/2006/main" xmlns:r="http://schemas.openxmlformats.org/officeDocument/2006/relationships">
+  <p:cSld>
+    <p:spTree>
+      <p:nvGrpSpPr>
+        <p:cNvPr id="1" name=""/>
+        <p:cNvGrpSpPr/>
+        <p:nvPr/>
+      </p:nvGrpSpPr>
+      <p:grpSpPr>
+        <a:xfrm>
+          <a:off x="0" y="0"/>
+          <a:ext cx="0" cy="0"/>
+          <a:chOff x="0" y="0"/>
+          <a:chExt cx="0" cy="0"/>
+        </a:xfrm>
+      </p:grpSpPr>
+      <p:sp>
+        <p:nvSpPr>
+          <p:cNvPr id="2" name="Slide Image Placeholder 1"/>
+          <p:cNvSpPr>
+            <a:spLocks noGrp="1"/>
+          </p:cNvSpPr>
+          <p:nvPr>
+            <p:ph type="sldImg" idx="2"/>
+          </p:nvPr>
+        </p:nvSpPr>
+        <p:spPr/>
+      </p:sp>
+      <p:sp>
+        <p:nvSpPr>
+          <p:cNvPr id="3" name="Notes Placeholder 2"/>
+          <p:cNvSpPr>
+            <a:spLocks noGrp="1"/>
+          </p:cNvSpPr>
+          <p:nvPr>
+            <p:ph type="body" idx="3" sz="quarter"/>
+          </p:nvPr>
+        </p:nvSpPr>
+        <p:spPr/>
+        <p:txBody>
+          <a:bodyPr/>
+          <a:lstStyle/>
+          <a:p>
+            <a:r>
+              <a:t>SLIDE 10</a:t>
+            </a:r>
+          </a:p>
+          <a:p/>
+          <a:p>
+            <a:r>
+              <a:t>Din tot ce am facut, as pastra cinci obiceiuri.</a:t>
+            </a:r>
+          </a:p>
+          <a:p>
+            <a:r>
+              <a:t>Protejeaza-ti datele: nu ai nevoie sa trimiti parole, acte sau informatii despre colegi ca sa explorezi o idee.</a:t>
+            </a:r>
+          </a:p>
+          <a:p>
+            <a:r>
+              <a:t>Verifica ce conteaza. Nu verificam la fel culoarea unui buton si o afirmatie despre sanatate.</a:t>
+            </a:r>
+          </a:p>
+          <a:p>
+            <a:r>
+              <a:t>Nu confunda tonul sigur cu adevarul. Ati vazut ca aspectul si corectitudinea sunt lucruri diferite.</a:t>
+            </a:r>
+          </a:p>
+          <a:p>
+            <a:r>
+              <a:t>Spune unde te-a ajutat AI si respecta regulile scolii. Contributia ta poate fi ideea, selectia, verificarea si ceea ce ai schimbat.</a:t>
+            </a:r>
+          </a:p>
+          <a:p>
+            <a:r>
+              <a:t>Si pastreaza decizia la tine. Daca nu intelegi rezultatul sau consecintele, opreste-te si cere sprijin. A folosi AI responsabil inseamna sa stii si cand sa nu te bazezi pe el.</a:t>
+            </a:r>
+          </a:p>
+          <a:p/>
+          <a:p>
+            <a:r>
+              <a:t>SURSE</a:t>
+            </a:r>
+          </a:p>
+          <a:p>
+            <a:r>
+              <a:t>https://dayofai.org/units/truth-tricks-and-ai-learning-to-verify-information</a:t>
+            </a:r>
+          </a:p>
+        </p:txBody>
+      </p:sp>
+      <p:sp>
+        <p:nvSpPr>
+          <p:cNvPr id="4" name="Slide Number Placeholder 3"/>
+          <p:cNvSpPr>
+            <a:spLocks noGrp="1"/>
+          </p:cNvSpPr>
+          <p:nvPr>
+            <p:ph type="sldNum" idx="5" sz="quarter"/>
+          </p:nvPr>
+        </p:nvSpPr>
+        <p:spPr/>
+      </p:sp>
+    </p:spTree>
+  </p:cSld>
+  <p:clrMapOvr>
+    <a:masterClrMapping/>
+  </p:clrMapOvr>
+</p:notes>
+</file>
+
+<file path=ppt/notesSlides/notesSlide11.xml><?xml version="1.0" encoding="utf-8"?>
+<p:notes xmlns:a="http://schemas.openxmlformats.org/drawingml/2006/main" xmlns:p="http://schemas.openxmlformats.org/presentationml/2006/main" xmlns:r="http://schemas.openxmlformats.org/officeDocument/2006/relationships">
+  <p:cSld>
+    <p:spTree>
+      <p:nvGrpSpPr>
+        <p:cNvPr id="1" name=""/>
+        <p:cNvGrpSpPr/>
+        <p:nvPr/>
+      </p:nvGrpSpPr>
+      <p:grpSpPr>
+        <a:xfrm>
+          <a:off x="0" y="0"/>
+          <a:ext cx="0" cy="0"/>
+          <a:chOff x="0" y="0"/>
+          <a:chExt cx="0" cy="0"/>
+        </a:xfrm>
+      </p:grpSpPr>
+      <p:sp>
+        <p:nvSpPr>
+          <p:cNvPr id="2" name="Slide Image Placeholder 1"/>
+          <p:cNvSpPr>
+            <a:spLocks noGrp="1"/>
+          </p:cNvSpPr>
+          <p:nvPr>
+            <p:ph type="sldImg" idx="2"/>
+          </p:nvPr>
+        </p:nvSpPr>
+        <p:spPr/>
+      </p:sp>
+      <p:sp>
+        <p:nvSpPr>
+          <p:cNvPr id="3" name="Notes Placeholder 2"/>
+          <p:cNvSpPr>
+            <a:spLocks noGrp="1"/>
+          </p:cNvSpPr>
+          <p:nvPr>
+            <p:ph type="body" idx="3" sz="quarter"/>
+          </p:nvPr>
+        </p:nvSpPr>
+        <p:spPr/>
+        <p:txBody>
+          <a:bodyPr/>
+          <a:lstStyle/>
+          <a:p>
+            <a:r>
+              <a:t>SLIDE 11</a:t>
+            </a:r>
+          </a:p>
+          <a:p/>
+          <a:p>
+            <a:r>
+              <a:t>Poate ca partea de cod v-a atras. Sau poate v-ati uitat mai degraba la cum arata pagina, la ce lipseste din program ori la cine poate participa.</a:t>
+            </a:r>
+          </a:p>
+          <a:p>
+            <a:r>
+              <a:t>Toate acestea au legatura cu munca in tech. Un software engineer construieste aplicatia. Cineva din cybersecurity se intreaba cum poate fi folosita gresit si cum o protejam. Data si AI inseamna sa lucrezi cu date si sa verifici ce concluzii poti trage.</a:t>
+            </a:r>
+          </a:p>
+          <a:p>
+            <a:r>
+              <a:t>UX inseamna sa intelegi oamenii si sa faci produsul usor de folosit. Product inseamna sa alegi problema si prioritatile. Responsible AI inseamna sa te gandesti la efecte, riscuri si echitate.</a:t>
+            </a:r>
+          </a:p>
+          <a:p>
+            <a:r>
+              <a:t>Nu trebuie sa va alegeti acum o meserie. Puteti observa ce fel de intrebari va place sa puneti si sa incercati proiecte mici in directia aceea.</a:t>
+            </a:r>
+          </a:p>
+          <a:p/>
+          <a:p>
+            <a:r>
+              <a:t>SURSE</a:t>
+            </a:r>
+          </a:p>
+          <a:p>
+            <a:r>
+              <a:t>Poveste oferita de Dragos sau exemplu educational original.</a:t>
+            </a:r>
+          </a:p>
+        </p:txBody>
+      </p:sp>
+      <p:sp>
+        <p:nvSpPr>
+          <p:cNvPr id="4" name="Slide Number Placeholder 3"/>
+          <p:cNvSpPr>
+            <a:spLocks noGrp="1"/>
+          </p:cNvSpPr>
+          <p:nvPr>
+            <p:ph type="sldNum" idx="5" sz="quarter"/>
+          </p:nvPr>
+        </p:nvSpPr>
+        <p:spPr/>
+      </p:sp>
+    </p:spTree>
+  </p:cSld>
+  <p:clrMapOvr>
+    <a:masterClrMapping/>
+  </p:clrMapOvr>
+</p:notes>
+</file>
+
+<file path=ppt/notesSlides/notesSlide12.xml><?xml version="1.0" encoding="utf-8"?>
+<p:notes xmlns:a="http://schemas.openxmlformats.org/drawingml/2006/main" xmlns:p="http://schemas.openxmlformats.org/presentationml/2006/main" xmlns:r="http://schemas.openxmlformats.org/officeDocument/2006/relationships">
+  <p:cSld>
+    <p:spTree>
+      <p:nvGrpSpPr>
+        <p:cNvPr id="1" name=""/>
+        <p:cNvGrpSpPr/>
+        <p:nvPr/>
+      </p:nvGrpSpPr>
+      <p:grpSpPr>
+        <a:xfrm>
+          <a:off x="0" y="0"/>
+          <a:ext cx="0" cy="0"/>
+          <a:chOff x="0" y="0"/>
+          <a:chExt cx="0" cy="0"/>
+        </a:xfrm>
+      </p:grpSpPr>
+      <p:sp>
+        <p:nvSpPr>
+          <p:cNvPr id="2" name="Slide Image Placeholder 1"/>
+          <p:cNvSpPr>
+            <a:spLocks noGrp="1"/>
+          </p:cNvSpPr>
+          <p:nvPr>
+            <p:ph type="sldImg" idx="2"/>
+          </p:nvPr>
+        </p:nvSpPr>
+        <p:spPr/>
+      </p:sp>
+      <p:sp>
+        <p:nvSpPr>
+          <p:cNvPr id="3" name="Notes Placeholder 2"/>
+          <p:cNvSpPr>
+            <a:spLocks noGrp="1"/>
+          </p:cNvSpPr>
+          <p:nvPr>
+            <p:ph type="body" idx="3" sz="quarter"/>
+          </p:nvPr>
+        </p:nvSpPr>
+        <p:spPr/>
+        <p:txBody>
+          <a:bodyPr/>
+          <a:lstStyle/>
+          <a:p>
+            <a:r>
+              <a:t>SLIDE 12</a:t>
+            </a:r>
+          </a:p>
+          <a:p/>
+          <a:p>
+            <a:r>
+              <a:t>Sa luam un rol de Product: te ocupi ca pagina sa rezolve o problema pentru oameni. AI iti poate propune texte, schite si un program.</a:t>
+            </a:r>
+          </a:p>
+          <a:p>
+            <a:r>
+              <a:t>Dar daca participantii nu pot ramane dupa o anumita ora? Daca unii nu au laptop? Daca sala nu poate fi folosita atunci? Ai nevoie sa cunosti situatia, sa asculti si sa alegi ce este fezabil. O pagina convingatoare nu rezolva singura aceste lucruri.</a:t>
+            </a:r>
+          </a:p>
+          <a:p>
+            <a:r>
+              <a:t>Unele sisteme pot deja folosi mai multe instrumente. In viitor am putea vedea mai multe activitati legate automat, dar nu stim exact ritmul, costul sau cat de fiabile vor deveni.</a:t>
+            </a:r>
+          </a:p>
+          <a:p>
+            <a:r>
+              <a:t>De aceea este mai util sa ne uitam la activitati decat sa spunem ca o meserie dispare sau este complet sigura. Cunostintele va ajuta sa observati greselile. Curiozitatea va ajuta sa explorati. Comunicarea si judecata va ajuta sa lucrati cu ceilalti si sa alegeti ce merita facut.</a:t>
+            </a:r>
+          </a:p>
+          <a:p/>
+          <a:p>
+            <a:r>
+              <a:t>SURSE</a:t>
+            </a:r>
+          </a:p>
+          <a:p>
+            <a:r>
+              <a:t>https://www.ilo.org/publications/generative-ai-and-jobs-2025-update</a:t>
+            </a:r>
+          </a:p>
+        </p:txBody>
+      </p:sp>
+      <p:sp>
+        <p:nvSpPr>
+          <p:cNvPr id="4" name="Slide Number Placeholder 3"/>
+          <p:cNvSpPr>
+            <a:spLocks noGrp="1"/>
+          </p:cNvSpPr>
+          <p:nvPr>
+            <p:ph type="sldNum" idx="5" sz="quarter"/>
+          </p:nvPr>
+        </p:nvSpPr>
+        <p:spPr/>
+      </p:sp>
+    </p:spTree>
+  </p:cSld>
+  <p:clrMapOvr>
+    <a:masterClrMapping/>
+  </p:clrMapOvr>
+</p:notes>
+</file>
+
+<file path=ppt/notesSlides/notesSlide13.xml><?xml version="1.0" encoding="utf-8"?>
+<p:notes xmlns:a="http://schemas.openxmlformats.org/drawingml/2006/main" xmlns:p="http://schemas.openxmlformats.org/presentationml/2006/main" xmlns:r="http://schemas.openxmlformats.org/officeDocument/2006/relationships">
+  <p:cSld>
+    <p:spTree>
+      <p:nvGrpSpPr>
+        <p:cNvPr id="1" name=""/>
+        <p:cNvGrpSpPr/>
+        <p:nvPr/>
+      </p:nvGrpSpPr>
+      <p:grpSpPr>
+        <a:xfrm>
+          <a:off x="0" y="0"/>
+          <a:ext cx="0" cy="0"/>
+          <a:chOff x="0" y="0"/>
+          <a:chExt cx="0" cy="0"/>
+        </a:xfrm>
+      </p:grpSpPr>
+      <p:sp>
+        <p:nvSpPr>
+          <p:cNvPr id="2" name="Slide Image Placeholder 1"/>
+          <p:cNvSpPr>
+            <a:spLocks noGrp="1"/>
+          </p:cNvSpPr>
+          <p:nvPr>
+            <p:ph type="sldImg" idx="2"/>
+          </p:nvPr>
+        </p:nvSpPr>
+        <p:spPr/>
+      </p:sp>
+      <p:sp>
+        <p:nvSpPr>
+          <p:cNvPr id="3" name="Notes Placeholder 2"/>
+          <p:cNvSpPr>
+            <a:spLocks noGrp="1"/>
+          </p:cNvSpPr>
+          <p:nvPr>
+            <p:ph type="body" idx="3" sz="quarter"/>
+          </p:nvPr>
+        </p:nvSpPr>
+        <p:spPr/>
+        <p:txBody>
+          <a:bodyPr/>
+          <a:lstStyle/>
+          <a:p>
+            <a:r>
+              <a:t>SLIDE 13</a:t>
+            </a:r>
+          </a:p>
+          <a:p/>
+          <a:p>
+            <a:r>
+              <a:t>Pentru cei care vor sa incerce, GitHub Copilot are o varianta Free, cu limite, si exista beneficii GitHub Education pentru elevii eligibili.</a:t>
+            </a:r>
+          </a:p>
+          <a:p>
+            <a:r>
+              <a:t>Nu trebuie sa facem conturi acum. Puteti incepe si cu o idee pe hartie: ce vreti sa obtineti si cum veti sti ca a functionat?</a:t>
+            </a:r>
+          </a:p>
+          <a:p>
+            <a:r>
+              <a:t>Mi-ar placea sa alegeti ceva care va intereseaza, nu ceva ce credeti ca trebuie sa impresioneze. Un inceput mic va da ceva real de imbunatatit.</a:t>
+            </a:r>
+          </a:p>
+          <a:p/>
+          <a:p>
+            <a:r>
+              <a:t>SURSE</a:t>
+            </a:r>
+          </a:p>
+          <a:p>
+            <a:r>
+              <a:t>https://docs.github.com/en/copilot/get-started/plans</a:t>
+            </a:r>
+          </a:p>
+          <a:p>
+            <a:r>
+              <a:t>https://docs.github.com/en/copilot/concepts/billing-and-usage/individuals/billing</a:t>
+            </a:r>
+          </a:p>
+          <a:p>
+            <a:r>
+              <a:t>https://education.github.com/pack</a:t>
+            </a:r>
+          </a:p>
+          <a:p>
+            <a:r>
+              <a:t>https://docs.github.com/en/education/about-github-education/github-education-for-students/apply-to-github-education-as-a-student</a:t>
+            </a:r>
+          </a:p>
+          <a:p>
+            <a:r>
+              <a:t>https://www.3blue1brown.com/lessons/mini-llm/</a:t>
+            </a:r>
+          </a:p>
+        </p:txBody>
+      </p:sp>
+      <p:sp>
+        <p:nvSpPr>
+          <p:cNvPr id="4" name="Slide Number Placeholder 3"/>
+          <p:cNvSpPr>
+            <a:spLocks noGrp="1"/>
+          </p:cNvSpPr>
+          <p:nvPr>
+            <p:ph type="sldNum" idx="5" sz="quarter"/>
+          </p:nvPr>
+        </p:nvSpPr>
+        <p:spPr/>
+      </p:sp>
+    </p:spTree>
+  </p:cSld>
+  <p:clrMapOvr>
+    <a:masterClrMapping/>
+  </p:clrMapOvr>
+</p:notes>
+</file>
+
+<file path=ppt/notesSlides/notesSlide14.xml><?xml version="1.0" encoding="utf-8"?>
+<p:notes xmlns:a="http://schemas.openxmlformats.org/drawingml/2006/main" xmlns:p="http://schemas.openxmlformats.org/presentationml/2006/main" xmlns:r="http://schemas.openxmlformats.org/officeDocument/2006/relationships">
+  <p:cSld>
+    <p:spTree>
+      <p:nvGrpSpPr>
+        <p:cNvPr id="1" name=""/>
+        <p:cNvGrpSpPr/>
+        <p:nvPr/>
+      </p:nvGrpSpPr>
+      <p:grpSpPr>
+        <a:xfrm>
+          <a:off x="0" y="0"/>
+          <a:ext cx="0" cy="0"/>
+          <a:chOff x="0" y="0"/>
+          <a:chExt cx="0" cy="0"/>
+        </a:xfrm>
+      </p:grpSpPr>
+      <p:sp>
+        <p:nvSpPr>
+          <p:cNvPr id="2" name="Slide Image Placeholder 1"/>
+          <p:cNvSpPr>
+            <a:spLocks noGrp="1"/>
+          </p:cNvSpPr>
+          <p:nvPr>
+            <p:ph type="sldImg" idx="2"/>
+          </p:nvPr>
+        </p:nvSpPr>
+        <p:spPr/>
+      </p:sp>
+      <p:sp>
+        <p:nvSpPr>
+          <p:cNvPr id="3" name="Notes Placeholder 2"/>
+          <p:cNvSpPr>
+            <a:spLocks noGrp="1"/>
+          </p:cNvSpPr>
+          <p:nvPr>
+            <p:ph type="body" idx="3" sz="quarter"/>
+          </p:nvPr>
+        </p:nvSpPr>
+        <p:spPr/>
+        <p:txBody>
+          <a:bodyPr/>
+          <a:lstStyle/>
+          <a:p>
+            <a:r>
+              <a:t>SLIDE 14</a:t>
+            </a:r>
+          </a:p>
+          <a:p/>
+          <a:p>
+            <a:r>
+              <a:t>As vrea sa ramaneti cu trei lucruri.</a:t>
+            </a:r>
+          </a:p>
+          <a:p>
+            <a:r>
+              <a:t>AI este un instrument foarte puternic, dar nu este infailibil.</a:t>
+            </a:r>
+          </a:p>
+          <a:p>
+            <a:r>
+              <a:t>Valoarea voastra ramane in intrebarile pe care le puneti, in alegeri si in felul in care ganditi.</a:t>
+            </a:r>
+          </a:p>
+          <a:p>
+            <a:r>
+              <a:t>Si nu trebuie sa stiti deja totul ca sa incepeti sa explorati si sa construiti.</a:t>
+            </a:r>
+          </a:p>
+          <a:p>
+            <a:r>
+              <a:t>Eu am inceput cu o foaie de comenzi si programe pe hartie. Provocarea mea pentru voi: alegeti o idee, incercati-o si aratati ce ati schimbat, verificat si invatat. Puteti incepe si pe hartie.</a:t>
+            </a:r>
+          </a:p>
+          <a:p>
+            <a:r>
+              <a:t>Acum sunt curios ce intrebari aveti.</a:t>
+            </a:r>
+          </a:p>
+          <a:p/>
+          <a:p>
+            <a:r>
+              <a:t>SURSE</a:t>
+            </a:r>
+          </a:p>
+          <a:p>
+            <a:r>
+              <a:t>Poveste oferita de Dragos sau exemplu educational original.</a:t>
+            </a:r>
+          </a:p>
+        </p:txBody>
+      </p:sp>
+      <p:sp>
+        <p:nvSpPr>
+          <p:cNvPr id="4" name="Slide Number Placeholder 3"/>
+          <p:cNvSpPr>
+            <a:spLocks noGrp="1"/>
+          </p:cNvSpPr>
+          <p:nvPr>
+            <p:ph type="sldNum" idx="5" sz="quarter"/>
+          </p:nvPr>
+        </p:nvSpPr>
+        <p:spPr/>
+      </p:sp>
+    </p:spTree>
+  </p:cSld>
+  <p:clrMapOvr>
+    <a:masterClrMapping/>
+  </p:clrMapOvr>
+</p:notes>
+</file>
+
+<file path=ppt/notesSlides/notesSlide2.xml><?xml version="1.0" encoding="utf-8"?>
+<p:notes xmlns:a="http://schemas.openxmlformats.org/drawingml/2006/main" xmlns:p="http://schemas.openxmlformats.org/presentationml/2006/main" xmlns:r="http://schemas.openxmlformats.org/officeDocument/2006/relationships">
+  <p:cSld>
+    <p:spTree>
+      <p:nvGrpSpPr>
+        <p:cNvPr id="1" name=""/>
+        <p:cNvGrpSpPr/>
+        <p:nvPr/>
+      </p:nvGrpSpPr>
+      <p:grpSpPr>
+        <a:xfrm>
+          <a:off x="0" y="0"/>
+          <a:ext cx="0" cy="0"/>
+          <a:chOff x="0" y="0"/>
+          <a:chExt cx="0" cy="0"/>
+        </a:xfrm>
+      </p:grpSpPr>
+      <p:sp>
+        <p:nvSpPr>
+          <p:cNvPr id="2" name="Slide Image Placeholder 1"/>
+          <p:cNvSpPr>
+            <a:spLocks noGrp="1"/>
+          </p:cNvSpPr>
+          <p:nvPr>
+            <p:ph type="sldImg" idx="2"/>
+          </p:nvPr>
+        </p:nvSpPr>
+        <p:spPr/>
+      </p:sp>
+      <p:sp>
+        <p:nvSpPr>
+          <p:cNvPr id="3" name="Notes Placeholder 2"/>
+          <p:cNvSpPr>
+            <a:spLocks noGrp="1"/>
+          </p:cNvSpPr>
+          <p:nvPr>
+            <p:ph type="body" idx="3" sz="quarter"/>
+          </p:nvPr>
+        </p:nvSpPr>
+        <p:spPr/>
+        <p:txBody>
+          <a:bodyPr/>
+          <a:lstStyle/>
+          <a:p>
+            <a:r>
+              <a:t>SLIDE 2</a:t>
+            </a:r>
+          </a:p>
+          <a:p/>
+          <a:p>
+            <a:r>
+              <a:t>Inainte sa va arat ceva, sunt curios de unde pornim. Pentru ce ati folosit AI pana acum? Alegeti varianta cea mai apropiata de voi; si 'inca nu' este un raspuns foarte bun.</a:t>
+            </a:r>
+          </a:p>
+          <a:p>
+            <a:r>
+              <a:t>Probabil avem experiente diferite. Pana la final vreau sa puteti face doua lucruri: sa formulati mai bine o cerere si sa verificati un rezultat fara sa va bazati doar pe AI.</a:t>
+            </a:r>
+          </a:p>
+          <a:p/>
+          <a:p>
+            <a:r>
+              <a:t>SURSE</a:t>
+            </a:r>
+          </a:p>
+          <a:p>
+            <a:r>
+              <a:t>Poveste oferita de Dragos sau exemplu educational original.</a:t>
+            </a:r>
+          </a:p>
+        </p:txBody>
+      </p:sp>
+      <p:sp>
+        <p:nvSpPr>
+          <p:cNvPr id="4" name="Slide Number Placeholder 3"/>
+          <p:cNvSpPr>
+            <a:spLocks noGrp="1"/>
+          </p:cNvSpPr>
+          <p:nvPr>
+            <p:ph type="sldNum" idx="5" sz="quarter"/>
+          </p:nvPr>
+        </p:nvSpPr>
+        <p:spPr/>
+      </p:sp>
+    </p:spTree>
+  </p:cSld>
+  <p:clrMapOvr>
+    <a:masterClrMapping/>
+  </p:clrMapOvr>
+</p:notes>
+</file>
+
+<file path=ppt/notesSlides/notesSlide3.xml><?xml version="1.0" encoding="utf-8"?>
+<p:notes xmlns:a="http://schemas.openxmlformats.org/drawingml/2006/main" xmlns:p="http://schemas.openxmlformats.org/presentationml/2006/main" xmlns:r="http://schemas.openxmlformats.org/officeDocument/2006/relationships">
+  <p:cSld>
+    <p:spTree>
+      <p:nvGrpSpPr>
+        <p:cNvPr id="1" name=""/>
+        <p:cNvGrpSpPr/>
+        <p:nvPr/>
+      </p:nvGrpSpPr>
+      <p:grpSpPr>
+        <a:xfrm>
+          <a:off x="0" y="0"/>
+          <a:ext cx="0" cy="0"/>
+          <a:chOff x="0" y="0"/>
+          <a:chExt cx="0" cy="0"/>
+        </a:xfrm>
+      </p:grpSpPr>
+      <p:sp>
+        <p:nvSpPr>
+          <p:cNvPr id="2" name="Slide Image Placeholder 1"/>
+          <p:cNvSpPr>
+            <a:spLocks noGrp="1"/>
+          </p:cNvSpPr>
+          <p:nvPr>
+            <p:ph type="sldImg" idx="2"/>
+          </p:nvPr>
+        </p:nvSpPr>
+        <p:spPr/>
+      </p:sp>
+      <p:sp>
+        <p:nvSpPr>
+          <p:cNvPr id="3" name="Notes Placeholder 2"/>
+          <p:cNvSpPr>
+            <a:spLocks noGrp="1"/>
+          </p:cNvSpPr>
+          <p:nvPr>
+            <p:ph type="body" idx="3" sz="quarter"/>
+          </p:nvPr>
+        </p:nvSpPr>
+        <p:spPr/>
+        <p:txBody>
+          <a:bodyPr/>
+          <a:lstStyle/>
+          <a:p>
+            <a:r>
+              <a:t>SLIDE 3</a:t>
+            </a:r>
+          </a:p>
+          <a:p/>
+          <a:p>
+            <a:r>
+              <a:t>AI nu a aparut odata cu aplicatiile pe care le folosim astazi. In 1950, Claude Shannon construia un soricel electromecanic care invata traseul printr-un labirint. La inceput explora. Apoi sistemul putea folosi drumul retinut.</a:t>
+            </a:r>
+          </a:p>
+          <a:p>
+            <a:r>
+              <a:t>Fotografia din stanga arata cum aratau unele calculatoare timpurii. Nu este masina care controla soricelul.</a:t>
+            </a:r>
+          </a:p>
+          <a:p>
+            <a:r>
+              <a:t>In 1966, ELIZA putea parea un partener de conversatie folosind reguli si tipare. Parea ca intelege, desi mecanismul era foarte diferit de cel al asistentilor de azi.</a:t>
+            </a:r>
+          </a:p>
+          <a:p>
+            <a:r>
+              <a:t>Intre aceste experimente si ChatGPT au trecut decenii de cercetare. Lansarea publica din 2022 a adus o schimbare vizibila: mult mai multi oameni au putut incerca direct o conversatie cu AI.</a:t>
+            </a:r>
+          </a:p>
+          <a:p/>
+          <a:p>
+            <a:r>
+              <a:t>SURSE</a:t>
+            </a:r>
+          </a:p>
+          <a:p>
+            <a:r>
+              <a:t>https://www.technologyreview.com/2018/12/19/138508/mighty-mouse/</a:t>
+            </a:r>
+          </a:p>
+          <a:p>
+            <a:r>
+              <a:t>https://www-formal.stanford.edu/jmc/history/dartmouth/dartmouth.html</a:t>
+            </a:r>
+          </a:p>
+          <a:p>
+            <a:r>
+              <a:t>https://www.csail.mit.edu/news/eliza-wins-peabody-award</a:t>
+            </a:r>
+          </a:p>
+          <a:p>
+            <a:r>
+              <a:t>https://openai.com/index/chatgpt/</a:t>
+            </a:r>
+          </a:p>
+          <a:p>
+            <a:r>
+              <a:t>https://commons.wikimedia.org/wiki/File:Eniac.jpg | U.S. Army; public domain (PD-USGov-Military-Army); cca 1947-1955.</a:t>
+            </a:r>
+          </a:p>
+        </p:txBody>
+      </p:sp>
+      <p:sp>
+        <p:nvSpPr>
+          <p:cNvPr id="4" name="Slide Number Placeholder 3"/>
+          <p:cNvSpPr>
+            <a:spLocks noGrp="1"/>
+          </p:cNvSpPr>
+          <p:nvPr>
+            <p:ph type="sldNum" idx="5" sz="quarter"/>
+          </p:nvPr>
+        </p:nvSpPr>
+        <p:spPr/>
+      </p:sp>
+    </p:spTree>
+  </p:cSld>
+  <p:clrMapOvr>
+    <a:masterClrMapping/>
+  </p:clrMapOvr>
+</p:notes>
+</file>
+
+<file path=ppt/notesSlides/notesSlide4.xml><?xml version="1.0" encoding="utf-8"?>
+<p:notes xmlns:a="http://schemas.openxmlformats.org/drawingml/2006/main" xmlns:p="http://schemas.openxmlformats.org/presentationml/2006/main" xmlns:r="http://schemas.openxmlformats.org/officeDocument/2006/relationships">
+  <p:cSld>
+    <p:spTree>
+      <p:nvGrpSpPr>
+        <p:cNvPr id="1" name=""/>
+        <p:cNvGrpSpPr/>
+        <p:nvPr/>
+      </p:nvGrpSpPr>
+      <p:grpSpPr>
+        <a:xfrm>
+          <a:off x="0" y="0"/>
+          <a:ext cx="0" cy="0"/>
+          <a:chOff x="0" y="0"/>
+          <a:chExt cx="0" cy="0"/>
+        </a:xfrm>
+      </p:grpSpPr>
+      <p:sp>
+        <p:nvSpPr>
+          <p:cNvPr id="2" name="Slide Image Placeholder 1"/>
+          <p:cNvSpPr>
+            <a:spLocks noGrp="1"/>
+          </p:cNvSpPr>
+          <p:nvPr>
+            <p:ph type="sldImg" idx="2"/>
+          </p:nvPr>
+        </p:nvSpPr>
+        <p:spPr/>
+      </p:sp>
+      <p:sp>
+        <p:nvSpPr>
+          <p:cNvPr id="3" name="Notes Placeholder 2"/>
+          <p:cNvSpPr>
+            <a:spLocks noGrp="1"/>
+          </p:cNvSpPr>
+          <p:nvPr>
+            <p:ph type="body" idx="3" sz="quarter"/>
+          </p:nvPr>
+        </p:nvSpPr>
+        <p:spPr/>
+        <p:txBody>
+          <a:bodyPr/>
+          <a:lstStyle/>
+          <a:p>
+            <a:r>
+              <a:t>SLIDE 4</a:t>
+            </a:r>
+          </a:p>
+          <a:p/>
+          <a:p>
+            <a:r>
+              <a:t>La biblioteca am deschis... Ce ati pune mai departe: o carte, un laptop sau o umbrela?</a:t>
+            </a:r>
+          </a:p>
+          <a:p>
+            <a:r>
+              <a:t>Acum adaug ceva: aveam de terminat un proiect digital. Poate ca unii dintre voi ati schimba alegerea.</a:t>
+            </a:r>
+          </a:p>
+          <a:p>
+            <a:r>
+              <a:t>Nu exista un singur raspuns obligatoriu. Ce observam este ca informatia noua schimba continuarea la care ne asteptam. Acesta este un punct de plecare ca sa intelegem modelele de limbaj.</a:t>
+            </a:r>
+          </a:p>
+          <a:p>
+            <a:r>
+              <a:t>Voturile noastre nu sunt probabilitatile unui model. Modelul a invatat tipare din multe exemple si le foloseste impreuna cu contextul. Iar o continuare plauzibila poate fi totusi falsa.</a:t>
+            </a:r>
+          </a:p>
+          <a:p/>
+          <a:p>
+            <a:r>
+              <a:t>SURSE</a:t>
+            </a:r>
+          </a:p>
+          <a:p>
+            <a:r>
+              <a:t>https://www.3blue1brown.com/lessons/mini-llm/</a:t>
+            </a:r>
+          </a:p>
+        </p:txBody>
+      </p:sp>
+      <p:sp>
+        <p:nvSpPr>
+          <p:cNvPr id="4" name="Slide Number Placeholder 3"/>
+          <p:cNvSpPr>
+            <a:spLocks noGrp="1"/>
+          </p:cNvSpPr>
+          <p:nvPr>
+            <p:ph type="sldNum" idx="5" sz="quarter"/>
+          </p:nvPr>
+        </p:nvSpPr>
+        <p:spPr/>
+      </p:sp>
+    </p:spTree>
+  </p:cSld>
+  <p:clrMapOvr>
+    <a:masterClrMapping/>
+  </p:clrMapOvr>
+</p:notes>
+</file>
+
+<file path=ppt/notesSlides/notesSlide5.xml><?xml version="1.0" encoding="utf-8"?>
+<p:notes xmlns:a="http://schemas.openxmlformats.org/drawingml/2006/main" xmlns:p="http://schemas.openxmlformats.org/presentationml/2006/main" xmlns:r="http://schemas.openxmlformats.org/officeDocument/2006/relationships">
+  <p:cSld>
+    <p:spTree>
+      <p:nvGrpSpPr>
+        <p:cNvPr id="1" name=""/>
+        <p:cNvGrpSpPr/>
+        <p:nvPr/>
+      </p:nvGrpSpPr>
+      <p:grpSpPr>
+        <a:xfrm>
+          <a:off x="0" y="0"/>
+          <a:ext cx="0" cy="0"/>
+          <a:chOff x="0" y="0"/>
+          <a:chExt cx="0" cy="0"/>
+        </a:xfrm>
+      </p:grpSpPr>
+      <p:sp>
+        <p:nvSpPr>
+          <p:cNvPr id="2" name="Slide Image Placeholder 1"/>
+          <p:cNvSpPr>
+            <a:spLocks noGrp="1"/>
+          </p:cNvSpPr>
+          <p:nvPr>
+            <p:ph type="sldImg" idx="2"/>
+          </p:nvPr>
+        </p:nvSpPr>
+        <p:spPr/>
+      </p:sp>
+      <p:sp>
+        <p:nvSpPr>
+          <p:cNvPr id="3" name="Notes Placeholder 2"/>
+          <p:cNvSpPr>
+            <a:spLocks noGrp="1"/>
+          </p:cNvSpPr>
+          <p:nvPr>
+            <p:ph type="body" idx="3" sz="quarter"/>
+          </p:nvPr>
+        </p:nvSpPr>
+        <p:spPr/>
+        <p:txBody>
+          <a:bodyPr/>
+          <a:lstStyle/>
+          <a:p>
+            <a:r>
+              <a:t>SLIDE 5</a:t>
+            </a:r>
+          </a:p>
+          <a:p/>
+          <a:p>
+            <a:r>
+              <a:t>Un LLM genereaza textul pas cu pas. Priveste contextul, atribuie probabilitati unor continuari si selecteaza un token, adica un fragment de text. Uneori este un cuvant, alteori doar o parte. Fragmentul se adauga si procesul continua.</a:t>
+            </a:r>
+          </a:p>
+          <a:p>
+            <a:r>
+              <a:t>De ce poate face mai mult decat completarea unei propozitii? In antrenare, modelul isi ajusteaza predictiile pe foarte multe exemple. Metodele si calculul au progresat. Alte etape de antrenare il ajuta sa urmeze cerinte si sa raspunda mai util.</a:t>
+            </a:r>
+          </a:p>
+          <a:p>
+            <a:r>
+              <a:t>Un asistent poate folosi si instrumente: cautare, analiza de imagini sau executare de cod. Astfel, de la o idee putem ajunge la o pagina pe care o deschidem si o incercam.</a:t>
+            </a:r>
+          </a:p>
+          <a:p>
+            <a:r>
+              <a:t>Dar faptul ca o poate genera nu inseamna ca a si verificat tot ce a scris.</a:t>
+            </a:r>
+          </a:p>
+          <a:p/>
+          <a:p>
+            <a:r>
+              <a:t>SURSE</a:t>
+            </a:r>
+          </a:p>
+          <a:p>
+            <a:r>
+              <a:t>https://www.3blue1brown.com/lessons/mini-llm/</a:t>
+            </a:r>
+          </a:p>
+        </p:txBody>
+      </p:sp>
+      <p:sp>
+        <p:nvSpPr>
+          <p:cNvPr id="4" name="Slide Number Placeholder 3"/>
+          <p:cNvSpPr>
+            <a:spLocks noGrp="1"/>
+          </p:cNvSpPr>
+          <p:nvPr>
+            <p:ph type="sldNum" idx="5" sz="quarter"/>
+          </p:nvPr>
+        </p:nvSpPr>
+        <p:spPr/>
+      </p:sp>
+    </p:spTree>
+  </p:cSld>
+  <p:clrMapOvr>
+    <a:masterClrMapping/>
+  </p:clrMapOvr>
+</p:notes>
+</file>
+
+<file path=ppt/notesSlides/notesSlide6.xml><?xml version="1.0" encoding="utf-8"?>
+<p:notes xmlns:a="http://schemas.openxmlformats.org/drawingml/2006/main" xmlns:p="http://schemas.openxmlformats.org/presentationml/2006/main" xmlns:r="http://schemas.openxmlformats.org/officeDocument/2006/relationships">
+  <p:cSld>
+    <p:spTree>
+      <p:nvGrpSpPr>
+        <p:cNvPr id="1" name=""/>
+        <p:cNvGrpSpPr/>
+        <p:nvPr/>
+      </p:nvGrpSpPr>
+      <p:grpSpPr>
+        <a:xfrm>
+          <a:off x="0" y="0"/>
+          <a:ext cx="0" cy="0"/>
+          <a:chOff x="0" y="0"/>
+          <a:chExt cx="0" cy="0"/>
+        </a:xfrm>
+      </p:grpSpPr>
+      <p:sp>
+        <p:nvSpPr>
+          <p:cNvPr id="2" name="Slide Image Placeholder 1"/>
+          <p:cNvSpPr>
+            <a:spLocks noGrp="1"/>
+          </p:cNvSpPr>
+          <p:nvPr>
+            <p:ph type="sldImg" idx="2"/>
+          </p:nvPr>
+        </p:nvSpPr>
+        <p:spPr/>
+      </p:sp>
+      <p:sp>
+        <p:nvSpPr>
+          <p:cNvPr id="3" name="Notes Placeholder 2"/>
+          <p:cNvSpPr>
+            <a:spLocks noGrp="1"/>
+          </p:cNvSpPr>
+          <p:nvPr>
+            <p:ph type="body" idx="3" sz="quarter"/>
+          </p:nvPr>
+        </p:nvSpPr>
+        <p:spPr/>
+        <p:txBody>
+          <a:bodyPr/>
+          <a:lstStyle/>
+          <a:p>
+            <a:r>
+              <a:t>SLIDE 6</a:t>
+            </a:r>
+          </a:p>
+          <a:p/>
+          <a:p>
+            <a:r>
+              <a:t>Sa luam o idee simpla: vrem o pagina pentru un eveniment la liceu. Nu trebuie sa stim deja cum se scrie fiecare linie de cod ca sa putem descrie ce vrem.</a:t>
+            </a:r>
+          </a:p>
+          <a:p>
+            <a:r>
+              <a:t>Priviti pagina: ce ati cauta daca ati fi invitati? Data, ora, locul, activitatile, costul. Exact aceste lucruri vor deveni criteriile noastre.</a:t>
+            </a:r>
+          </a:p>
+          <a:p>
+            <a:r>
+              <a:t>Aceasta captura este un exemplu pregatit pentru sesiune. In Copilot vom vedea ce putem obtine pornind de la o cerere si cum se schimba rezultatul cand o clarificam.</a:t>
+            </a:r>
+          </a:p>
+          <a:p/>
+          <a:p>
+            <a:r>
+              <a:t>SURSE</a:t>
+            </a:r>
+          </a:p>
+          <a:p>
+            <a:r>
+              <a:t>Poveste oferita de Dragos sau exemplu educational original.</a:t>
+            </a:r>
+          </a:p>
+        </p:txBody>
+      </p:sp>
+      <p:sp>
+        <p:nvSpPr>
+          <p:cNvPr id="4" name="Slide Number Placeholder 3"/>
+          <p:cNvSpPr>
+            <a:spLocks noGrp="1"/>
+          </p:cNvSpPr>
+          <p:nvPr>
+            <p:ph type="sldNum" idx="5" sz="quarter"/>
+          </p:nvPr>
+        </p:nvSpPr>
+        <p:spPr/>
+      </p:sp>
+    </p:spTree>
+  </p:cSld>
+  <p:clrMapOvr>
+    <a:masterClrMapping/>
+  </p:clrMapOvr>
+</p:notes>
+</file>
+
+<file path=ppt/notesSlides/notesSlide7.xml><?xml version="1.0" encoding="utf-8"?>
+<p:notes xmlns:a="http://schemas.openxmlformats.org/drawingml/2006/main" xmlns:p="http://schemas.openxmlformats.org/presentationml/2006/main" xmlns:r="http://schemas.openxmlformats.org/officeDocument/2006/relationships">
+  <p:cSld>
+    <p:spTree>
+      <p:nvGrpSpPr>
+        <p:cNvPr id="1" name=""/>
+        <p:cNvGrpSpPr/>
+        <p:nvPr/>
+      </p:nvGrpSpPr>
+      <p:grpSpPr>
+        <a:xfrm>
+          <a:off x="0" y="0"/>
+          <a:ext cx="0" cy="0"/>
+          <a:chOff x="0" y="0"/>
+          <a:chExt cx="0" cy="0"/>
+        </a:xfrm>
+      </p:grpSpPr>
+      <p:sp>
+        <p:nvSpPr>
+          <p:cNvPr id="2" name="Slide Image Placeholder 1"/>
+          <p:cNvSpPr>
+            <a:spLocks noGrp="1"/>
+          </p:cNvSpPr>
+          <p:nvPr>
+            <p:ph type="sldImg" idx="2"/>
+          </p:nvPr>
+        </p:nvSpPr>
+        <p:spPr/>
+      </p:sp>
+      <p:sp>
+        <p:nvSpPr>
+          <p:cNvPr id="3" name="Notes Placeholder 2"/>
+          <p:cNvSpPr>
+            <a:spLocks noGrp="1"/>
+          </p:cNvSpPr>
+          <p:nvPr>
+            <p:ph type="body" idx="3" sz="quarter"/>
+          </p:nvPr>
+        </p:nvSpPr>
+        <p:spPr/>
+        <p:txBody>
+          <a:bodyPr/>
+          <a:lstStyle/>
+          <a:p>
+            <a:r>
+              <a:t>SLIDE 7</a:t>
+            </a:r>
+          </a:p>
+          <a:p/>
+          <a:p>
+            <a:r>
+              <a:t>O sa incep intentionat cu o cerere scurta: fa o pagina pentru un eveniment la liceu.</a:t>
+            </a:r>
+          </a:p>
+          <a:p>
+            <a:r>
+              <a:t>Sa vedem ce intelege din ea. Daca imi cere detalii, foarte bine: a observat ca ii lipsesc informatii. Daca produce direct o pagina, ne uitam la presupunerile pe care le-a facut.</a:t>
+            </a:r>
+          </a:p>
+          <a:p>
+            <a:r>
+              <a:t>Nu cautam sa obtinem ceva perfect din prima. Vrem sa vedem unde trebuie sa intervenim noi. O pagina poate arata bine si totusi sa nu spuna cand are loc evenimentul.</a:t>
+            </a:r>
+          </a:p>
+          <a:p/>
+          <a:p>
+            <a:r>
+              <a:t>SURSE</a:t>
+            </a:r>
+          </a:p>
+          <a:p>
+            <a:r>
+              <a:t>Poveste oferita de Dragos sau exemplu educational original.</a:t>
+            </a:r>
+          </a:p>
+        </p:txBody>
+      </p:sp>
+      <p:sp>
+        <p:nvSpPr>
+          <p:cNvPr id="4" name="Slide Number Placeholder 3"/>
+          <p:cNvSpPr>
+            <a:spLocks noGrp="1"/>
+          </p:cNvSpPr>
+          <p:nvPr>
+            <p:ph type="sldNum" idx="5" sz="quarter"/>
+          </p:nvPr>
+        </p:nvSpPr>
+        <p:spPr/>
+      </p:sp>
+    </p:spTree>
+  </p:cSld>
+  <p:clrMapOvr>
+    <a:masterClrMapping/>
+  </p:clrMapOvr>
+</p:notes>
+</file>
+
+<file path=ppt/notesSlides/notesSlide8.xml><?xml version="1.0" encoding="utf-8"?>
+<p:notes xmlns:a="http://schemas.openxmlformats.org/drawingml/2006/main" xmlns:p="http://schemas.openxmlformats.org/presentationml/2006/main" xmlns:r="http://schemas.openxmlformats.org/officeDocument/2006/relationships">
+  <p:cSld>
+    <p:spTree>
+      <p:nvGrpSpPr>
+        <p:cNvPr id="1" name=""/>
+        <p:cNvGrpSpPr/>
+        <p:nvPr/>
+      </p:nvGrpSpPr>
+      <p:grpSpPr>
+        <a:xfrm>
+          <a:off x="0" y="0"/>
+          <a:ext cx="0" cy="0"/>
+          <a:chOff x="0" y="0"/>
+          <a:chExt cx="0" cy="0"/>
+        </a:xfrm>
+      </p:grpSpPr>
+      <p:sp>
+        <p:nvSpPr>
+          <p:cNvPr id="2" name="Slide Image Placeholder 1"/>
+          <p:cNvSpPr>
+            <a:spLocks noGrp="1"/>
+          </p:cNvSpPr>
+          <p:nvPr>
+            <p:ph type="sldImg" idx="2"/>
+          </p:nvPr>
+        </p:nvSpPr>
+        <p:spPr/>
+      </p:sp>
+      <p:sp>
+        <p:nvSpPr>
+          <p:cNvPr id="3" name="Notes Placeholder 2"/>
+          <p:cNvSpPr>
+            <a:spLocks noGrp="1"/>
+          </p:cNvSpPr>
+          <p:nvPr>
+            <p:ph type="body" idx="3" sz="quarter"/>
+          </p:nvPr>
+        </p:nvSpPr>
+        <p:spPr/>
+        <p:txBody>
+          <a:bodyPr/>
+          <a:lstStyle/>
+          <a:p>
+            <a:r>
+              <a:t>SLIDE 8</a:t>
+            </a:r>
+          </a:p>
+          <a:p/>
+          <a:p>
+            <a:r>
+              <a:t>Ce voiam, de fapt? O pagina care sa ajute un elev sa inteleaga daca vrea sa vina. Acum avem un scop si detalii.</a:t>
+            </a:r>
+          </a:p>
+          <a:p>
+            <a:r>
+              <a:t>Adaugam numele, data, ora, locul, accesul gratuit si faptul ca trebuie sa mearga pe telefon. Cand schimbam cererea, avem si criterii dupa care putem judeca pagina.</a:t>
+            </a:r>
+          </a:p>
+          <a:p>
+            <a:r>
+              <a:t>Puteti scrie in chat un lucru pe care l-ati mai clarifica. Eu am pregatit deja cateva, asa ca putem continua si fara raspunsuri.</a:t>
+            </a:r>
+          </a:p>
+          <a:p>
+            <a:r>
+              <a:t>Gandirea critica incepe chiar din felul in care intrebam. 'De ce AI ii face pe elevi lenesi?' presupune deja concluzia. 'Cand poate AI ajuta sau impiedica invatarea?' ne lasa sa exploram mai multe explicatii.</a:t>
+            </a:r>
+          </a:p>
+          <a:p>
+            <a:r>
+              <a:t>O cerere mai buna poate aduce un rezultat mai util. Nu garanteaza ca fiecare informatie este adevarata.</a:t>
+            </a:r>
+          </a:p>
+          <a:p/>
+          <a:p>
+            <a:r>
+              <a:t>SURSE</a:t>
+            </a:r>
+          </a:p>
+          <a:p>
+            <a:r>
+              <a:t>https://uit.stanford.edu/service/techtraining/ai-demystified/prompt-engineering</a:t>
+            </a:r>
+          </a:p>
+        </p:txBody>
+      </p:sp>
+      <p:sp>
+        <p:nvSpPr>
+          <p:cNvPr id="4" name="Slide Number Placeholder 3"/>
+          <p:cNvSpPr>
+            <a:spLocks noGrp="1"/>
+          </p:cNvSpPr>
+          <p:nvPr>
+            <p:ph type="sldNum" idx="5" sz="quarter"/>
+          </p:nvPr>
+        </p:nvSpPr>
+        <p:spPr/>
+      </p:sp>
+    </p:spTree>
+  </p:cSld>
+  <p:clrMapOvr>
+    <a:masterClrMapping/>
+  </p:clrMapOvr>
+</p:notes>
+</file>
+
+<file path=ppt/notesSlides/notesSlide9.xml><?xml version="1.0" encoding="utf-8"?>
+<p:notes xmlns:a="http://schemas.openxmlformats.org/drawingml/2006/main" xmlns:p="http://schemas.openxmlformats.org/presentationml/2006/main" xmlns:r="http://schemas.openxmlformats.org/officeDocument/2006/relationships">
+  <p:cSld>
+    <p:spTree>
+      <p:nvGrpSpPr>
+        <p:cNvPr id="1" name=""/>
+        <p:cNvGrpSpPr/>
+        <p:nvPr/>
+      </p:nvGrpSpPr>
+      <p:grpSpPr>
+        <a:xfrm>
+          <a:off x="0" y="0"/>
+          <a:ext cx="0" cy="0"/>
+          <a:chOff x="0" y="0"/>
+          <a:chExt cx="0" cy="0"/>
+        </a:xfrm>
+      </p:grpSpPr>
+      <p:sp>
+        <p:nvSpPr>
+          <p:cNvPr id="2" name="Slide Image Placeholder 1"/>
+          <p:cNvSpPr>
+            <a:spLocks noGrp="1"/>
+          </p:cNvSpPr>
+          <p:nvPr>
+            <p:ph type="sldImg" idx="2"/>
+          </p:nvPr>
+        </p:nvSpPr>
+        <p:spPr/>
+      </p:sp>
+      <p:sp>
+        <p:nvSpPr>
+          <p:cNvPr id="3" name="Notes Placeholder 2"/>
+          <p:cNvSpPr>
+            <a:spLocks noGrp="1"/>
+          </p:cNvSpPr>
+          <p:nvPr>
+            <p:ph type="body" idx="3" sz="quarter"/>
+          </p:nvPr>
+        </p:nvSpPr>
+        <p:spPr/>
+        <p:txBody>
+          <a:bodyPr/>
+          <a:lstStyle/>
+          <a:p>
+            <a:r>
+              <a:t>SLIDE 9</a:t>
+            </a:r>
+          </a:p>
+          <a:p/>
+          <a:p>
+            <a:r>
+              <a:t>Acum verificam trei lucruri diferite. Mai intai: respecta ce am cerut? Comparam data si ora cu cererea noastra, nu cu memoria modelului.</a:t>
+            </a:r>
+          </a:p>
+          <a:p>
+            <a:r>
+              <a:t>Apoi: functioneaza? Apasam pe buton si deschidem pagina la latimea unui telefon. Programul incepe la 17 si se termina la 19? Cele trei intervale de 40 de minute dau doua ore?</a:t>
+            </a:r>
+          </a:p>
+          <a:p>
+            <a:r>
+              <a:t>In sfarsit: putem trata informatia drept adevarata? Aici evenimentul este fictiv. Pentru unul real, faptul ca AI a pus o data pe pagina nu o confirma. O verificam cu organizatorul sau cu anuntul oficial.</a:t>
+            </a:r>
+          </a:p>
+          <a:p>
+            <a:r>
+              <a:t>Un raspuns poate suna sigur sau poate fi foarte frumos si totusi sa contina o informatie gresita. Tocmai de aceea trebuie sa alegem verificarea potrivita.</a:t>
+            </a:r>
+          </a:p>
+          <a:p/>
+          <a:p>
+            <a:r>
+              <a:t>SURSE</a:t>
+            </a:r>
+          </a:p>
+          <a:p>
+            <a:r>
+              <a:t>https://dayofai.org/units/truth-tricks-and-ai-learning-to-verify-information</a:t>
+            </a:r>
+          </a:p>
+        </p:txBody>
+      </p:sp>
+      <p:sp>
+        <p:nvSpPr>
+          <p:cNvPr id="4" name="Slide Number Placeholder 3"/>
+          <p:cNvSpPr>
+            <a:spLocks noGrp="1"/>
+          </p:cNvSpPr>
+          <p:nvPr>
+            <p:ph type="sldNum" idx="5" sz="quarter"/>
+          </p:nvPr>
+        </p:nvSpPr>
+        <p:spPr/>
+      </p:sp>
+    </p:spTree>
+  </p:cSld>
+  <p:clrMapOvr>
+    <a:masterClrMapping/>
+  </p:clrMapOvr>
+</p:notes>
 </file>
 
 <file path=ppt/slideLayouts/slideLayout1.xml><?xml version="1.0" encoding="utf-8"?>

</xml_diff>

<commit_message>
Add explanatory visual loops, Theseus maze and focused evidence
Retain all fourteen slides and narration; enlarge event details and improve verification paths.

Co-authored-by: Copilot App <223556219+Copilot@users.noreply.github.com>

Copilot-Session: 1eb2797f-3b87-49f8-85d2-d57d82049b02
</commit_message>
<xml_diff>
--- a/downloads/cartea-daliei-ai.pptx
+++ b/downloads/cartea-daliei-ai.pptx
@@ -1265,7 +1265,7 @@
           </a:p>
           <a:p>
             <a:r>
-              <a:t>Fotografia din stanga arata cum aratau unele calculatoare timpurii. Nu este masina care controla soricelul.</a:t>
+              <a:t>In schema din stanga, traseul albastru reprezinta drumul retinut. Este o ilustratie a ideii, nu planul aparatului original.</a:t>
             </a:r>
           </a:p>
           <a:p>
@@ -1302,11 +1302,6 @@
           <a:p>
             <a:r>
               <a:t>https://openai.com/index/chatgpt/</a:t>
-            </a:r>
-          </a:p>
-          <a:p>
-            <a:r>
-              <a:t>https://commons.wikimedia.org/wiki/File:Eniac.jpg | U.S. Army; public domain (PD-USGov-Military-Army); cca 1947-1955.</a:t>
             </a:r>
           </a:p>
         </p:txBody>
@@ -5447,8 +5442,8 @@
         </p:nvSpPr>
         <p:spPr>
           <a:xfrm>
-            <a:off x="6309360" y="1965960"/>
-            <a:ext cx="4846320" cy="1371600"/>
+            <a:off x="6217920" y="2240280"/>
+            <a:ext cx="2286000" cy="987552"/>
           </a:xfrm>
           <a:prstGeom prst="rect">
             <a:avLst/>
@@ -5467,29 +5462,13 @@
               </a:spcAft>
             </a:pPr>
             <a:r>
-              <a:rPr sz="3100" b="1">
+              <a:rPr sz="2800" b="1">
                 <a:solidFill>
                   <a:srgbClr val="FFFFFF"/>
                 </a:solidFill>
                 <a:latin typeface="Aptos"/>
               </a:rPr>
               <a:t>Scriam.</a:t>
-            </a:r>
-          </a:p>
-          <a:p>
-            <a:pPr>
-              <a:spcAft>
-                <a:spcPts val="800"/>
-              </a:spcAft>
-            </a:pPr>
-            <a:r>
-              <a:rPr sz="3100" b="1">
-                <a:solidFill>
-                  <a:srgbClr val="FFFFFF"/>
-                </a:solidFill>
-                <a:latin typeface="Aptos"/>
-              </a:rPr>
-              <a:t>Un prieten incerca.</a:t>
             </a:r>
           </a:p>
         </p:txBody>
@@ -5502,8 +5481,8 @@
         </p:nvSpPr>
         <p:spPr>
           <a:xfrm>
-            <a:off x="6309360" y="3703320"/>
-            <a:ext cx="4846320" cy="1188720"/>
+            <a:off x="8869680" y="2240280"/>
+            <a:ext cx="2286000" cy="987552"/>
           </a:xfrm>
           <a:prstGeom prst="rect">
             <a:avLst/>
@@ -5522,29 +5501,29 @@
               </a:spcAft>
             </a:pPr>
             <a:r>
-              <a:rPr sz="3100" b="1">
-                <a:solidFill>
-                  <a:srgbClr val="D6EC79"/>
-                </a:solidFill>
-                <a:latin typeface="Aptos"/>
-              </a:rPr>
-              <a:t>A doua zi aflam</a:t>
-            </a:r>
-          </a:p>
-          <a:p>
-            <a:pPr>
-              <a:spcAft>
-                <a:spcPts val="800"/>
-              </a:spcAft>
-            </a:pPr>
-            <a:r>
-              <a:rPr sz="3100" b="1">
-                <a:solidFill>
-                  <a:srgbClr val="D6EC79"/>
-                </a:solidFill>
-                <a:latin typeface="Aptos"/>
-              </a:rPr>
-              <a:t>ce nu mersese.</a:t>
+              <a:rPr sz="2800" b="1">
+                <a:solidFill>
+                  <a:srgbClr val="FFFFFF"/>
+                </a:solidFill>
+                <a:latin typeface="Aptos"/>
+              </a:rPr>
+              <a:t>Prietenul</a:t>
+            </a:r>
+          </a:p>
+          <a:p>
+            <a:pPr>
+              <a:spcAft>
+                <a:spcPts val="800"/>
+              </a:spcAft>
+            </a:pPr>
+            <a:r>
+              <a:rPr sz="2800" b="1">
+                <a:solidFill>
+                  <a:srgbClr val="FFFFFF"/>
+                </a:solidFill>
+                <a:latin typeface="Aptos"/>
+              </a:rPr>
+              <a:t>incerca.</a:t>
             </a:r>
           </a:p>
         </p:txBody>
@@ -5557,8 +5536,8 @@
         </p:nvSpPr>
         <p:spPr>
           <a:xfrm>
-            <a:off x="685800" y="5705856"/>
-            <a:ext cx="10881360" cy="402336"/>
+            <a:off x="8869680" y="4453128"/>
+            <a:ext cx="2286000" cy="987552"/>
           </a:xfrm>
           <a:prstGeom prst="rect">
             <a:avLst/>
@@ -5577,13 +5556,451 @@
               </a:spcAft>
             </a:pPr>
             <a:r>
-              <a:rPr sz="2500" b="1">
+              <a:rPr sz="2800" b="1">
+                <a:solidFill>
+                  <a:srgbClr val="D6EC79"/>
+                </a:solidFill>
+                <a:latin typeface="Aptos"/>
+              </a:rPr>
+              <a:t>Notite</a:t>
+            </a:r>
+          </a:p>
+          <a:p>
+            <a:pPr>
+              <a:spcAft>
+                <a:spcPts val="800"/>
+              </a:spcAft>
+            </a:pPr>
+            <a:r>
+              <a:rPr sz="2800" b="1">
+                <a:solidFill>
+                  <a:srgbClr val="D6EC79"/>
+                </a:solidFill>
+                <a:latin typeface="Aptos"/>
+              </a:rPr>
+              <a:t>a doua zi.</a:t>
+            </a:r>
+          </a:p>
+        </p:txBody>
+      </p:sp>
+      <p:sp>
+        <p:nvSpPr>
+          <p:cNvPr id="17" name="TextBox 16"/>
+          <p:cNvSpPr txBox="1"/>
+          <p:nvPr/>
+        </p:nvSpPr>
+        <p:spPr>
+          <a:xfrm>
+            <a:off x="6217920" y="4453128"/>
+            <a:ext cx="2286000" cy="987552"/>
+          </a:xfrm>
+          <a:prstGeom prst="rect">
+            <a:avLst/>
+          </a:prstGeom>
+          <a:noFill/>
+        </p:spPr>
+        <p:txBody>
+          <a:bodyPr wrap="square" lIns="22860" rIns="22860" tIns="22860" bIns="22860">
+            <a:spAutoFit/>
+          </a:bodyPr>
+          <a:lstStyle/>
+          <a:p>
+            <a:pPr>
+              <a:spcAft>
+                <a:spcPts val="800"/>
+              </a:spcAft>
+            </a:pPr>
+            <a:r>
+              <a:rPr sz="2800" b="1">
+                <a:solidFill>
+                  <a:srgbClr val="D6EC79"/>
+                </a:solidFill>
+                <a:latin typeface="Aptos"/>
+              </a:rPr>
+              <a:t>Corectam.</a:t>
+            </a:r>
+          </a:p>
+        </p:txBody>
+      </p:sp>
+      <p:sp>
+        <p:nvSpPr>
+          <p:cNvPr id="18" name="Rectangle 17"/>
+          <p:cNvSpPr/>
+          <p:nvPr/>
+        </p:nvSpPr>
+        <p:spPr>
+          <a:xfrm>
+            <a:off x="7909560" y="2589530"/>
+            <a:ext cx="740664" cy="33020"/>
+          </a:xfrm>
+          <a:prstGeom prst="rect">
+            <a:avLst/>
+          </a:prstGeom>
+          <a:solidFill>
+            <a:srgbClr val="D6EC79"/>
+          </a:solidFill>
+          <a:ln>
+            <a:noFill/>
+          </a:ln>
+        </p:spPr>
+        <p:style>
+          <a:lnRef idx="1">
+            <a:schemeClr val="accent1"/>
+          </a:lnRef>
+          <a:fillRef idx="3">
+            <a:schemeClr val="accent1"/>
+          </a:fillRef>
+          <a:effectRef idx="2">
+            <a:schemeClr val="accent1"/>
+          </a:effectRef>
+          <a:fontRef idx="minor">
+            <a:schemeClr val="lt1"/>
+          </a:fontRef>
+        </p:style>
+        <p:txBody>
+          <a:bodyPr rtlCol="0" anchor="ctr"/>
+          <a:lstStyle/>
+          <a:p>
+            <a:pPr algn="ctr"/>
+          </a:p>
+        </p:txBody>
+      </p:sp>
+      <p:sp>
+        <p:nvSpPr>
+          <p:cNvPr id="19" name="Isosceles Triangle 18"/>
+          <p:cNvSpPr/>
+          <p:nvPr/>
+        </p:nvSpPr>
+        <p:spPr>
+          <a:xfrm rot="5400000">
+            <a:off x="8567928" y="2523744"/>
+            <a:ext cx="164592" cy="164592"/>
+          </a:xfrm>
+          <a:prstGeom prst="triangle">
+            <a:avLst/>
+          </a:prstGeom>
+          <a:solidFill>
+            <a:srgbClr val="D6EC79"/>
+          </a:solidFill>
+          <a:ln>
+            <a:noFill/>
+          </a:ln>
+        </p:spPr>
+        <p:style>
+          <a:lnRef idx="1">
+            <a:schemeClr val="accent1"/>
+          </a:lnRef>
+          <a:fillRef idx="3">
+            <a:schemeClr val="accent1"/>
+          </a:fillRef>
+          <a:effectRef idx="2">
+            <a:schemeClr val="accent1"/>
+          </a:effectRef>
+          <a:fontRef idx="minor">
+            <a:schemeClr val="lt1"/>
+          </a:fontRef>
+        </p:style>
+        <p:txBody>
+          <a:bodyPr rtlCol="0" anchor="ctr"/>
+          <a:lstStyle/>
+          <a:p>
+            <a:pPr algn="ctr"/>
+          </a:p>
+        </p:txBody>
+      </p:sp>
+      <p:sp>
+        <p:nvSpPr>
+          <p:cNvPr id="20" name="Rectangle 19"/>
+          <p:cNvSpPr/>
+          <p:nvPr/>
+        </p:nvSpPr>
+        <p:spPr>
+          <a:xfrm>
+            <a:off x="9813290" y="3337560"/>
+            <a:ext cx="33020" cy="841248"/>
+          </a:xfrm>
+          <a:prstGeom prst="rect">
+            <a:avLst/>
+          </a:prstGeom>
+          <a:solidFill>
+            <a:srgbClr val="D6EC79"/>
+          </a:solidFill>
+          <a:ln>
+            <a:noFill/>
+          </a:ln>
+        </p:spPr>
+        <p:style>
+          <a:lnRef idx="1">
+            <a:schemeClr val="accent1"/>
+          </a:lnRef>
+          <a:fillRef idx="3">
+            <a:schemeClr val="accent1"/>
+          </a:fillRef>
+          <a:effectRef idx="2">
+            <a:schemeClr val="accent1"/>
+          </a:effectRef>
+          <a:fontRef idx="minor">
+            <a:schemeClr val="lt1"/>
+          </a:fontRef>
+        </p:style>
+        <p:txBody>
+          <a:bodyPr rtlCol="0" anchor="ctr"/>
+          <a:lstStyle/>
+          <a:p>
+            <a:pPr algn="ctr"/>
+          </a:p>
+        </p:txBody>
+      </p:sp>
+      <p:sp>
+        <p:nvSpPr>
+          <p:cNvPr id="21" name="Isosceles Triangle 20"/>
+          <p:cNvSpPr/>
+          <p:nvPr/>
+        </p:nvSpPr>
+        <p:spPr>
+          <a:xfrm rot="10800000">
+            <a:off x="9747504" y="4096512"/>
+            <a:ext cx="164592" cy="164592"/>
+          </a:xfrm>
+          <a:prstGeom prst="triangle">
+            <a:avLst/>
+          </a:prstGeom>
+          <a:solidFill>
+            <a:srgbClr val="D6EC79"/>
+          </a:solidFill>
+          <a:ln>
+            <a:noFill/>
+          </a:ln>
+        </p:spPr>
+        <p:style>
+          <a:lnRef idx="1">
+            <a:schemeClr val="accent1"/>
+          </a:lnRef>
+          <a:fillRef idx="3">
+            <a:schemeClr val="accent1"/>
+          </a:fillRef>
+          <a:effectRef idx="2">
+            <a:schemeClr val="accent1"/>
+          </a:effectRef>
+          <a:fontRef idx="minor">
+            <a:schemeClr val="lt1"/>
+          </a:fontRef>
+        </p:style>
+        <p:txBody>
+          <a:bodyPr rtlCol="0" anchor="ctr"/>
+          <a:lstStyle/>
+          <a:p>
+            <a:pPr algn="ctr"/>
+          </a:p>
+        </p:txBody>
+      </p:sp>
+      <p:sp>
+        <p:nvSpPr>
+          <p:cNvPr id="22" name="Rectangle 21"/>
+          <p:cNvSpPr/>
+          <p:nvPr/>
+        </p:nvSpPr>
+        <p:spPr>
+          <a:xfrm>
+            <a:off x="8092440" y="4811522"/>
+            <a:ext cx="502920" cy="33020"/>
+          </a:xfrm>
+          <a:prstGeom prst="rect">
+            <a:avLst/>
+          </a:prstGeom>
+          <a:solidFill>
+            <a:srgbClr val="D6EC79"/>
+          </a:solidFill>
+          <a:ln>
+            <a:noFill/>
+          </a:ln>
+        </p:spPr>
+        <p:style>
+          <a:lnRef idx="1">
+            <a:schemeClr val="accent1"/>
+          </a:lnRef>
+          <a:fillRef idx="3">
+            <a:schemeClr val="accent1"/>
+          </a:fillRef>
+          <a:effectRef idx="2">
+            <a:schemeClr val="accent1"/>
+          </a:effectRef>
+          <a:fontRef idx="minor">
+            <a:schemeClr val="lt1"/>
+          </a:fontRef>
+        </p:style>
+        <p:txBody>
+          <a:bodyPr rtlCol="0" anchor="ctr"/>
+          <a:lstStyle/>
+          <a:p>
+            <a:pPr algn="ctr"/>
+          </a:p>
+        </p:txBody>
+      </p:sp>
+      <p:sp>
+        <p:nvSpPr>
+          <p:cNvPr id="23" name="Isosceles Triangle 22"/>
+          <p:cNvSpPr/>
+          <p:nvPr/>
+        </p:nvSpPr>
+        <p:spPr>
+          <a:xfrm rot="16200000">
+            <a:off x="8010144" y="4745736"/>
+            <a:ext cx="164592" cy="164592"/>
+          </a:xfrm>
+          <a:prstGeom prst="triangle">
+            <a:avLst/>
+          </a:prstGeom>
+          <a:solidFill>
+            <a:srgbClr val="D6EC79"/>
+          </a:solidFill>
+          <a:ln>
+            <a:noFill/>
+          </a:ln>
+        </p:spPr>
+        <p:style>
+          <a:lnRef idx="1">
+            <a:schemeClr val="accent1"/>
+          </a:lnRef>
+          <a:fillRef idx="3">
+            <a:schemeClr val="accent1"/>
+          </a:fillRef>
+          <a:effectRef idx="2">
+            <a:schemeClr val="accent1"/>
+          </a:effectRef>
+          <a:fontRef idx="minor">
+            <a:schemeClr val="lt1"/>
+          </a:fontRef>
+        </p:style>
+        <p:txBody>
+          <a:bodyPr rtlCol="0" anchor="ctr"/>
+          <a:lstStyle/>
+          <a:p>
+            <a:pPr algn="ctr"/>
+          </a:p>
+        </p:txBody>
+      </p:sp>
+      <p:sp>
+        <p:nvSpPr>
+          <p:cNvPr id="24" name="Rectangle 23"/>
+          <p:cNvSpPr/>
+          <p:nvPr/>
+        </p:nvSpPr>
+        <p:spPr>
+          <a:xfrm>
+            <a:off x="6996938" y="3328416"/>
+            <a:ext cx="33020" cy="832103"/>
+          </a:xfrm>
+          <a:prstGeom prst="rect">
+            <a:avLst/>
+          </a:prstGeom>
+          <a:solidFill>
+            <a:srgbClr val="D6EC79"/>
+          </a:solidFill>
+          <a:ln>
+            <a:noFill/>
+          </a:ln>
+        </p:spPr>
+        <p:style>
+          <a:lnRef idx="1">
+            <a:schemeClr val="accent1"/>
+          </a:lnRef>
+          <a:fillRef idx="3">
+            <a:schemeClr val="accent1"/>
+          </a:fillRef>
+          <a:effectRef idx="2">
+            <a:schemeClr val="accent1"/>
+          </a:effectRef>
+          <a:fontRef idx="minor">
+            <a:schemeClr val="lt1"/>
+          </a:fontRef>
+        </p:style>
+        <p:txBody>
+          <a:bodyPr rtlCol="0" anchor="ctr"/>
+          <a:lstStyle/>
+          <a:p>
+            <a:pPr algn="ctr"/>
+          </a:p>
+        </p:txBody>
+      </p:sp>
+      <p:sp>
+        <p:nvSpPr>
+          <p:cNvPr id="25" name="Isosceles Triangle 24"/>
+          <p:cNvSpPr/>
+          <p:nvPr/>
+        </p:nvSpPr>
+        <p:spPr>
+          <a:xfrm>
+            <a:off x="6931152" y="3246120"/>
+            <a:ext cx="164592" cy="164592"/>
+          </a:xfrm>
+          <a:prstGeom prst="triangle">
+            <a:avLst/>
+          </a:prstGeom>
+          <a:solidFill>
+            <a:srgbClr val="D6EC79"/>
+          </a:solidFill>
+          <a:ln>
+            <a:noFill/>
+          </a:ln>
+        </p:spPr>
+        <p:style>
+          <a:lnRef idx="1">
+            <a:schemeClr val="accent1"/>
+          </a:lnRef>
+          <a:fillRef idx="3">
+            <a:schemeClr val="accent1"/>
+          </a:fillRef>
+          <a:effectRef idx="2">
+            <a:schemeClr val="accent1"/>
+          </a:effectRef>
+          <a:fontRef idx="minor">
+            <a:schemeClr val="lt1"/>
+          </a:fontRef>
+        </p:style>
+        <p:txBody>
+          <a:bodyPr rtlCol="0" anchor="ctr"/>
+          <a:lstStyle/>
+          <a:p>
+            <a:pPr algn="ctr"/>
+          </a:p>
+        </p:txBody>
+      </p:sp>
+      <p:sp>
+        <p:nvSpPr>
+          <p:cNvPr id="26" name="TextBox 25"/>
+          <p:cNvSpPr txBox="1"/>
+          <p:nvPr/>
+        </p:nvSpPr>
+        <p:spPr>
+          <a:xfrm>
+            <a:off x="685800" y="5806440"/>
+            <a:ext cx="10881360" cy="356616"/>
+          </a:xfrm>
+          <a:prstGeom prst="rect">
+            <a:avLst/>
+          </a:prstGeom>
+          <a:noFill/>
+        </p:spPr>
+        <p:txBody>
+          <a:bodyPr wrap="square" lIns="22860" rIns="22860" tIns="22860" bIns="22860">
+            <a:spAutoFit/>
+          </a:bodyPr>
+          <a:lstStyle/>
+          <a:p>
+            <a:pPr>
+              <a:spcAft>
+                <a:spcPts val="800"/>
+              </a:spcAft>
+            </a:pPr>
+            <a:r>
+              <a:rPr sz="2400" b="1">
                 <a:solidFill>
                   <a:srgbClr val="FFFFFF"/>
                 </a:solidFill>
                 <a:latin typeface="Aptos"/>
               </a:rPr>
-              <a:t>O idee. O incercare. Feedback. Inca o incercare.</a:t>
+              <a:t>Un fel de remote debugging. Cu raspuns a doua zi.</a:t>
             </a:r>
           </a:p>
         </p:txBody>
@@ -9558,40 +9975,1306 @@
           </a:p>
         </p:txBody>
       </p:sp>
-      <p:pic>
-        <p:nvPicPr>
-          <p:cNvPr id="6" name="Picture 5" descr="Fotografie ENIAC, circa 1947-1955, context istoric pentru calculatoarele timpurii; nu este masina Theseus sau ELIZA."/>
-          <p:cNvPicPr>
-            <a:picLocks noChangeAspect="1"/>
-          </p:cNvPicPr>
-          <p:nvPr/>
-        </p:nvPicPr>
-        <p:blipFill>
-          <a:blip r:embed="rId2"/>
-          <a:stretch>
-            <a:fillRect/>
-          </a:stretch>
-        </p:blipFill>
-        <p:spPr>
-          <a:xfrm>
-            <a:off x="640080" y="1948559"/>
-            <a:ext cx="4389120" cy="3354073"/>
-          </a:xfrm>
-          <a:prstGeom prst="rect">
-            <a:avLst/>
-          </a:prstGeom>
-        </p:spPr>
-      </p:pic>
-      <p:sp>
-        <p:nvSpPr>
-          <p:cNvPr id="7" name="TextBox 6"/>
+      <p:sp>
+        <p:nvSpPr>
+          <p:cNvPr id="6" name="Rectangle 5"/>
+          <p:cNvSpPr/>
+          <p:nvPr/>
+        </p:nvSpPr>
+        <p:spPr>
+          <a:xfrm>
+            <a:off x="658368" y="1810512"/>
+            <a:ext cx="4535424" cy="4407408"/>
+          </a:xfrm>
+          <a:prstGeom prst="rect">
+            <a:avLst/>
+          </a:prstGeom>
+          <a:solidFill>
+            <a:srgbClr val="FFFFFF"/>
+          </a:solidFill>
+          <a:ln>
+            <a:noFill/>
+          </a:ln>
+        </p:spPr>
+        <p:style>
+          <a:lnRef idx="1">
+            <a:schemeClr val="accent1"/>
+          </a:lnRef>
+          <a:fillRef idx="3">
+            <a:schemeClr val="accent1"/>
+          </a:fillRef>
+          <a:effectRef idx="2">
+            <a:schemeClr val="accent1"/>
+          </a:effectRef>
+          <a:fontRef idx="minor">
+            <a:schemeClr val="lt1"/>
+          </a:fontRef>
+        </p:style>
+        <p:txBody>
+          <a:bodyPr rtlCol="0" anchor="ctr"/>
+          <a:lstStyle/>
+          <a:p>
+            <a:pPr algn="ctr"/>
+          </a:p>
+        </p:txBody>
+      </p:sp>
+      <p:sp>
+        <p:nvSpPr>
+          <p:cNvPr id="7" name="Rectangle 6"/>
+          <p:cNvSpPr/>
+          <p:nvPr/>
+        </p:nvSpPr>
+        <p:spPr>
+          <a:xfrm>
+            <a:off x="1605788" y="2807208"/>
+            <a:ext cx="25400" cy="658367"/>
+          </a:xfrm>
+          <a:prstGeom prst="rect">
+            <a:avLst/>
+          </a:prstGeom>
+          <a:solidFill>
+            <a:srgbClr val="526176"/>
+          </a:solidFill>
+          <a:ln>
+            <a:noFill/>
+          </a:ln>
+        </p:spPr>
+        <p:style>
+          <a:lnRef idx="1">
+            <a:schemeClr val="accent1"/>
+          </a:lnRef>
+          <a:fillRef idx="3">
+            <a:schemeClr val="accent1"/>
+          </a:fillRef>
+          <a:effectRef idx="2">
+            <a:schemeClr val="accent1"/>
+          </a:effectRef>
+          <a:fontRef idx="minor">
+            <a:schemeClr val="lt1"/>
+          </a:fontRef>
+        </p:style>
+        <p:txBody>
+          <a:bodyPr rtlCol="0" anchor="ctr"/>
+          <a:lstStyle/>
+          <a:p>
+            <a:pPr algn="ctr"/>
+          </a:p>
+        </p:txBody>
+      </p:sp>
+      <p:sp>
+        <p:nvSpPr>
+          <p:cNvPr id="8" name="Rectangle 7"/>
+          <p:cNvSpPr/>
+          <p:nvPr/>
+        </p:nvSpPr>
+        <p:spPr>
+          <a:xfrm>
+            <a:off x="1605788" y="3465576"/>
+            <a:ext cx="25400" cy="658367"/>
+          </a:xfrm>
+          <a:prstGeom prst="rect">
+            <a:avLst/>
+          </a:prstGeom>
+          <a:solidFill>
+            <a:srgbClr val="526176"/>
+          </a:solidFill>
+          <a:ln>
+            <a:noFill/>
+          </a:ln>
+        </p:spPr>
+        <p:style>
+          <a:lnRef idx="1">
+            <a:schemeClr val="accent1"/>
+          </a:lnRef>
+          <a:fillRef idx="3">
+            <a:schemeClr val="accent1"/>
+          </a:fillRef>
+          <a:effectRef idx="2">
+            <a:schemeClr val="accent1"/>
+          </a:effectRef>
+          <a:fontRef idx="minor">
+            <a:schemeClr val="lt1"/>
+          </a:fontRef>
+        </p:style>
+        <p:txBody>
+          <a:bodyPr rtlCol="0" anchor="ctr"/>
+          <a:lstStyle/>
+          <a:p>
+            <a:pPr algn="ctr"/>
+          </a:p>
+        </p:txBody>
+      </p:sp>
+      <p:sp>
+        <p:nvSpPr>
+          <p:cNvPr id="9" name="Rectangle 8"/>
+          <p:cNvSpPr/>
+          <p:nvPr/>
+        </p:nvSpPr>
+        <p:spPr>
+          <a:xfrm>
+            <a:off x="1605788" y="4123944"/>
+            <a:ext cx="25400" cy="658368"/>
+          </a:xfrm>
+          <a:prstGeom prst="rect">
+            <a:avLst/>
+          </a:prstGeom>
+          <a:solidFill>
+            <a:srgbClr val="526176"/>
+          </a:solidFill>
+          <a:ln>
+            <a:noFill/>
+          </a:ln>
+        </p:spPr>
+        <p:style>
+          <a:lnRef idx="1">
+            <a:schemeClr val="accent1"/>
+          </a:lnRef>
+          <a:fillRef idx="3">
+            <a:schemeClr val="accent1"/>
+          </a:fillRef>
+          <a:effectRef idx="2">
+            <a:schemeClr val="accent1"/>
+          </a:effectRef>
+          <a:fontRef idx="minor">
+            <a:schemeClr val="lt1"/>
+          </a:fontRef>
+        </p:style>
+        <p:txBody>
+          <a:bodyPr rtlCol="0" anchor="ctr"/>
+          <a:lstStyle/>
+          <a:p>
+            <a:pPr algn="ctr"/>
+          </a:p>
+        </p:txBody>
+      </p:sp>
+      <p:sp>
+        <p:nvSpPr>
+          <p:cNvPr id="10" name="Rectangle 9"/>
+          <p:cNvSpPr/>
+          <p:nvPr/>
+        </p:nvSpPr>
+        <p:spPr>
+          <a:xfrm>
+            <a:off x="2264156" y="4123944"/>
+            <a:ext cx="25400" cy="658368"/>
+          </a:xfrm>
+          <a:prstGeom prst="rect">
+            <a:avLst/>
+          </a:prstGeom>
+          <a:solidFill>
+            <a:srgbClr val="526176"/>
+          </a:solidFill>
+          <a:ln>
+            <a:noFill/>
+          </a:ln>
+        </p:spPr>
+        <p:style>
+          <a:lnRef idx="1">
+            <a:schemeClr val="accent1"/>
+          </a:lnRef>
+          <a:fillRef idx="3">
+            <a:schemeClr val="accent1"/>
+          </a:fillRef>
+          <a:effectRef idx="2">
+            <a:schemeClr val="accent1"/>
+          </a:effectRef>
+          <a:fontRef idx="minor">
+            <a:schemeClr val="lt1"/>
+          </a:fontRef>
+        </p:style>
+        <p:txBody>
+          <a:bodyPr rtlCol="0" anchor="ctr"/>
+          <a:lstStyle/>
+          <a:p>
+            <a:pPr algn="ctr"/>
+          </a:p>
+        </p:txBody>
+      </p:sp>
+      <p:sp>
+        <p:nvSpPr>
+          <p:cNvPr id="11" name="Rectangle 10"/>
+          <p:cNvSpPr/>
+          <p:nvPr/>
+        </p:nvSpPr>
+        <p:spPr>
+          <a:xfrm>
+            <a:off x="2922524" y="4123944"/>
+            <a:ext cx="25400" cy="658368"/>
+          </a:xfrm>
+          <a:prstGeom prst="rect">
+            <a:avLst/>
+          </a:prstGeom>
+          <a:solidFill>
+            <a:srgbClr val="526176"/>
+          </a:solidFill>
+          <a:ln>
+            <a:noFill/>
+          </a:ln>
+        </p:spPr>
+        <p:style>
+          <a:lnRef idx="1">
+            <a:schemeClr val="accent1"/>
+          </a:lnRef>
+          <a:fillRef idx="3">
+            <a:schemeClr val="accent1"/>
+          </a:fillRef>
+          <a:effectRef idx="2">
+            <a:schemeClr val="accent1"/>
+          </a:effectRef>
+          <a:fontRef idx="minor">
+            <a:schemeClr val="lt1"/>
+          </a:fontRef>
+        </p:style>
+        <p:txBody>
+          <a:bodyPr rtlCol="0" anchor="ctr"/>
+          <a:lstStyle/>
+          <a:p>
+            <a:pPr algn="ctr"/>
+          </a:p>
+        </p:txBody>
+      </p:sp>
+      <p:sp>
+        <p:nvSpPr>
+          <p:cNvPr id="12" name="Rectangle 11"/>
+          <p:cNvSpPr/>
+          <p:nvPr/>
+        </p:nvSpPr>
+        <p:spPr>
+          <a:xfrm>
+            <a:off x="3580892" y="4123944"/>
+            <a:ext cx="25400" cy="658368"/>
+          </a:xfrm>
+          <a:prstGeom prst="rect">
+            <a:avLst/>
+          </a:prstGeom>
+          <a:solidFill>
+            <a:srgbClr val="526176"/>
+          </a:solidFill>
+          <a:ln>
+            <a:noFill/>
+          </a:ln>
+        </p:spPr>
+        <p:style>
+          <a:lnRef idx="1">
+            <a:schemeClr val="accent1"/>
+          </a:lnRef>
+          <a:fillRef idx="3">
+            <a:schemeClr val="accent1"/>
+          </a:fillRef>
+          <a:effectRef idx="2">
+            <a:schemeClr val="accent1"/>
+          </a:effectRef>
+          <a:fontRef idx="minor">
+            <a:schemeClr val="lt1"/>
+          </a:fontRef>
+        </p:style>
+        <p:txBody>
+          <a:bodyPr rtlCol="0" anchor="ctr"/>
+          <a:lstStyle/>
+          <a:p>
+            <a:pPr algn="ctr"/>
+          </a:p>
+        </p:txBody>
+      </p:sp>
+      <p:sp>
+        <p:nvSpPr>
+          <p:cNvPr id="13" name="Rectangle 12"/>
+          <p:cNvSpPr/>
+          <p:nvPr/>
+        </p:nvSpPr>
+        <p:spPr>
+          <a:xfrm>
+            <a:off x="1605788" y="4782312"/>
+            <a:ext cx="25400" cy="658367"/>
+          </a:xfrm>
+          <a:prstGeom prst="rect">
+            <a:avLst/>
+          </a:prstGeom>
+          <a:solidFill>
+            <a:srgbClr val="526176"/>
+          </a:solidFill>
+          <a:ln>
+            <a:noFill/>
+          </a:ln>
+        </p:spPr>
+        <p:style>
+          <a:lnRef idx="1">
+            <a:schemeClr val="accent1"/>
+          </a:lnRef>
+          <a:fillRef idx="3">
+            <a:schemeClr val="accent1"/>
+          </a:fillRef>
+          <a:effectRef idx="2">
+            <a:schemeClr val="accent1"/>
+          </a:effectRef>
+          <a:fontRef idx="minor">
+            <a:schemeClr val="lt1"/>
+          </a:fontRef>
+        </p:style>
+        <p:txBody>
+          <a:bodyPr rtlCol="0" anchor="ctr"/>
+          <a:lstStyle/>
+          <a:p>
+            <a:pPr algn="ctr"/>
+          </a:p>
+        </p:txBody>
+      </p:sp>
+      <p:sp>
+        <p:nvSpPr>
+          <p:cNvPr id="14" name="Rectangle 13"/>
+          <p:cNvSpPr/>
+          <p:nvPr/>
+        </p:nvSpPr>
+        <p:spPr>
+          <a:xfrm>
+            <a:off x="2922524" y="4782312"/>
+            <a:ext cx="25400" cy="658367"/>
+          </a:xfrm>
+          <a:prstGeom prst="rect">
+            <a:avLst/>
+          </a:prstGeom>
+          <a:solidFill>
+            <a:srgbClr val="526176"/>
+          </a:solidFill>
+          <a:ln>
+            <a:noFill/>
+          </a:ln>
+        </p:spPr>
+        <p:style>
+          <a:lnRef idx="1">
+            <a:schemeClr val="accent1"/>
+          </a:lnRef>
+          <a:fillRef idx="3">
+            <a:schemeClr val="accent1"/>
+          </a:fillRef>
+          <a:effectRef idx="2">
+            <a:schemeClr val="accent1"/>
+          </a:effectRef>
+          <a:fontRef idx="minor">
+            <a:schemeClr val="lt1"/>
+          </a:fontRef>
+        </p:style>
+        <p:txBody>
+          <a:bodyPr rtlCol="0" anchor="ctr"/>
+          <a:lstStyle/>
+          <a:p>
+            <a:pPr algn="ctr"/>
+          </a:p>
+        </p:txBody>
+      </p:sp>
+      <p:sp>
+        <p:nvSpPr>
+          <p:cNvPr id="15" name="Rectangle 14"/>
+          <p:cNvSpPr/>
+          <p:nvPr/>
+        </p:nvSpPr>
+        <p:spPr>
+          <a:xfrm>
+            <a:off x="2276856" y="2794508"/>
+            <a:ext cx="658367" cy="25400"/>
+          </a:xfrm>
+          <a:prstGeom prst="rect">
+            <a:avLst/>
+          </a:prstGeom>
+          <a:solidFill>
+            <a:srgbClr val="526176"/>
+          </a:solidFill>
+          <a:ln>
+            <a:noFill/>
+          </a:ln>
+        </p:spPr>
+        <p:style>
+          <a:lnRef idx="1">
+            <a:schemeClr val="accent1"/>
+          </a:lnRef>
+          <a:fillRef idx="3">
+            <a:schemeClr val="accent1"/>
+          </a:fillRef>
+          <a:effectRef idx="2">
+            <a:schemeClr val="accent1"/>
+          </a:effectRef>
+          <a:fontRef idx="minor">
+            <a:schemeClr val="lt1"/>
+          </a:fontRef>
+        </p:style>
+        <p:txBody>
+          <a:bodyPr rtlCol="0" anchor="ctr"/>
+          <a:lstStyle/>
+          <a:p>
+            <a:pPr algn="ctr"/>
+          </a:p>
+        </p:txBody>
+      </p:sp>
+      <p:sp>
+        <p:nvSpPr>
+          <p:cNvPr id="16" name="Rectangle 15"/>
+          <p:cNvSpPr/>
+          <p:nvPr/>
+        </p:nvSpPr>
+        <p:spPr>
+          <a:xfrm>
+            <a:off x="2935224" y="2794508"/>
+            <a:ext cx="658367" cy="25400"/>
+          </a:xfrm>
+          <a:prstGeom prst="rect">
+            <a:avLst/>
+          </a:prstGeom>
+          <a:solidFill>
+            <a:srgbClr val="526176"/>
+          </a:solidFill>
+          <a:ln>
+            <a:noFill/>
+          </a:ln>
+        </p:spPr>
+        <p:style>
+          <a:lnRef idx="1">
+            <a:schemeClr val="accent1"/>
+          </a:lnRef>
+          <a:fillRef idx="3">
+            <a:schemeClr val="accent1"/>
+          </a:fillRef>
+          <a:effectRef idx="2">
+            <a:schemeClr val="accent1"/>
+          </a:effectRef>
+          <a:fontRef idx="minor">
+            <a:schemeClr val="lt1"/>
+          </a:fontRef>
+        </p:style>
+        <p:txBody>
+          <a:bodyPr rtlCol="0" anchor="ctr"/>
+          <a:lstStyle/>
+          <a:p>
+            <a:pPr algn="ctr"/>
+          </a:p>
+        </p:txBody>
+      </p:sp>
+      <p:sp>
+        <p:nvSpPr>
+          <p:cNvPr id="17" name="Rectangle 16"/>
+          <p:cNvSpPr/>
+          <p:nvPr/>
+        </p:nvSpPr>
+        <p:spPr>
+          <a:xfrm>
+            <a:off x="2276856" y="3452876"/>
+            <a:ext cx="658367" cy="25400"/>
+          </a:xfrm>
+          <a:prstGeom prst="rect">
+            <a:avLst/>
+          </a:prstGeom>
+          <a:solidFill>
+            <a:srgbClr val="526176"/>
+          </a:solidFill>
+          <a:ln>
+            <a:noFill/>
+          </a:ln>
+        </p:spPr>
+        <p:style>
+          <a:lnRef idx="1">
+            <a:schemeClr val="accent1"/>
+          </a:lnRef>
+          <a:fillRef idx="3">
+            <a:schemeClr val="accent1"/>
+          </a:fillRef>
+          <a:effectRef idx="2">
+            <a:schemeClr val="accent1"/>
+          </a:effectRef>
+          <a:fontRef idx="minor">
+            <a:schemeClr val="lt1"/>
+          </a:fontRef>
+        </p:style>
+        <p:txBody>
+          <a:bodyPr rtlCol="0" anchor="ctr"/>
+          <a:lstStyle/>
+          <a:p>
+            <a:pPr algn="ctr"/>
+          </a:p>
+        </p:txBody>
+      </p:sp>
+      <p:sp>
+        <p:nvSpPr>
+          <p:cNvPr id="18" name="Rectangle 17"/>
+          <p:cNvSpPr/>
+          <p:nvPr/>
+        </p:nvSpPr>
+        <p:spPr>
+          <a:xfrm>
+            <a:off x="2935224" y="3452876"/>
+            <a:ext cx="658367" cy="25400"/>
+          </a:xfrm>
+          <a:prstGeom prst="rect">
+            <a:avLst/>
+          </a:prstGeom>
+          <a:solidFill>
+            <a:srgbClr val="526176"/>
+          </a:solidFill>
+          <a:ln>
+            <a:noFill/>
+          </a:ln>
+        </p:spPr>
+        <p:style>
+          <a:lnRef idx="1">
+            <a:schemeClr val="accent1"/>
+          </a:lnRef>
+          <a:fillRef idx="3">
+            <a:schemeClr val="accent1"/>
+          </a:fillRef>
+          <a:effectRef idx="2">
+            <a:schemeClr val="accent1"/>
+          </a:effectRef>
+          <a:fontRef idx="minor">
+            <a:schemeClr val="lt1"/>
+          </a:fontRef>
+        </p:style>
+        <p:txBody>
+          <a:bodyPr rtlCol="0" anchor="ctr"/>
+          <a:lstStyle/>
+          <a:p>
+            <a:pPr algn="ctr"/>
+          </a:p>
+        </p:txBody>
+      </p:sp>
+      <p:sp>
+        <p:nvSpPr>
+          <p:cNvPr id="19" name="Rectangle 18"/>
+          <p:cNvSpPr/>
+          <p:nvPr/>
+        </p:nvSpPr>
+        <p:spPr>
+          <a:xfrm>
+            <a:off x="3593591" y="3452876"/>
+            <a:ext cx="658367" cy="25400"/>
+          </a:xfrm>
+          <a:prstGeom prst="rect">
+            <a:avLst/>
+          </a:prstGeom>
+          <a:solidFill>
+            <a:srgbClr val="526176"/>
+          </a:solidFill>
+          <a:ln>
+            <a:noFill/>
+          </a:ln>
+        </p:spPr>
+        <p:style>
+          <a:lnRef idx="1">
+            <a:schemeClr val="accent1"/>
+          </a:lnRef>
+          <a:fillRef idx="3">
+            <a:schemeClr val="accent1"/>
+          </a:fillRef>
+          <a:effectRef idx="2">
+            <a:schemeClr val="accent1"/>
+          </a:effectRef>
+          <a:fontRef idx="minor">
+            <a:schemeClr val="lt1"/>
+          </a:fontRef>
+        </p:style>
+        <p:txBody>
+          <a:bodyPr rtlCol="0" anchor="ctr"/>
+          <a:lstStyle/>
+          <a:p>
+            <a:pPr algn="ctr"/>
+          </a:p>
+        </p:txBody>
+      </p:sp>
+      <p:sp>
+        <p:nvSpPr>
+          <p:cNvPr id="20" name="Rectangle 19"/>
+          <p:cNvSpPr/>
+          <p:nvPr/>
+        </p:nvSpPr>
+        <p:spPr>
+          <a:xfrm>
+            <a:off x="2276856" y="4111243"/>
+            <a:ext cx="658367" cy="25400"/>
+          </a:xfrm>
+          <a:prstGeom prst="rect">
+            <a:avLst/>
+          </a:prstGeom>
+          <a:solidFill>
+            <a:srgbClr val="526176"/>
+          </a:solidFill>
+          <a:ln>
+            <a:noFill/>
+          </a:ln>
+        </p:spPr>
+        <p:style>
+          <a:lnRef idx="1">
+            <a:schemeClr val="accent1"/>
+          </a:lnRef>
+          <a:fillRef idx="3">
+            <a:schemeClr val="accent1"/>
+          </a:fillRef>
+          <a:effectRef idx="2">
+            <a:schemeClr val="accent1"/>
+          </a:effectRef>
+          <a:fontRef idx="minor">
+            <a:schemeClr val="lt1"/>
+          </a:fontRef>
+        </p:style>
+        <p:txBody>
+          <a:bodyPr rtlCol="0" anchor="ctr"/>
+          <a:lstStyle/>
+          <a:p>
+            <a:pPr algn="ctr"/>
+          </a:p>
+        </p:txBody>
+      </p:sp>
+      <p:sp>
+        <p:nvSpPr>
+          <p:cNvPr id="21" name="Rectangle 20"/>
+          <p:cNvSpPr/>
+          <p:nvPr/>
+        </p:nvSpPr>
+        <p:spPr>
+          <a:xfrm>
+            <a:off x="3593591" y="4769612"/>
+            <a:ext cx="658367" cy="25400"/>
+          </a:xfrm>
+          <a:prstGeom prst="rect">
+            <a:avLst/>
+          </a:prstGeom>
+          <a:solidFill>
+            <a:srgbClr val="526176"/>
+          </a:solidFill>
+          <a:ln>
+            <a:noFill/>
+          </a:ln>
+        </p:spPr>
+        <p:style>
+          <a:lnRef idx="1">
+            <a:schemeClr val="accent1"/>
+          </a:lnRef>
+          <a:fillRef idx="3">
+            <a:schemeClr val="accent1"/>
+          </a:fillRef>
+          <a:effectRef idx="2">
+            <a:schemeClr val="accent1"/>
+          </a:effectRef>
+          <a:fontRef idx="minor">
+            <a:schemeClr val="lt1"/>
+          </a:fontRef>
+        </p:style>
+        <p:txBody>
+          <a:bodyPr rtlCol="0" anchor="ctr"/>
+          <a:lstStyle/>
+          <a:p>
+            <a:pPr algn="ctr"/>
+          </a:p>
+        </p:txBody>
+      </p:sp>
+      <p:sp>
+        <p:nvSpPr>
+          <p:cNvPr id="22" name="Rectangle 21"/>
+          <p:cNvSpPr/>
+          <p:nvPr/>
+        </p:nvSpPr>
+        <p:spPr>
+          <a:xfrm>
+            <a:off x="960120" y="2132965"/>
+            <a:ext cx="3291839" cy="31750"/>
+          </a:xfrm>
+          <a:prstGeom prst="rect">
+            <a:avLst/>
+          </a:prstGeom>
+          <a:solidFill>
+            <a:srgbClr val="182636"/>
+          </a:solidFill>
+          <a:ln>
+            <a:noFill/>
+          </a:ln>
+        </p:spPr>
+        <p:style>
+          <a:lnRef idx="1">
+            <a:schemeClr val="accent1"/>
+          </a:lnRef>
+          <a:fillRef idx="3">
+            <a:schemeClr val="accent1"/>
+          </a:fillRef>
+          <a:effectRef idx="2">
+            <a:schemeClr val="accent1"/>
+          </a:effectRef>
+          <a:fontRef idx="minor">
+            <a:schemeClr val="lt1"/>
+          </a:fontRef>
+        </p:style>
+        <p:txBody>
+          <a:bodyPr rtlCol="0" anchor="ctr"/>
+          <a:lstStyle/>
+          <a:p>
+            <a:pPr algn="ctr"/>
+          </a:p>
+        </p:txBody>
+      </p:sp>
+      <p:sp>
+        <p:nvSpPr>
+          <p:cNvPr id="23" name="Rectangle 22"/>
+          <p:cNvSpPr/>
+          <p:nvPr/>
+        </p:nvSpPr>
+        <p:spPr>
+          <a:xfrm>
+            <a:off x="4236085" y="2148840"/>
+            <a:ext cx="31750" cy="3291839"/>
+          </a:xfrm>
+          <a:prstGeom prst="rect">
+            <a:avLst/>
+          </a:prstGeom>
+          <a:solidFill>
+            <a:srgbClr val="182636"/>
+          </a:solidFill>
+          <a:ln>
+            <a:noFill/>
+          </a:ln>
+        </p:spPr>
+        <p:style>
+          <a:lnRef idx="1">
+            <a:schemeClr val="accent1"/>
+          </a:lnRef>
+          <a:fillRef idx="3">
+            <a:schemeClr val="accent1"/>
+          </a:fillRef>
+          <a:effectRef idx="2">
+            <a:schemeClr val="accent1"/>
+          </a:effectRef>
+          <a:fontRef idx="minor">
+            <a:schemeClr val="lt1"/>
+          </a:fontRef>
+        </p:style>
+        <p:txBody>
+          <a:bodyPr rtlCol="0" anchor="ctr"/>
+          <a:lstStyle/>
+          <a:p>
+            <a:pPr algn="ctr"/>
+          </a:p>
+        </p:txBody>
+      </p:sp>
+      <p:sp>
+        <p:nvSpPr>
+          <p:cNvPr id="24" name="Rectangle 23"/>
+          <p:cNvSpPr/>
+          <p:nvPr/>
+        </p:nvSpPr>
+        <p:spPr>
+          <a:xfrm>
+            <a:off x="960120" y="5424805"/>
+            <a:ext cx="3291839" cy="31750"/>
+          </a:xfrm>
+          <a:prstGeom prst="rect">
+            <a:avLst/>
+          </a:prstGeom>
+          <a:solidFill>
+            <a:srgbClr val="182636"/>
+          </a:solidFill>
+          <a:ln>
+            <a:noFill/>
+          </a:ln>
+        </p:spPr>
+        <p:style>
+          <a:lnRef idx="1">
+            <a:schemeClr val="accent1"/>
+          </a:lnRef>
+          <a:fillRef idx="3">
+            <a:schemeClr val="accent1"/>
+          </a:fillRef>
+          <a:effectRef idx="2">
+            <a:schemeClr val="accent1"/>
+          </a:effectRef>
+          <a:fontRef idx="minor">
+            <a:schemeClr val="lt1"/>
+          </a:fontRef>
+        </p:style>
+        <p:txBody>
+          <a:bodyPr rtlCol="0" anchor="ctr"/>
+          <a:lstStyle/>
+          <a:p>
+            <a:pPr algn="ctr"/>
+          </a:p>
+        </p:txBody>
+      </p:sp>
+      <p:sp>
+        <p:nvSpPr>
+          <p:cNvPr id="25" name="Rectangle 24"/>
+          <p:cNvSpPr/>
+          <p:nvPr/>
+        </p:nvSpPr>
+        <p:spPr>
+          <a:xfrm>
+            <a:off x="944245" y="2148840"/>
+            <a:ext cx="31750" cy="3291839"/>
+          </a:xfrm>
+          <a:prstGeom prst="rect">
+            <a:avLst/>
+          </a:prstGeom>
+          <a:solidFill>
+            <a:srgbClr val="182636"/>
+          </a:solidFill>
+          <a:ln>
+            <a:noFill/>
+          </a:ln>
+        </p:spPr>
+        <p:style>
+          <a:lnRef idx="1">
+            <a:schemeClr val="accent1"/>
+          </a:lnRef>
+          <a:fillRef idx="3">
+            <a:schemeClr val="accent1"/>
+          </a:fillRef>
+          <a:effectRef idx="2">
+            <a:schemeClr val="accent1"/>
+          </a:effectRef>
+          <a:fontRef idx="minor">
+            <a:schemeClr val="lt1"/>
+          </a:fontRef>
+        </p:style>
+        <p:txBody>
+          <a:bodyPr rtlCol="0" anchor="ctr"/>
+          <a:lstStyle/>
+          <a:p>
+            <a:pPr algn="ctr"/>
+          </a:p>
+        </p:txBody>
+      </p:sp>
+      <p:sp>
+        <p:nvSpPr>
+          <p:cNvPr id="26" name="Rectangle 25"/>
+          <p:cNvSpPr/>
+          <p:nvPr/>
+        </p:nvSpPr>
+        <p:spPr>
+          <a:xfrm>
+            <a:off x="1289304" y="2433574"/>
+            <a:ext cx="658367" cy="88900"/>
+          </a:xfrm>
+          <a:prstGeom prst="rect">
+            <a:avLst/>
+          </a:prstGeom>
+          <a:solidFill>
+            <a:srgbClr val="244BDD"/>
+          </a:solidFill>
+          <a:ln>
+            <a:noFill/>
+          </a:ln>
+        </p:spPr>
+        <p:style>
+          <a:lnRef idx="1">
+            <a:schemeClr val="accent1"/>
+          </a:lnRef>
+          <a:fillRef idx="3">
+            <a:schemeClr val="accent1"/>
+          </a:fillRef>
+          <a:effectRef idx="2">
+            <a:schemeClr val="accent1"/>
+          </a:effectRef>
+          <a:fontRef idx="minor">
+            <a:schemeClr val="lt1"/>
+          </a:fontRef>
+        </p:style>
+        <p:txBody>
+          <a:bodyPr rtlCol="0" anchor="ctr"/>
+          <a:lstStyle/>
+          <a:p>
+            <a:pPr algn="ctr"/>
+          </a:p>
+        </p:txBody>
+      </p:sp>
+      <p:sp>
+        <p:nvSpPr>
+          <p:cNvPr id="27" name="Rectangle 26"/>
+          <p:cNvSpPr/>
+          <p:nvPr/>
+        </p:nvSpPr>
+        <p:spPr>
+          <a:xfrm>
+            <a:off x="1903221" y="2478024"/>
+            <a:ext cx="88900" cy="658368"/>
+          </a:xfrm>
+          <a:prstGeom prst="rect">
+            <a:avLst/>
+          </a:prstGeom>
+          <a:solidFill>
+            <a:srgbClr val="244BDD"/>
+          </a:solidFill>
+          <a:ln>
+            <a:noFill/>
+          </a:ln>
+        </p:spPr>
+        <p:style>
+          <a:lnRef idx="1">
+            <a:schemeClr val="accent1"/>
+          </a:lnRef>
+          <a:fillRef idx="3">
+            <a:schemeClr val="accent1"/>
+          </a:fillRef>
+          <a:effectRef idx="2">
+            <a:schemeClr val="accent1"/>
+          </a:effectRef>
+          <a:fontRef idx="minor">
+            <a:schemeClr val="lt1"/>
+          </a:fontRef>
+        </p:style>
+        <p:txBody>
+          <a:bodyPr rtlCol="0" anchor="ctr"/>
+          <a:lstStyle/>
+          <a:p>
+            <a:pPr algn="ctr"/>
+          </a:p>
+        </p:txBody>
+      </p:sp>
+      <p:sp>
+        <p:nvSpPr>
+          <p:cNvPr id="28" name="Rectangle 27"/>
+          <p:cNvSpPr/>
+          <p:nvPr/>
+        </p:nvSpPr>
+        <p:spPr>
+          <a:xfrm>
+            <a:off x="1903221" y="3136392"/>
+            <a:ext cx="88900" cy="658368"/>
+          </a:xfrm>
+          <a:prstGeom prst="rect">
+            <a:avLst/>
+          </a:prstGeom>
+          <a:solidFill>
+            <a:srgbClr val="244BDD"/>
+          </a:solidFill>
+          <a:ln>
+            <a:noFill/>
+          </a:ln>
+        </p:spPr>
+        <p:style>
+          <a:lnRef idx="1">
+            <a:schemeClr val="accent1"/>
+          </a:lnRef>
+          <a:fillRef idx="3">
+            <a:schemeClr val="accent1"/>
+          </a:fillRef>
+          <a:effectRef idx="2">
+            <a:schemeClr val="accent1"/>
+          </a:effectRef>
+          <a:fontRef idx="minor">
+            <a:schemeClr val="lt1"/>
+          </a:fontRef>
+        </p:style>
+        <p:txBody>
+          <a:bodyPr rtlCol="0" anchor="ctr"/>
+          <a:lstStyle/>
+          <a:p>
+            <a:pPr algn="ctr"/>
+          </a:p>
+        </p:txBody>
+      </p:sp>
+      <p:sp>
+        <p:nvSpPr>
+          <p:cNvPr id="29" name="Rectangle 28"/>
+          <p:cNvSpPr/>
+          <p:nvPr/>
+        </p:nvSpPr>
+        <p:spPr>
+          <a:xfrm>
+            <a:off x="1947672" y="3750310"/>
+            <a:ext cx="658367" cy="88900"/>
+          </a:xfrm>
+          <a:prstGeom prst="rect">
+            <a:avLst/>
+          </a:prstGeom>
+          <a:solidFill>
+            <a:srgbClr val="244BDD"/>
+          </a:solidFill>
+          <a:ln>
+            <a:noFill/>
+          </a:ln>
+        </p:spPr>
+        <p:style>
+          <a:lnRef idx="1">
+            <a:schemeClr val="accent1"/>
+          </a:lnRef>
+          <a:fillRef idx="3">
+            <a:schemeClr val="accent1"/>
+          </a:fillRef>
+          <a:effectRef idx="2">
+            <a:schemeClr val="accent1"/>
+          </a:effectRef>
+          <a:fontRef idx="minor">
+            <a:schemeClr val="lt1"/>
+          </a:fontRef>
+        </p:style>
+        <p:txBody>
+          <a:bodyPr rtlCol="0" anchor="ctr"/>
+          <a:lstStyle/>
+          <a:p>
+            <a:pPr algn="ctr"/>
+          </a:p>
+        </p:txBody>
+      </p:sp>
+      <p:sp>
+        <p:nvSpPr>
+          <p:cNvPr id="30" name="Rectangle 29"/>
+          <p:cNvSpPr/>
+          <p:nvPr/>
+        </p:nvSpPr>
+        <p:spPr>
+          <a:xfrm>
+            <a:off x="2606039" y="3750310"/>
+            <a:ext cx="658368" cy="88900"/>
+          </a:xfrm>
+          <a:prstGeom prst="rect">
+            <a:avLst/>
+          </a:prstGeom>
+          <a:solidFill>
+            <a:srgbClr val="244BDD"/>
+          </a:solidFill>
+          <a:ln>
+            <a:noFill/>
+          </a:ln>
+        </p:spPr>
+        <p:style>
+          <a:lnRef idx="1">
+            <a:schemeClr val="accent1"/>
+          </a:lnRef>
+          <a:fillRef idx="3">
+            <a:schemeClr val="accent1"/>
+          </a:fillRef>
+          <a:effectRef idx="2">
+            <a:schemeClr val="accent1"/>
+          </a:effectRef>
+          <a:fontRef idx="minor">
+            <a:schemeClr val="lt1"/>
+          </a:fontRef>
+        </p:style>
+        <p:txBody>
+          <a:bodyPr rtlCol="0" anchor="ctr"/>
+          <a:lstStyle/>
+          <a:p>
+            <a:pPr algn="ctr"/>
+          </a:p>
+        </p:txBody>
+      </p:sp>
+      <p:sp>
+        <p:nvSpPr>
+          <p:cNvPr id="31" name="Rectangle 30"/>
+          <p:cNvSpPr/>
+          <p:nvPr/>
+        </p:nvSpPr>
+        <p:spPr>
+          <a:xfrm>
+            <a:off x="3219958" y="3794760"/>
+            <a:ext cx="88900" cy="658367"/>
+          </a:xfrm>
+          <a:prstGeom prst="rect">
+            <a:avLst/>
+          </a:prstGeom>
+          <a:solidFill>
+            <a:srgbClr val="244BDD"/>
+          </a:solidFill>
+          <a:ln>
+            <a:noFill/>
+          </a:ln>
+        </p:spPr>
+        <p:style>
+          <a:lnRef idx="1">
+            <a:schemeClr val="accent1"/>
+          </a:lnRef>
+          <a:fillRef idx="3">
+            <a:schemeClr val="accent1"/>
+          </a:fillRef>
+          <a:effectRef idx="2">
+            <a:schemeClr val="accent1"/>
+          </a:effectRef>
+          <a:fontRef idx="minor">
+            <a:schemeClr val="lt1"/>
+          </a:fontRef>
+        </p:style>
+        <p:txBody>
+          <a:bodyPr rtlCol="0" anchor="ctr"/>
+          <a:lstStyle/>
+          <a:p>
+            <a:pPr algn="ctr"/>
+          </a:p>
+        </p:txBody>
+      </p:sp>
+      <p:sp>
+        <p:nvSpPr>
+          <p:cNvPr id="32" name="Rectangle 31"/>
+          <p:cNvSpPr/>
+          <p:nvPr/>
+        </p:nvSpPr>
+        <p:spPr>
+          <a:xfrm>
+            <a:off x="3219958" y="4453128"/>
+            <a:ext cx="88900" cy="658367"/>
+          </a:xfrm>
+          <a:prstGeom prst="rect">
+            <a:avLst/>
+          </a:prstGeom>
+          <a:solidFill>
+            <a:srgbClr val="244BDD"/>
+          </a:solidFill>
+          <a:ln>
+            <a:noFill/>
+          </a:ln>
+        </p:spPr>
+        <p:style>
+          <a:lnRef idx="1">
+            <a:schemeClr val="accent1"/>
+          </a:lnRef>
+          <a:fillRef idx="3">
+            <a:schemeClr val="accent1"/>
+          </a:fillRef>
+          <a:effectRef idx="2">
+            <a:schemeClr val="accent1"/>
+          </a:effectRef>
+          <a:fontRef idx="minor">
+            <a:schemeClr val="lt1"/>
+          </a:fontRef>
+        </p:style>
+        <p:txBody>
+          <a:bodyPr rtlCol="0" anchor="ctr"/>
+          <a:lstStyle/>
+          <a:p>
+            <a:pPr algn="ctr"/>
+          </a:p>
+        </p:txBody>
+      </p:sp>
+      <p:sp>
+        <p:nvSpPr>
+          <p:cNvPr id="33" name="Rectangle 32"/>
+          <p:cNvSpPr/>
+          <p:nvPr/>
+        </p:nvSpPr>
+        <p:spPr>
+          <a:xfrm>
+            <a:off x="3264408" y="5067046"/>
+            <a:ext cx="658367" cy="88900"/>
+          </a:xfrm>
+          <a:prstGeom prst="rect">
+            <a:avLst/>
+          </a:prstGeom>
+          <a:solidFill>
+            <a:srgbClr val="244BDD"/>
+          </a:solidFill>
+          <a:ln>
+            <a:noFill/>
+          </a:ln>
+        </p:spPr>
+        <p:style>
+          <a:lnRef idx="1">
+            <a:schemeClr val="accent1"/>
+          </a:lnRef>
+          <a:fillRef idx="3">
+            <a:schemeClr val="accent1"/>
+          </a:fillRef>
+          <a:effectRef idx="2">
+            <a:schemeClr val="accent1"/>
+          </a:effectRef>
+          <a:fontRef idx="minor">
+            <a:schemeClr val="lt1"/>
+          </a:fontRef>
+        </p:style>
+        <p:txBody>
+          <a:bodyPr rtlCol="0" anchor="ctr"/>
+          <a:lstStyle/>
+          <a:p>
+            <a:pPr algn="ctr"/>
+          </a:p>
+        </p:txBody>
+      </p:sp>
+      <p:sp>
+        <p:nvSpPr>
+          <p:cNvPr id="34" name="Oval 33"/>
+          <p:cNvSpPr/>
+          <p:nvPr/>
+        </p:nvSpPr>
+        <p:spPr>
+          <a:xfrm>
+            <a:off x="1193292" y="2382012"/>
+            <a:ext cx="192024" cy="192024"/>
+          </a:xfrm>
+          <a:prstGeom prst="ellipse">
+            <a:avLst/>
+          </a:prstGeom>
+          <a:solidFill>
+            <a:srgbClr val="182636"/>
+          </a:solidFill>
+          <a:ln>
+            <a:noFill/>
+          </a:ln>
+        </p:spPr>
+        <p:style>
+          <a:lnRef idx="1">
+            <a:schemeClr val="accent1"/>
+          </a:lnRef>
+          <a:fillRef idx="3">
+            <a:schemeClr val="accent1"/>
+          </a:fillRef>
+          <a:effectRef idx="2">
+            <a:schemeClr val="accent1"/>
+          </a:effectRef>
+          <a:fontRef idx="minor">
+            <a:schemeClr val="lt1"/>
+          </a:fontRef>
+        </p:style>
+        <p:txBody>
+          <a:bodyPr rtlCol="0" anchor="ctr"/>
+          <a:lstStyle/>
+          <a:p>
+            <a:pPr algn="ctr"/>
+          </a:p>
+        </p:txBody>
+      </p:sp>
+      <p:sp>
+        <p:nvSpPr>
+          <p:cNvPr id="35" name="Oval 34"/>
+          <p:cNvSpPr/>
+          <p:nvPr/>
+        </p:nvSpPr>
+        <p:spPr>
+          <a:xfrm>
+            <a:off x="3813048" y="5001768"/>
+            <a:ext cx="219456" cy="219456"/>
+          </a:xfrm>
+          <a:prstGeom prst="ellipse">
+            <a:avLst/>
+          </a:prstGeom>
+          <a:solidFill>
+            <a:srgbClr val="182636"/>
+          </a:solidFill>
+          <a:ln>
+            <a:noFill/>
+          </a:ln>
+        </p:spPr>
+        <p:style>
+          <a:lnRef idx="1">
+            <a:schemeClr val="accent1"/>
+          </a:lnRef>
+          <a:fillRef idx="3">
+            <a:schemeClr val="accent1"/>
+          </a:fillRef>
+          <a:effectRef idx="2">
+            <a:schemeClr val="accent1"/>
+          </a:effectRef>
+          <a:fontRef idx="minor">
+            <a:schemeClr val="lt1"/>
+          </a:fontRef>
+        </p:style>
+        <p:txBody>
+          <a:bodyPr rtlCol="0" anchor="ctr"/>
+          <a:lstStyle/>
+          <a:p>
+            <a:pPr algn="ctr"/>
+          </a:p>
+        </p:txBody>
+      </p:sp>
+      <p:sp>
+        <p:nvSpPr>
+          <p:cNvPr id="36" name="TextBox 35"/>
           <p:cNvSpPr txBox="1"/>
           <p:nvPr/>
         </p:nvSpPr>
         <p:spPr>
           <a:xfrm>
-            <a:off x="685800" y="5468112"/>
-            <a:ext cx="4480560" cy="548640"/>
+            <a:off x="960120" y="1856231"/>
+            <a:ext cx="1645920" cy="246888"/>
           </a:xfrm>
           <a:prstGeom prst="rect">
             <a:avLst/>
@@ -9610,43 +11293,27 @@
               </a:spcAft>
             </a:pPr>
             <a:r>
-              <a:rPr sz="1300" b="0">
-                <a:solidFill>
-                  <a:srgbClr val="526176"/>
-                </a:solidFill>
-                <a:latin typeface="Aptos"/>
-              </a:rPr>
-              <a:t>ENIAC, cca 1947-1955</a:t>
-            </a:r>
-          </a:p>
-          <a:p>
-            <a:pPr>
-              <a:spcAft>
-                <a:spcPts val="800"/>
-              </a:spcAft>
-            </a:pPr>
-            <a:r>
-              <a:rPr sz="1300" b="0">
-                <a:solidFill>
-                  <a:srgbClr val="526176"/>
-                </a:solidFill>
-                <a:latin typeface="Aptos"/>
-              </a:rPr>
-              <a:t>U.S. Army / Wikimedia Commons</a:t>
-            </a:r>
-          </a:p>
-        </p:txBody>
-      </p:sp>
-      <p:sp>
-        <p:nvSpPr>
-          <p:cNvPr id="8" name="TextBox 7"/>
+              <a:rPr sz="1400" b="1">
+                <a:solidFill>
+                  <a:srgbClr val="244BDD"/>
+                </a:solidFill>
+                <a:latin typeface="Aptos"/>
+              </a:rPr>
+              <a:t>START</a:t>
+            </a:r>
+          </a:p>
+        </p:txBody>
+      </p:sp>
+      <p:sp>
+        <p:nvSpPr>
+          <p:cNvPr id="37" name="TextBox 36"/>
           <p:cNvSpPr txBox="1"/>
           <p:nvPr/>
         </p:nvSpPr>
         <p:spPr>
           <a:xfrm>
-            <a:off x="5486400" y="1874519"/>
-            <a:ext cx="1005840" cy="502920"/>
+            <a:off x="3383280" y="5486400"/>
+            <a:ext cx="1371600" cy="320040"/>
           </a:xfrm>
           <a:prstGeom prst="rect">
             <a:avLst/>
@@ -9665,27 +11332,27 @@
               </a:spcAft>
             </a:pPr>
             <a:r>
-              <a:rPr sz="2500" b="1">
+              <a:rPr sz="1400" b="1">
                 <a:solidFill>
                   <a:srgbClr val="244BDD"/>
                 </a:solidFill>
                 <a:latin typeface="Aptos"/>
               </a:rPr>
-              <a:t>1950</a:t>
-            </a:r>
-          </a:p>
-        </p:txBody>
-      </p:sp>
-      <p:sp>
-        <p:nvSpPr>
-          <p:cNvPr id="9" name="TextBox 8"/>
+              <a:t>IESIRE</a:t>
+            </a:r>
+          </a:p>
+        </p:txBody>
+      </p:sp>
+      <p:sp>
+        <p:nvSpPr>
+          <p:cNvPr id="38" name="TextBox 37"/>
           <p:cNvSpPr txBox="1"/>
           <p:nvPr/>
         </p:nvSpPr>
         <p:spPr>
           <a:xfrm>
-            <a:off x="6510528" y="1874519"/>
-            <a:ext cx="4892040" cy="502920"/>
+            <a:off x="960120" y="5852160"/>
+            <a:ext cx="3931920" cy="274320"/>
           </a:xfrm>
           <a:prstGeom prst="rect">
             <a:avLst/>
@@ -9704,27 +11371,27 @@
               </a:spcAft>
             </a:pPr>
             <a:r>
-              <a:rPr sz="2500" b="1">
-                <a:solidFill>
-                  <a:srgbClr val="182636"/>
-                </a:solidFill>
-                <a:latin typeface="Aptos"/>
-              </a:rPr>
-              <a:t>Theseus gaseste iesirea.</a:t>
-            </a:r>
-          </a:p>
-        </p:txBody>
-      </p:sp>
-      <p:sp>
-        <p:nvSpPr>
-          <p:cNvPr id="10" name="TextBox 9"/>
+              <a:rPr sz="1300" b="0">
+                <a:solidFill>
+                  <a:srgbClr val="526176"/>
+                </a:solidFill>
+                <a:latin typeface="Aptos"/>
+              </a:rPr>
+              <a:t>Schema ilustrativa: Theseus, 1950</a:t>
+            </a:r>
+          </a:p>
+        </p:txBody>
+      </p:sp>
+      <p:sp>
+        <p:nvSpPr>
+          <p:cNvPr id="39" name="TextBox 38"/>
           <p:cNvSpPr txBox="1"/>
           <p:nvPr/>
         </p:nvSpPr>
         <p:spPr>
           <a:xfrm>
-            <a:off x="6510528" y="2441448"/>
-            <a:ext cx="4892040" cy="621792"/>
+            <a:off x="5486400" y="1874519"/>
+            <a:ext cx="1005840" cy="502920"/>
           </a:xfrm>
           <a:prstGeom prst="rect">
             <a:avLst/>
@@ -9743,27 +11410,27 @@
               </a:spcAft>
             </a:pPr>
             <a:r>
-              <a:rPr sz="2100" b="0">
-                <a:solidFill>
-                  <a:srgbClr val="182636"/>
-                </a:solidFill>
-                <a:latin typeface="Aptos"/>
-              </a:rPr>
-              <a:t>Claude Shannon: un labirint si memorie in relee.</a:t>
-            </a:r>
-          </a:p>
-        </p:txBody>
-      </p:sp>
-      <p:sp>
-        <p:nvSpPr>
-          <p:cNvPr id="11" name="TextBox 10"/>
+              <a:rPr sz="2500" b="1">
+                <a:solidFill>
+                  <a:srgbClr val="244BDD"/>
+                </a:solidFill>
+                <a:latin typeface="Aptos"/>
+              </a:rPr>
+              <a:t>1950</a:t>
+            </a:r>
+          </a:p>
+        </p:txBody>
+      </p:sp>
+      <p:sp>
+        <p:nvSpPr>
+          <p:cNvPr id="40" name="TextBox 39"/>
           <p:cNvSpPr txBox="1"/>
           <p:nvPr/>
         </p:nvSpPr>
         <p:spPr>
           <a:xfrm>
-            <a:off x="5486400" y="3182111"/>
-            <a:ext cx="1005840" cy="502920"/>
+            <a:off x="6510528" y="1874519"/>
+            <a:ext cx="4892040" cy="502920"/>
           </a:xfrm>
           <a:prstGeom prst="rect">
             <a:avLst/>
@@ -9784,25 +11451,25 @@
             <a:r>
               <a:rPr sz="2500" b="1">
                 <a:solidFill>
-                  <a:srgbClr val="244BDD"/>
-                </a:solidFill>
-                <a:latin typeface="Aptos"/>
-              </a:rPr>
-              <a:t>1966</a:t>
-            </a:r>
-          </a:p>
-        </p:txBody>
-      </p:sp>
-      <p:sp>
-        <p:nvSpPr>
-          <p:cNvPr id="12" name="TextBox 11"/>
+                  <a:srgbClr val="182636"/>
+                </a:solidFill>
+                <a:latin typeface="Aptos"/>
+              </a:rPr>
+              <a:t>Theseus gaseste iesirea.</a:t>
+            </a:r>
+          </a:p>
+        </p:txBody>
+      </p:sp>
+      <p:sp>
+        <p:nvSpPr>
+          <p:cNvPr id="41" name="TextBox 40"/>
           <p:cNvSpPr txBox="1"/>
           <p:nvPr/>
         </p:nvSpPr>
         <p:spPr>
           <a:xfrm>
-            <a:off x="6510528" y="3182111"/>
-            <a:ext cx="4892040" cy="502920"/>
+            <a:off x="6510528" y="2441448"/>
+            <a:ext cx="4892040" cy="621792"/>
           </a:xfrm>
           <a:prstGeom prst="rect">
             <a:avLst/>
@@ -9821,27 +11488,27 @@
               </a:spcAft>
             </a:pPr>
             <a:r>
-              <a:rPr sz="2500" b="1">
+              <a:rPr sz="2100" b="0">
                 <a:solidFill>
                   <a:srgbClr val="182636"/>
                 </a:solidFill>
                 <a:latin typeface="Aptos"/>
               </a:rPr>
-              <a:t>ELIZA sustine o conversatie.</a:t>
-            </a:r>
-          </a:p>
-        </p:txBody>
-      </p:sp>
-      <p:sp>
-        <p:nvSpPr>
-          <p:cNvPr id="13" name="TextBox 12"/>
+              <a:t>Claude Shannon: un labirint si memorie in relee.</a:t>
+            </a:r>
+          </a:p>
+        </p:txBody>
+      </p:sp>
+      <p:sp>
+        <p:nvSpPr>
+          <p:cNvPr id="42" name="TextBox 41"/>
           <p:cNvSpPr txBox="1"/>
           <p:nvPr/>
         </p:nvSpPr>
         <p:spPr>
           <a:xfrm>
-            <a:off x="6510528" y="3749039"/>
-            <a:ext cx="4892040" cy="621792"/>
+            <a:off x="5486400" y="3182111"/>
+            <a:ext cx="1005840" cy="502920"/>
           </a:xfrm>
           <a:prstGeom prst="rect">
             <a:avLst/>
@@ -9860,27 +11527,27 @@
               </a:spcAft>
             </a:pPr>
             <a:r>
-              <a:rPr sz="2100" b="0">
-                <a:solidFill>
-                  <a:srgbClr val="182636"/>
-                </a:solidFill>
-                <a:latin typeface="Aptos"/>
-              </a:rPr>
-              <a:t>Joseph Weizenbaum: reguli si tipare de limbaj.</a:t>
-            </a:r>
-          </a:p>
-        </p:txBody>
-      </p:sp>
-      <p:sp>
-        <p:nvSpPr>
-          <p:cNvPr id="14" name="TextBox 13"/>
+              <a:rPr sz="2500" b="1">
+                <a:solidFill>
+                  <a:srgbClr val="244BDD"/>
+                </a:solidFill>
+                <a:latin typeface="Aptos"/>
+              </a:rPr>
+              <a:t>1966</a:t>
+            </a:r>
+          </a:p>
+        </p:txBody>
+      </p:sp>
+      <p:sp>
+        <p:nvSpPr>
+          <p:cNvPr id="43" name="TextBox 42"/>
           <p:cNvSpPr txBox="1"/>
           <p:nvPr/>
         </p:nvSpPr>
         <p:spPr>
           <a:xfrm>
-            <a:off x="5486400" y="4489704"/>
-            <a:ext cx="1005840" cy="502920"/>
+            <a:off x="6510528" y="3182111"/>
+            <a:ext cx="4892040" cy="502920"/>
           </a:xfrm>
           <a:prstGeom prst="rect">
             <a:avLst/>
@@ -9901,25 +11568,25 @@
             <a:r>
               <a:rPr sz="2500" b="1">
                 <a:solidFill>
-                  <a:srgbClr val="244BDD"/>
-                </a:solidFill>
-                <a:latin typeface="Aptos"/>
-              </a:rPr>
-              <a:t>2022</a:t>
-            </a:r>
-          </a:p>
-        </p:txBody>
-      </p:sp>
-      <p:sp>
-        <p:nvSpPr>
-          <p:cNvPr id="15" name="TextBox 14"/>
+                  <a:srgbClr val="182636"/>
+                </a:solidFill>
+                <a:latin typeface="Aptos"/>
+              </a:rPr>
+              <a:t>ELIZA sustine o conversatie.</a:t>
+            </a:r>
+          </a:p>
+        </p:txBody>
+      </p:sp>
+      <p:sp>
+        <p:nvSpPr>
+          <p:cNvPr id="44" name="TextBox 43"/>
           <p:cNvSpPr txBox="1"/>
           <p:nvPr/>
         </p:nvSpPr>
         <p:spPr>
           <a:xfrm>
-            <a:off x="6510528" y="4489704"/>
-            <a:ext cx="4892040" cy="502920"/>
+            <a:off x="6510528" y="3749039"/>
+            <a:ext cx="4892040" cy="621792"/>
           </a:xfrm>
           <a:prstGeom prst="rect">
             <a:avLst/>
@@ -9938,8 +11605,86 @@
               </a:spcAft>
             </a:pPr>
             <a:r>
+              <a:rPr sz="2100" b="0">
+                <a:solidFill>
+                  <a:srgbClr val="182636"/>
+                </a:solidFill>
+                <a:latin typeface="Aptos"/>
+              </a:rPr>
+              <a:t>Joseph Weizenbaum: reguli si tipare de limbaj.</a:t>
+            </a:r>
+          </a:p>
+        </p:txBody>
+      </p:sp>
+      <p:sp>
+        <p:nvSpPr>
+          <p:cNvPr id="45" name="TextBox 44"/>
+          <p:cNvSpPr txBox="1"/>
+          <p:nvPr/>
+        </p:nvSpPr>
+        <p:spPr>
+          <a:xfrm>
+            <a:off x="5486400" y="4489704"/>
+            <a:ext cx="1005840" cy="502920"/>
+          </a:xfrm>
+          <a:prstGeom prst="rect">
+            <a:avLst/>
+          </a:prstGeom>
+          <a:noFill/>
+        </p:spPr>
+        <p:txBody>
+          <a:bodyPr wrap="square" lIns="22860" rIns="22860" tIns="22860" bIns="22860">
+            <a:spAutoFit/>
+          </a:bodyPr>
+          <a:lstStyle/>
+          <a:p>
+            <a:pPr>
+              <a:spcAft>
+                <a:spcPts val="800"/>
+              </a:spcAft>
+            </a:pPr>
+            <a:r>
               <a:rPr sz="2500" b="1">
                 <a:solidFill>
+                  <a:srgbClr val="244BDD"/>
+                </a:solidFill>
+                <a:latin typeface="Aptos"/>
+              </a:rPr>
+              <a:t>2022</a:t>
+            </a:r>
+          </a:p>
+        </p:txBody>
+      </p:sp>
+      <p:sp>
+        <p:nvSpPr>
+          <p:cNvPr id="46" name="TextBox 45"/>
+          <p:cNvSpPr txBox="1"/>
+          <p:nvPr/>
+        </p:nvSpPr>
+        <p:spPr>
+          <a:xfrm>
+            <a:off x="6510528" y="4489704"/>
+            <a:ext cx="4892040" cy="502920"/>
+          </a:xfrm>
+          <a:prstGeom prst="rect">
+            <a:avLst/>
+          </a:prstGeom>
+          <a:noFill/>
+        </p:spPr>
+        <p:txBody>
+          <a:bodyPr wrap="square" lIns="22860" rIns="22860" tIns="22860" bIns="22860">
+            <a:spAutoFit/>
+          </a:bodyPr>
+          <a:lstStyle/>
+          <a:p>
+            <a:pPr>
+              <a:spcAft>
+                <a:spcPts val="800"/>
+              </a:spcAft>
+            </a:pPr>
+            <a:r>
+              <a:rPr sz="2500" b="1">
+                <a:solidFill>
                   <a:srgbClr val="182636"/>
                 </a:solidFill>
                 <a:latin typeface="Aptos"/>
@@ -9951,7 +11696,7 @@
       </p:sp>
       <p:sp>
         <p:nvSpPr>
-          <p:cNvPr id="16" name="TextBox 15"/>
+          <p:cNvPr id="47" name="TextBox 46"/>
           <p:cNvSpPr txBox="1"/>
           <p:nvPr/>
         </p:nvSpPr>
@@ -10684,8 +12429,8 @@
         </p:nvSpPr>
         <p:spPr>
           <a:xfrm>
-            <a:off x="685800" y="2148840"/>
-            <a:ext cx="3337560" cy="1600200"/>
+            <a:off x="731520" y="2103120"/>
+            <a:ext cx="3017520" cy="1627632"/>
           </a:xfrm>
           <a:prstGeom prst="rect">
             <a:avLst/>
@@ -10727,8 +12472,8 @@
         </p:nvSpPr>
         <p:spPr>
           <a:xfrm>
-            <a:off x="868680" y="2377440"/>
-            <a:ext cx="2971800" cy="548640"/>
+            <a:off x="868680" y="2322576"/>
+            <a:ext cx="2743200" cy="640080"/>
           </a:xfrm>
           <a:prstGeom prst="rect">
             <a:avLst/>
@@ -10747,7 +12492,7 @@
               </a:spcAft>
             </a:pPr>
             <a:r>
-              <a:rPr sz="2900" b="1">
+              <a:rPr sz="2600" b="1">
                 <a:solidFill>
                   <a:srgbClr val="244BDD"/>
                 </a:solidFill>
@@ -10766,8 +12511,8 @@
         </p:nvSpPr>
         <p:spPr>
           <a:xfrm>
-            <a:off x="868680" y="3026664"/>
-            <a:ext cx="2971800" cy="548640"/>
+            <a:off x="868680" y="3044952"/>
+            <a:ext cx="2743200" cy="594360"/>
           </a:xfrm>
           <a:prstGeom prst="rect">
             <a:avLst/>
@@ -10786,13 +12531,13 @@
               </a:spcAft>
             </a:pPr>
             <a:r>
-              <a:rPr sz="2300" b="0">
+              <a:rPr sz="2200" b="0">
                 <a:solidFill>
                   <a:srgbClr val="182636"/>
                 </a:solidFill>
                 <a:latin typeface="Aptos"/>
               </a:rPr>
-              <a:t>Textul de pana acum</a:t>
+              <a:t>"La biblioteca am..."</a:t>
             </a:r>
           </a:p>
         </p:txBody>
@@ -10805,8 +12550,8 @@
         </p:nvSpPr>
         <p:spPr>
           <a:xfrm>
-            <a:off x="4434840" y="2148840"/>
-            <a:ext cx="3337560" cy="1600200"/>
+            <a:off x="4572000" y="2103120"/>
+            <a:ext cx="3017520" cy="1627632"/>
           </a:xfrm>
           <a:prstGeom prst="rect">
             <a:avLst/>
@@ -10848,8 +12593,8 @@
         </p:nvSpPr>
         <p:spPr>
           <a:xfrm>
-            <a:off x="4617720" y="2377440"/>
-            <a:ext cx="2971800" cy="548640"/>
+            <a:off x="4709160" y="2322576"/>
+            <a:ext cx="2743200" cy="640080"/>
           </a:xfrm>
           <a:prstGeom prst="rect">
             <a:avLst/>
@@ -10868,13 +12613,13 @@
               </a:spcAft>
             </a:pPr>
             <a:r>
-              <a:rPr sz="2900" b="1">
+              <a:rPr sz="2600" b="1">
                 <a:solidFill>
                   <a:srgbClr val="244BDD"/>
                 </a:solidFill>
                 <a:latin typeface="Aptos"/>
               </a:rPr>
-              <a:t>Posibilitati</a:t>
+              <a:t>Continuari posibile</a:t>
             </a:r>
           </a:p>
         </p:txBody>
@@ -10887,8 +12632,8 @@
         </p:nvSpPr>
         <p:spPr>
           <a:xfrm>
-            <a:off x="4617720" y="3026664"/>
-            <a:ext cx="2971800" cy="548640"/>
+            <a:off x="4709160" y="3044952"/>
+            <a:ext cx="2743200" cy="594360"/>
           </a:xfrm>
           <a:prstGeom prst="rect">
             <a:avLst/>
@@ -10907,13 +12652,13 @@
               </a:spcAft>
             </a:pPr>
             <a:r>
-              <a:rPr sz="2300" b="0">
+              <a:rPr sz="2200" b="0">
                 <a:solidFill>
                   <a:srgbClr val="182636"/>
                 </a:solidFill>
                 <a:latin typeface="Aptos"/>
               </a:rPr>
-              <a:t>Continuari posibile</a:t>
+              <a:t>Modelul evalueaza variante.</a:t>
             </a:r>
           </a:p>
         </p:txBody>
@@ -10926,8 +12671,8 @@
         </p:nvSpPr>
         <p:spPr>
           <a:xfrm>
-            <a:off x="8183879" y="2148840"/>
-            <a:ext cx="3337560" cy="1600200"/>
+            <a:off x="8412480" y="2103120"/>
+            <a:ext cx="3017520" cy="1627632"/>
           </a:xfrm>
           <a:prstGeom prst="rect">
             <a:avLst/>
@@ -10969,8 +12714,8 @@
         </p:nvSpPr>
         <p:spPr>
           <a:xfrm>
-            <a:off x="8366759" y="2377440"/>
-            <a:ext cx="2971800" cy="548640"/>
+            <a:off x="8549640" y="2322576"/>
+            <a:ext cx="2743200" cy="640080"/>
           </a:xfrm>
           <a:prstGeom prst="rect">
             <a:avLst/>
@@ -10989,13 +12734,13 @@
               </a:spcAft>
             </a:pPr>
             <a:r>
-              <a:rPr sz="2900" b="1">
+              <a:rPr sz="2600" b="1">
                 <a:solidFill>
                   <a:srgbClr val="244BDD"/>
                 </a:solidFill>
                 <a:latin typeface="Aptos"/>
               </a:rPr>
-              <a:t>Alegere</a:t>
+              <a:t>Token nou</a:t>
             </a:r>
           </a:p>
         </p:txBody>
@@ -11008,8 +12753,8 @@
         </p:nvSpPr>
         <p:spPr>
           <a:xfrm>
-            <a:off x="8366759" y="3026664"/>
-            <a:ext cx="2971800" cy="548640"/>
+            <a:off x="8549640" y="3044952"/>
+            <a:ext cx="2743200" cy="594360"/>
           </a:xfrm>
           <a:prstGeom prst="rect">
             <a:avLst/>
@@ -11028,27 +12773,371 @@
               </a:spcAft>
             </a:pPr>
             <a:r>
-              <a:rPr sz="2300" b="0">
+              <a:rPr sz="2200" b="0">
                 <a:solidFill>
                   <a:srgbClr val="182636"/>
                 </a:solidFill>
                 <a:latin typeface="Aptos"/>
               </a:rPr>
-              <a:t>Un token nou</a:t>
-            </a:r>
-          </a:p>
-        </p:txBody>
-      </p:sp>
-      <p:sp>
-        <p:nvSpPr>
-          <p:cNvPr id="15" name="TextBox 14"/>
+              <a:t>"deschis"</a:t>
+            </a:r>
+          </a:p>
+        </p:txBody>
+      </p:sp>
+      <p:sp>
+        <p:nvSpPr>
+          <p:cNvPr id="15" name="Rectangle 14"/>
+          <p:cNvSpPr/>
+          <p:nvPr/>
+        </p:nvSpPr>
+        <p:spPr>
+          <a:xfrm>
+            <a:off x="3858768" y="2835148"/>
+            <a:ext cx="548640" cy="35560"/>
+          </a:xfrm>
+          <a:prstGeom prst="rect">
+            <a:avLst/>
+          </a:prstGeom>
+          <a:solidFill>
+            <a:srgbClr val="244BDD"/>
+          </a:solidFill>
+          <a:ln>
+            <a:noFill/>
+          </a:ln>
+        </p:spPr>
+        <p:style>
+          <a:lnRef idx="1">
+            <a:schemeClr val="accent1"/>
+          </a:lnRef>
+          <a:fillRef idx="3">
+            <a:schemeClr val="accent1"/>
+          </a:fillRef>
+          <a:effectRef idx="2">
+            <a:schemeClr val="accent1"/>
+          </a:effectRef>
+          <a:fontRef idx="minor">
+            <a:schemeClr val="lt1"/>
+          </a:fontRef>
+        </p:style>
+        <p:txBody>
+          <a:bodyPr rtlCol="0" anchor="ctr"/>
+          <a:lstStyle/>
+          <a:p>
+            <a:pPr algn="ctr"/>
+          </a:p>
+        </p:txBody>
+      </p:sp>
+      <p:sp>
+        <p:nvSpPr>
+          <p:cNvPr id="16" name="Isosceles Triangle 15"/>
+          <p:cNvSpPr/>
+          <p:nvPr/>
+        </p:nvSpPr>
+        <p:spPr>
+          <a:xfrm rot="5400000">
+            <a:off x="4325112" y="2770632"/>
+            <a:ext cx="164592" cy="164592"/>
+          </a:xfrm>
+          <a:prstGeom prst="triangle">
+            <a:avLst/>
+          </a:prstGeom>
+          <a:solidFill>
+            <a:srgbClr val="244BDD"/>
+          </a:solidFill>
+          <a:ln>
+            <a:noFill/>
+          </a:ln>
+        </p:spPr>
+        <p:style>
+          <a:lnRef idx="1">
+            <a:schemeClr val="accent1"/>
+          </a:lnRef>
+          <a:fillRef idx="3">
+            <a:schemeClr val="accent1"/>
+          </a:fillRef>
+          <a:effectRef idx="2">
+            <a:schemeClr val="accent1"/>
+          </a:effectRef>
+          <a:fontRef idx="minor">
+            <a:schemeClr val="lt1"/>
+          </a:fontRef>
+        </p:style>
+        <p:txBody>
+          <a:bodyPr rtlCol="0" anchor="ctr"/>
+          <a:lstStyle/>
+          <a:p>
+            <a:pPr algn="ctr"/>
+          </a:p>
+        </p:txBody>
+      </p:sp>
+      <p:sp>
+        <p:nvSpPr>
+          <p:cNvPr id="17" name="Rectangle 16"/>
+          <p:cNvSpPr/>
+          <p:nvPr/>
+        </p:nvSpPr>
+        <p:spPr>
+          <a:xfrm>
+            <a:off x="7699248" y="2835148"/>
+            <a:ext cx="548639" cy="35560"/>
+          </a:xfrm>
+          <a:prstGeom prst="rect">
+            <a:avLst/>
+          </a:prstGeom>
+          <a:solidFill>
+            <a:srgbClr val="244BDD"/>
+          </a:solidFill>
+          <a:ln>
+            <a:noFill/>
+          </a:ln>
+        </p:spPr>
+        <p:style>
+          <a:lnRef idx="1">
+            <a:schemeClr val="accent1"/>
+          </a:lnRef>
+          <a:fillRef idx="3">
+            <a:schemeClr val="accent1"/>
+          </a:fillRef>
+          <a:effectRef idx="2">
+            <a:schemeClr val="accent1"/>
+          </a:effectRef>
+          <a:fontRef idx="minor">
+            <a:schemeClr val="lt1"/>
+          </a:fontRef>
+        </p:style>
+        <p:txBody>
+          <a:bodyPr rtlCol="0" anchor="ctr"/>
+          <a:lstStyle/>
+          <a:p>
+            <a:pPr algn="ctr"/>
+          </a:p>
+        </p:txBody>
+      </p:sp>
+      <p:sp>
+        <p:nvSpPr>
+          <p:cNvPr id="18" name="Isosceles Triangle 17"/>
+          <p:cNvSpPr/>
+          <p:nvPr/>
+        </p:nvSpPr>
+        <p:spPr>
+          <a:xfrm rot="5400000">
+            <a:off x="8165592" y="2770632"/>
+            <a:ext cx="164592" cy="164592"/>
+          </a:xfrm>
+          <a:prstGeom prst="triangle">
+            <a:avLst/>
+          </a:prstGeom>
+          <a:solidFill>
+            <a:srgbClr val="244BDD"/>
+          </a:solidFill>
+          <a:ln>
+            <a:noFill/>
+          </a:ln>
+        </p:spPr>
+        <p:style>
+          <a:lnRef idx="1">
+            <a:schemeClr val="accent1"/>
+          </a:lnRef>
+          <a:fillRef idx="3">
+            <a:schemeClr val="accent1"/>
+          </a:fillRef>
+          <a:effectRef idx="2">
+            <a:schemeClr val="accent1"/>
+          </a:effectRef>
+          <a:fontRef idx="minor">
+            <a:schemeClr val="lt1"/>
+          </a:fontRef>
+        </p:style>
+        <p:txBody>
+          <a:bodyPr rtlCol="0" anchor="ctr"/>
+          <a:lstStyle/>
+          <a:p>
+            <a:pPr algn="ctr"/>
+          </a:p>
+        </p:txBody>
+      </p:sp>
+      <p:sp>
+        <p:nvSpPr>
+          <p:cNvPr id="19" name="Rectangle 18"/>
+          <p:cNvSpPr/>
+          <p:nvPr/>
+        </p:nvSpPr>
+        <p:spPr>
+          <a:xfrm>
+            <a:off x="9903460" y="3822191"/>
+            <a:ext cx="35560" cy="612647"/>
+          </a:xfrm>
+          <a:prstGeom prst="rect">
+            <a:avLst/>
+          </a:prstGeom>
+          <a:solidFill>
+            <a:srgbClr val="244BDD"/>
+          </a:solidFill>
+          <a:ln>
+            <a:noFill/>
+          </a:ln>
+        </p:spPr>
+        <p:style>
+          <a:lnRef idx="1">
+            <a:schemeClr val="accent1"/>
+          </a:lnRef>
+          <a:fillRef idx="3">
+            <a:schemeClr val="accent1"/>
+          </a:fillRef>
+          <a:effectRef idx="2">
+            <a:schemeClr val="accent1"/>
+          </a:effectRef>
+          <a:fontRef idx="minor">
+            <a:schemeClr val="lt1"/>
+          </a:fontRef>
+        </p:style>
+        <p:txBody>
+          <a:bodyPr rtlCol="0" anchor="ctr"/>
+          <a:lstStyle/>
+          <a:p>
+            <a:pPr algn="ctr"/>
+          </a:p>
+        </p:txBody>
+      </p:sp>
+      <p:sp>
+        <p:nvSpPr>
+          <p:cNvPr id="20" name="Rectangle 19"/>
+          <p:cNvSpPr/>
+          <p:nvPr/>
+        </p:nvSpPr>
+        <p:spPr>
+          <a:xfrm>
+            <a:off x="7680960" y="4417059"/>
+            <a:ext cx="2240279" cy="35560"/>
+          </a:xfrm>
+          <a:prstGeom prst="rect">
+            <a:avLst/>
+          </a:prstGeom>
+          <a:solidFill>
+            <a:srgbClr val="244BDD"/>
+          </a:solidFill>
+          <a:ln>
+            <a:noFill/>
+          </a:ln>
+        </p:spPr>
+        <p:style>
+          <a:lnRef idx="1">
+            <a:schemeClr val="accent1"/>
+          </a:lnRef>
+          <a:fillRef idx="3">
+            <a:schemeClr val="accent1"/>
+          </a:fillRef>
+          <a:effectRef idx="2">
+            <a:schemeClr val="accent1"/>
+          </a:effectRef>
+          <a:fontRef idx="minor">
+            <a:schemeClr val="lt1"/>
+          </a:fontRef>
+        </p:style>
+        <p:txBody>
+          <a:bodyPr rtlCol="0" anchor="ctr"/>
+          <a:lstStyle/>
+          <a:p>
+            <a:pPr algn="ctr"/>
+          </a:p>
+        </p:txBody>
+      </p:sp>
+      <p:sp>
+        <p:nvSpPr>
+          <p:cNvPr id="21" name="Isosceles Triangle 20"/>
+          <p:cNvSpPr/>
+          <p:nvPr/>
+        </p:nvSpPr>
+        <p:spPr>
+          <a:xfrm rot="16200000">
+            <a:off x="7598664" y="4352544"/>
+            <a:ext cx="164592" cy="164592"/>
+          </a:xfrm>
+          <a:prstGeom prst="triangle">
+            <a:avLst/>
+          </a:prstGeom>
+          <a:solidFill>
+            <a:srgbClr val="244BDD"/>
+          </a:solidFill>
+          <a:ln>
+            <a:noFill/>
+          </a:ln>
+        </p:spPr>
+        <p:style>
+          <a:lnRef idx="1">
+            <a:schemeClr val="accent1"/>
+          </a:lnRef>
+          <a:fillRef idx="3">
+            <a:schemeClr val="accent1"/>
+          </a:fillRef>
+          <a:effectRef idx="2">
+            <a:schemeClr val="accent1"/>
+          </a:effectRef>
+          <a:fontRef idx="minor">
+            <a:schemeClr val="lt1"/>
+          </a:fontRef>
+        </p:style>
+        <p:txBody>
+          <a:bodyPr rtlCol="0" anchor="ctr"/>
+          <a:lstStyle/>
+          <a:p>
+            <a:pPr algn="ctr"/>
+          </a:p>
+        </p:txBody>
+      </p:sp>
+      <p:sp>
+        <p:nvSpPr>
+          <p:cNvPr id="22" name="Rectangle 21"/>
+          <p:cNvSpPr/>
+          <p:nvPr/>
+        </p:nvSpPr>
+        <p:spPr>
+          <a:xfrm>
+            <a:off x="3794760" y="3913632"/>
+            <a:ext cx="3767328" cy="1261872"/>
+          </a:xfrm>
+          <a:prstGeom prst="rect">
+            <a:avLst/>
+          </a:prstGeom>
+          <a:solidFill>
+            <a:srgbClr val="244BDD"/>
+          </a:solidFill>
+          <a:ln>
+            <a:noFill/>
+          </a:ln>
+        </p:spPr>
+        <p:style>
+          <a:lnRef idx="1">
+            <a:schemeClr val="accent1"/>
+          </a:lnRef>
+          <a:fillRef idx="3">
+            <a:schemeClr val="accent1"/>
+          </a:fillRef>
+          <a:effectRef idx="2">
+            <a:schemeClr val="accent1"/>
+          </a:effectRef>
+          <a:fontRef idx="minor">
+            <a:schemeClr val="lt1"/>
+          </a:fontRef>
+        </p:style>
+        <p:txBody>
+          <a:bodyPr rtlCol="0" anchor="ctr"/>
+          <a:lstStyle/>
+          <a:p>
+            <a:pPr algn="ctr"/>
+          </a:p>
+        </p:txBody>
+      </p:sp>
+      <p:sp>
+        <p:nvSpPr>
+          <p:cNvPr id="23" name="TextBox 22"/>
           <p:cNvSpPr txBox="1"/>
           <p:nvPr/>
         </p:nvSpPr>
         <p:spPr>
           <a:xfrm>
-            <a:off x="822960" y="4050791"/>
-            <a:ext cx="10515600" cy="502920"/>
+            <a:off x="3959352" y="4050791"/>
+            <a:ext cx="3438144" cy="393192"/>
           </a:xfrm>
           <a:prstGeom prst="rect">
             <a:avLst/>
@@ -11069,25 +13158,25 @@
             <a:r>
               <a:rPr sz="2500" b="1">
                 <a:solidFill>
-                  <a:srgbClr val="182636"/>
-                </a:solidFill>
-                <a:latin typeface="Aptos"/>
-              </a:rPr>
-              <a:t>"La biblioteca..."  &gt;  "...am deschis"  &gt;  "...un laptop"</a:t>
-            </a:r>
-          </a:p>
-        </p:txBody>
-      </p:sp>
-      <p:sp>
-        <p:nvSpPr>
-          <p:cNvPr id="16" name="TextBox 15"/>
+                  <a:srgbClr val="FFFFFF"/>
+                </a:solidFill>
+                <a:latin typeface="Aptos"/>
+              </a:rPr>
+              <a:t>Context actualizat</a:t>
+            </a:r>
+          </a:p>
+        </p:txBody>
+      </p:sp>
+      <p:sp>
+        <p:nvSpPr>
+          <p:cNvPr id="24" name="TextBox 23"/>
           <p:cNvSpPr txBox="1"/>
           <p:nvPr/>
         </p:nvSpPr>
         <p:spPr>
           <a:xfrm>
-            <a:off x="822960" y="4773168"/>
-            <a:ext cx="10515600" cy="594360"/>
+            <a:off x="3959352" y="4581144"/>
+            <a:ext cx="3438144" cy="411480"/>
           </a:xfrm>
           <a:prstGeom prst="rect">
             <a:avLst/>
@@ -11106,27 +13195,156 @@
               </a:spcAft>
             </a:pPr>
             <a:r>
-              <a:rPr sz="2800" b="1">
-                <a:solidFill>
-                  <a:srgbClr val="244BDD"/>
-                </a:solidFill>
-                <a:latin typeface="Aptos"/>
-              </a:rPr>
-              <a:t>Textul nou intra in context. Procesul continua.</a:t>
-            </a:r>
-          </a:p>
-        </p:txBody>
-      </p:sp>
-      <p:sp>
-        <p:nvSpPr>
-          <p:cNvPr id="17" name="TextBox 16"/>
+              <a:rPr sz="2000" b="0">
+                <a:solidFill>
+                  <a:srgbClr val="FFFFFF"/>
+                </a:solidFill>
+                <a:latin typeface="Aptos"/>
+              </a:rPr>
+              <a:t>"La biblioteca am deschis..."</a:t>
+            </a:r>
+          </a:p>
+        </p:txBody>
+      </p:sp>
+      <p:sp>
+        <p:nvSpPr>
+          <p:cNvPr id="25" name="Rectangle 24"/>
+          <p:cNvSpPr/>
+          <p:nvPr/>
+        </p:nvSpPr>
+        <p:spPr>
+          <a:xfrm>
+            <a:off x="2240280" y="4417059"/>
+            <a:ext cx="1435607" cy="35560"/>
+          </a:xfrm>
+          <a:prstGeom prst="rect">
+            <a:avLst/>
+          </a:prstGeom>
+          <a:solidFill>
+            <a:srgbClr val="244BDD"/>
+          </a:solidFill>
+          <a:ln>
+            <a:noFill/>
+          </a:ln>
+        </p:spPr>
+        <p:style>
+          <a:lnRef idx="1">
+            <a:schemeClr val="accent1"/>
+          </a:lnRef>
+          <a:fillRef idx="3">
+            <a:schemeClr val="accent1"/>
+          </a:fillRef>
+          <a:effectRef idx="2">
+            <a:schemeClr val="accent1"/>
+          </a:effectRef>
+          <a:fontRef idx="minor">
+            <a:schemeClr val="lt1"/>
+          </a:fontRef>
+        </p:style>
+        <p:txBody>
+          <a:bodyPr rtlCol="0" anchor="ctr"/>
+          <a:lstStyle/>
+          <a:p>
+            <a:pPr algn="ctr"/>
+          </a:p>
+        </p:txBody>
+      </p:sp>
+      <p:sp>
+        <p:nvSpPr>
+          <p:cNvPr id="26" name="Rectangle 25"/>
+          <p:cNvSpPr/>
+          <p:nvPr/>
+        </p:nvSpPr>
+        <p:spPr>
+          <a:xfrm>
+            <a:off x="2222500" y="3822191"/>
+            <a:ext cx="35560" cy="612647"/>
+          </a:xfrm>
+          <a:prstGeom prst="rect">
+            <a:avLst/>
+          </a:prstGeom>
+          <a:solidFill>
+            <a:srgbClr val="244BDD"/>
+          </a:solidFill>
+          <a:ln>
+            <a:noFill/>
+          </a:ln>
+        </p:spPr>
+        <p:style>
+          <a:lnRef idx="1">
+            <a:schemeClr val="accent1"/>
+          </a:lnRef>
+          <a:fillRef idx="3">
+            <a:schemeClr val="accent1"/>
+          </a:fillRef>
+          <a:effectRef idx="2">
+            <a:schemeClr val="accent1"/>
+          </a:effectRef>
+          <a:fontRef idx="minor">
+            <a:schemeClr val="lt1"/>
+          </a:fontRef>
+        </p:style>
+        <p:txBody>
+          <a:bodyPr rtlCol="0" anchor="ctr"/>
+          <a:lstStyle/>
+          <a:p>
+            <a:pPr algn="ctr"/>
+          </a:p>
+        </p:txBody>
+      </p:sp>
+      <p:sp>
+        <p:nvSpPr>
+          <p:cNvPr id="27" name="Isosceles Triangle 26"/>
+          <p:cNvSpPr/>
+          <p:nvPr/>
+        </p:nvSpPr>
+        <p:spPr>
+          <a:xfrm>
+            <a:off x="2157984" y="3739896"/>
+            <a:ext cx="164592" cy="164592"/>
+          </a:xfrm>
+          <a:prstGeom prst="triangle">
+            <a:avLst/>
+          </a:prstGeom>
+          <a:solidFill>
+            <a:srgbClr val="244BDD"/>
+          </a:solidFill>
+          <a:ln>
+            <a:noFill/>
+          </a:ln>
+        </p:spPr>
+        <p:style>
+          <a:lnRef idx="1">
+            <a:schemeClr val="accent1"/>
+          </a:lnRef>
+          <a:fillRef idx="3">
+            <a:schemeClr val="accent1"/>
+          </a:fillRef>
+          <a:effectRef idx="2">
+            <a:schemeClr val="accent1"/>
+          </a:effectRef>
+          <a:fontRef idx="minor">
+            <a:schemeClr val="lt1"/>
+          </a:fontRef>
+        </p:style>
+        <p:txBody>
+          <a:bodyPr rtlCol="0" anchor="ctr"/>
+          <a:lstStyle/>
+          <a:p>
+            <a:pPr algn="ctr"/>
+          </a:p>
+        </p:txBody>
+      </p:sp>
+      <p:sp>
+        <p:nvSpPr>
+          <p:cNvPr id="28" name="TextBox 27"/>
           <p:cNvSpPr txBox="1"/>
           <p:nvPr/>
         </p:nvSpPr>
         <p:spPr>
           <a:xfrm>
-            <a:off x="822960" y="5605272"/>
-            <a:ext cx="10515600" cy="448056"/>
+            <a:off x="777240" y="5687568"/>
+            <a:ext cx="10515600" cy="411480"/>
           </a:xfrm>
           <a:prstGeom prst="rect">
             <a:avLst/>
@@ -11145,13 +13363,13 @@
               </a:spcAft>
             </a:pPr>
             <a:r>
-              <a:rPr sz="2200" b="0">
+              <a:rPr sz="2500" b="1">
                 <a:solidFill>
                   <a:srgbClr val="182636"/>
                 </a:solidFill>
                 <a:latin typeface="Aptos"/>
               </a:rPr>
-              <a:t>Antrenare + invatarea cerintelor + instrumente = mai multe posibilitati</a:t>
+              <a:t>Un token este un fragment de text. Procesul se repeta.</a:t>
             </a:r>
           </a:p>
         </p:txBody>
@@ -11344,7 +13562,7 @@
       </p:sp>
       <p:pic>
         <p:nvPicPr>
-          <p:cNvPr id="6" name="Picture 5" descr="Captura reala a exemplului local pregatit Atelier de idei, eveniment fictiv; nu este output live Copilot."/>
+          <p:cNvPr id="6" name="Picture 5" descr="Captura decupata a paginii pregatite Atelier de idei, cu titlul si ilustratia; nu este output live din Copilot."/>
           <p:cNvPicPr>
             <a:picLocks noChangeAspect="1"/>
           </p:cNvPicPr>
@@ -11358,8 +13576,8 @@
         </p:blipFill>
         <p:spPr>
           <a:xfrm>
-            <a:off x="1138843" y="1783080"/>
-            <a:ext cx="6317672" cy="4343400"/>
+            <a:off x="693911" y="1801368"/>
+            <a:ext cx="6796056" cy="2743200"/>
           </a:xfrm>
           <a:prstGeom prst="rect">
             <a:avLst/>
@@ -11374,8 +13592,8 @@
         </p:nvSpPr>
         <p:spPr>
           <a:xfrm>
-            <a:off x="8257031" y="1947672"/>
-            <a:ext cx="3246120" cy="1005840"/>
+            <a:off x="7909560" y="2029968"/>
+            <a:ext cx="3566160" cy="2121408"/>
           </a:xfrm>
           <a:prstGeom prst="rect">
             <a:avLst/>
@@ -11394,43 +13612,83 @@
               </a:spcAft>
             </a:pPr>
             <a:r>
-              <a:rPr sz="2800" b="1">
-                <a:solidFill>
-                  <a:srgbClr val="182636"/>
-                </a:solidFill>
-                <a:latin typeface="Aptos"/>
-              </a:rPr>
-              <a:t>Un eveniment</a:t>
-            </a:r>
-          </a:p>
-          <a:p>
-            <a:pPr>
-              <a:spcAft>
-                <a:spcPts val="800"/>
-              </a:spcAft>
-            </a:pPr>
-            <a:r>
-              <a:rPr sz="2800" b="1">
-                <a:solidFill>
-                  <a:srgbClr val="182636"/>
-                </a:solidFill>
-                <a:latin typeface="Aptos"/>
-              </a:rPr>
-              <a:t>pentru liceeni.</a:t>
-            </a:r>
-          </a:p>
-        </p:txBody>
-      </p:sp>
-      <p:sp>
-        <p:nvSpPr>
-          <p:cNvPr id="8" name="TextBox 7"/>
+              <a:rPr sz="2700" b="1">
+                <a:solidFill>
+                  <a:srgbClr val="244BDD"/>
+                </a:solidFill>
+                <a:latin typeface="Aptos"/>
+              </a:rPr>
+              <a:t>Ce trebuie sa afli</a:t>
+            </a:r>
+          </a:p>
+          <a:p>
+            <a:pPr>
+              <a:spcAft>
+                <a:spcPts val="800"/>
+              </a:spcAft>
+            </a:pPr>
+            <a:r>
+              <a:rPr sz="2700" b="1">
+                <a:solidFill>
+                  <a:srgbClr val="244BDD"/>
+                </a:solidFill>
+                <a:latin typeface="Aptos"/>
+              </a:rPr>
+              <a:t>ca sa decizi daca</a:t>
+            </a:r>
+          </a:p>
+          <a:p>
+            <a:pPr>
+              <a:spcAft>
+                <a:spcPts val="800"/>
+              </a:spcAft>
+            </a:pPr>
+            <a:r>
+              <a:rPr sz="2700" b="1">
+                <a:solidFill>
+                  <a:srgbClr val="244BDD"/>
+                </a:solidFill>
+                <a:latin typeface="Aptos"/>
+              </a:rPr>
+              <a:t>vrei sa participi?</a:t>
+            </a:r>
+          </a:p>
+        </p:txBody>
+      </p:sp>
+      <p:pic>
+        <p:nvPicPr>
+          <p:cNvPr id="8" name="Picture 7" descr="Detalii din acelasi exemplu fictiv, marite: 30 octombrie 2026, 17-19, sala de festivitati, acces gratuit."/>
+          <p:cNvPicPr>
+            <a:picLocks noChangeAspect="1"/>
+          </p:cNvPicPr>
+          <p:nvPr/>
+        </p:nvPicPr>
+        <p:blipFill>
+          <a:blip r:embed="rId3"/>
+          <a:stretch>
+            <a:fillRect/>
+          </a:stretch>
+        </p:blipFill>
+        <p:spPr>
+          <a:xfrm>
+            <a:off x="731520" y="4619169"/>
+            <a:ext cx="10698480" cy="1304692"/>
+          </a:xfrm>
+          <a:prstGeom prst="rect">
+            <a:avLst/>
+          </a:prstGeom>
+        </p:spPr>
+      </p:pic>
+      <p:sp>
+        <p:nvSpPr>
+          <p:cNvPr id="9" name="TextBox 8"/>
           <p:cNvSpPr txBox="1"/>
           <p:nvPr/>
         </p:nvSpPr>
         <p:spPr>
           <a:xfrm>
-            <a:off x="8257031" y="3337560"/>
-            <a:ext cx="3246120" cy="1783080"/>
+            <a:off x="731520" y="5989320"/>
+            <a:ext cx="10424160" cy="256032"/>
           </a:xfrm>
           <a:prstGeom prst="rect">
             <a:avLst/>
@@ -11449,100 +13707,13 @@
               </a:spcAft>
             </a:pPr>
             <a:r>
-              <a:rPr sz="2500" b="1">
-                <a:solidFill>
-                  <a:srgbClr val="244BDD"/>
-                </a:solidFill>
-                <a:latin typeface="Aptos"/>
-              </a:rPr>
-              <a:t>Ce trebuie sa afli</a:t>
-            </a:r>
-          </a:p>
-          <a:p>
-            <a:pPr>
-              <a:spcAft>
-                <a:spcPts val="800"/>
-              </a:spcAft>
-            </a:pPr>
-            <a:r>
-              <a:rPr sz="2500" b="1">
-                <a:solidFill>
-                  <a:srgbClr val="244BDD"/>
-                </a:solidFill>
-                <a:latin typeface="Aptos"/>
-              </a:rPr>
-              <a:t>ca sa decizi daca</a:t>
-            </a:r>
-          </a:p>
-          <a:p>
-            <a:pPr>
-              <a:spcAft>
-                <a:spcPts val="800"/>
-              </a:spcAft>
-            </a:pPr>
-            <a:r>
-              <a:rPr sz="2500" b="1">
-                <a:solidFill>
-                  <a:srgbClr val="244BDD"/>
-                </a:solidFill>
-                <a:latin typeface="Aptos"/>
-              </a:rPr>
-              <a:t>vrei sa participi?</a:t>
-            </a:r>
-          </a:p>
-        </p:txBody>
-      </p:sp>
-      <p:sp>
-        <p:nvSpPr>
-          <p:cNvPr id="9" name="TextBox 8"/>
-          <p:cNvSpPr txBox="1"/>
-          <p:nvPr/>
-        </p:nvSpPr>
-        <p:spPr>
-          <a:xfrm>
-            <a:off x="8257031" y="5349240"/>
-            <a:ext cx="3246120" cy="603504"/>
-          </a:xfrm>
-          <a:prstGeom prst="rect">
-            <a:avLst/>
-          </a:prstGeom>
-          <a:noFill/>
-        </p:spPr>
-        <p:txBody>
-          <a:bodyPr wrap="square" lIns="22860" rIns="22860" tIns="22860" bIns="22860">
-            <a:spAutoFit/>
-          </a:bodyPr>
-          <a:lstStyle/>
-          <a:p>
-            <a:pPr>
-              <a:spcAft>
-                <a:spcPts val="800"/>
-              </a:spcAft>
-            </a:pPr>
-            <a:r>
-              <a:rPr sz="1600" b="0">
+              <a:rPr sz="1500" b="0">
                 <a:solidFill>
                   <a:srgbClr val="526176"/>
                 </a:solidFill>
                 <a:latin typeface="Aptos"/>
               </a:rPr>
-              <a:t>Exemplu fictiv,</a:t>
-            </a:r>
-          </a:p>
-          <a:p>
-            <a:pPr>
-              <a:spcAft>
-                <a:spcPts val="800"/>
-              </a:spcAft>
-            </a:pPr>
-            <a:r>
-              <a:rPr sz="1600" b="0">
-                <a:solidFill>
-                  <a:srgbClr val="526176"/>
-                </a:solidFill>
-                <a:latin typeface="Aptos"/>
-              </a:rPr>
-              <a:t>pregatit local.</a:t>
+              <a:t>Capturi ale exemplului pregatit, cu detaliile marite. Eveniment fictiv.</a:t>
             </a:r>
           </a:p>
         </p:txBody>
@@ -12593,8 +14764,8 @@
         </p:nvSpPr>
         <p:spPr>
           <a:xfrm>
-            <a:off x="777240" y="1938528"/>
-            <a:ext cx="3794760" cy="594360"/>
+            <a:off x="777240" y="2057400"/>
+            <a:ext cx="3657600" cy="731520"/>
           </a:xfrm>
           <a:prstGeom prst="rect">
             <a:avLst/>
@@ -12613,7 +14784,7 @@
               </a:spcAft>
             </a:pPr>
             <a:r>
-              <a:rPr sz="2700" b="1">
+              <a:rPr sz="2600" b="1">
                 <a:solidFill>
                   <a:srgbClr val="D6EC79"/>
                 </a:solidFill>
@@ -12626,14 +14797,57 @@
       </p:sp>
       <p:sp>
         <p:nvSpPr>
-          <p:cNvPr id="7" name="TextBox 6"/>
+          <p:cNvPr id="7" name="Rectangle 6"/>
+          <p:cNvSpPr/>
+          <p:nvPr/>
+        </p:nvSpPr>
+        <p:spPr>
+          <a:xfrm>
+            <a:off x="4709160" y="1901952"/>
+            <a:ext cx="2487168" cy="1060704"/>
+          </a:xfrm>
+          <a:prstGeom prst="rect">
+            <a:avLst/>
+          </a:prstGeom>
+          <a:solidFill>
+            <a:srgbClr val="263B51"/>
+          </a:solidFill>
+          <a:ln>
+            <a:noFill/>
+          </a:ln>
+        </p:spPr>
+        <p:style>
+          <a:lnRef idx="1">
+            <a:schemeClr val="accent1"/>
+          </a:lnRef>
+          <a:fillRef idx="3">
+            <a:schemeClr val="accent1"/>
+          </a:fillRef>
+          <a:effectRef idx="2">
+            <a:schemeClr val="accent1"/>
+          </a:effectRef>
+          <a:fontRef idx="minor">
+            <a:schemeClr val="lt1"/>
+          </a:fontRef>
+        </p:style>
+        <p:txBody>
+          <a:bodyPr rtlCol="0" anchor="ctr"/>
+          <a:lstStyle/>
+          <a:p>
+            <a:pPr algn="ctr"/>
+          </a:p>
+        </p:txBody>
+      </p:sp>
+      <p:sp>
+        <p:nvSpPr>
+          <p:cNvPr id="8" name="TextBox 7"/>
           <p:cNvSpPr txBox="1"/>
           <p:nvPr/>
         </p:nvSpPr>
         <p:spPr>
           <a:xfrm>
-            <a:off x="4800600" y="1938528"/>
-            <a:ext cx="6492240" cy="877824"/>
+            <a:off x="4846320" y="2139696"/>
+            <a:ext cx="2212848" cy="594360"/>
           </a:xfrm>
           <a:prstGeom prst="rect">
             <a:avLst/>
@@ -12652,27 +14866,113 @@
               </a:spcAft>
             </a:pPr>
             <a:r>
-              <a:rPr sz="2500" b="0">
+              <a:rPr sz="2400" b="1">
                 <a:solidFill>
                   <a:srgbClr val="FFFFFF"/>
                 </a:solidFill>
                 <a:latin typeface="Aptos"/>
               </a:rPr>
-              <a:t>Data, ora, locul si accesul sunt cele stabilite.</a:t>
-            </a:r>
-          </a:p>
-        </p:txBody>
-      </p:sp>
-      <p:sp>
-        <p:nvSpPr>
-          <p:cNvPr id="8" name="TextBox 7"/>
+              <a:t>Cererea</a:t>
+            </a:r>
+          </a:p>
+        </p:txBody>
+      </p:sp>
+      <p:sp>
+        <p:nvSpPr>
+          <p:cNvPr id="9" name="Rectangle 8"/>
+          <p:cNvSpPr/>
+          <p:nvPr/>
+        </p:nvSpPr>
+        <p:spPr>
+          <a:xfrm>
+            <a:off x="7333488" y="2396236"/>
+            <a:ext cx="576072" cy="35560"/>
+          </a:xfrm>
+          <a:prstGeom prst="rect">
+            <a:avLst/>
+          </a:prstGeom>
+          <a:solidFill>
+            <a:srgbClr val="D6EC79"/>
+          </a:solidFill>
+          <a:ln>
+            <a:noFill/>
+          </a:ln>
+        </p:spPr>
+        <p:style>
+          <a:lnRef idx="1">
+            <a:schemeClr val="accent1"/>
+          </a:lnRef>
+          <a:fillRef idx="3">
+            <a:schemeClr val="accent1"/>
+          </a:fillRef>
+          <a:effectRef idx="2">
+            <a:schemeClr val="accent1"/>
+          </a:effectRef>
+          <a:fontRef idx="minor">
+            <a:schemeClr val="lt1"/>
+          </a:fontRef>
+        </p:style>
+        <p:txBody>
+          <a:bodyPr rtlCol="0" anchor="ctr"/>
+          <a:lstStyle/>
+          <a:p>
+            <a:pPr algn="ctr"/>
+          </a:p>
+        </p:txBody>
+      </p:sp>
+      <p:sp>
+        <p:nvSpPr>
+          <p:cNvPr id="10" name="Isosceles Triangle 9"/>
+          <p:cNvSpPr/>
+          <p:nvPr/>
+        </p:nvSpPr>
+        <p:spPr>
+          <a:xfrm rot="5400000">
+            <a:off x="7827264" y="2331720"/>
+            <a:ext cx="164592" cy="164592"/>
+          </a:xfrm>
+          <a:prstGeom prst="triangle">
+            <a:avLst/>
+          </a:prstGeom>
+          <a:solidFill>
+            <a:srgbClr val="D6EC79"/>
+          </a:solidFill>
+          <a:ln>
+            <a:noFill/>
+          </a:ln>
+        </p:spPr>
+        <p:style>
+          <a:lnRef idx="1">
+            <a:schemeClr val="accent1"/>
+          </a:lnRef>
+          <a:fillRef idx="3">
+            <a:schemeClr val="accent1"/>
+          </a:fillRef>
+          <a:effectRef idx="2">
+            <a:schemeClr val="accent1"/>
+          </a:effectRef>
+          <a:fontRef idx="minor">
+            <a:schemeClr val="lt1"/>
+          </a:fontRef>
+        </p:style>
+        <p:txBody>
+          <a:bodyPr rtlCol="0" anchor="ctr"/>
+          <a:lstStyle/>
+          <a:p>
+            <a:pPr algn="ctr"/>
+          </a:p>
+        </p:txBody>
+      </p:sp>
+      <p:sp>
+        <p:nvSpPr>
+          <p:cNvPr id="11" name="TextBox 10"/>
           <p:cNvSpPr txBox="1"/>
           <p:nvPr/>
         </p:nvSpPr>
         <p:spPr>
           <a:xfrm>
-            <a:off x="777240" y="3172968"/>
-            <a:ext cx="3794760" cy="594360"/>
+            <a:off x="8129016" y="1947672"/>
+            <a:ext cx="3200400" cy="941832"/>
           </a:xfrm>
           <a:prstGeom prst="rect">
             <a:avLst/>
@@ -12691,27 +14991,43 @@
               </a:spcAft>
             </a:pPr>
             <a:r>
-              <a:rPr sz="2700" b="1">
-                <a:solidFill>
-                  <a:srgbClr val="D6EC79"/>
-                </a:solidFill>
-                <a:latin typeface="Aptos"/>
-              </a:rPr>
-              <a:t>Functioneaza?</a:t>
-            </a:r>
-          </a:p>
-        </p:txBody>
-      </p:sp>
-      <p:sp>
-        <p:nvSpPr>
-          <p:cNvPr id="9" name="TextBox 8"/>
+              <a:rPr sz="2400" b="0">
+                <a:solidFill>
+                  <a:srgbClr val="FFFFFF"/>
+                </a:solidFill>
+                <a:latin typeface="Aptos"/>
+              </a:rPr>
+              <a:t>Compara data,</a:t>
+            </a:r>
+          </a:p>
+          <a:p>
+            <a:pPr>
+              <a:spcAft>
+                <a:spcPts val="800"/>
+              </a:spcAft>
+            </a:pPr>
+            <a:r>
+              <a:rPr sz="2400" b="0">
+                <a:solidFill>
+                  <a:srgbClr val="FFFFFF"/>
+                </a:solidFill>
+                <a:latin typeface="Aptos"/>
+              </a:rPr>
+              <a:t>ora si locul.</a:t>
+            </a:r>
+          </a:p>
+        </p:txBody>
+      </p:sp>
+      <p:sp>
+        <p:nvSpPr>
+          <p:cNvPr id="12" name="TextBox 11"/>
           <p:cNvSpPr txBox="1"/>
           <p:nvPr/>
         </p:nvSpPr>
         <p:spPr>
           <a:xfrm>
-            <a:off x="4800600" y="3172968"/>
-            <a:ext cx="6492240" cy="877824"/>
+            <a:off x="777240" y="3401568"/>
+            <a:ext cx="3657600" cy="731520"/>
           </a:xfrm>
           <a:prstGeom prst="rect">
             <a:avLst/>
@@ -12730,27 +15046,70 @@
               </a:spcAft>
             </a:pPr>
             <a:r>
-              <a:rPr sz="2500" b="0">
-                <a:solidFill>
-                  <a:srgbClr val="FFFFFF"/>
-                </a:solidFill>
-                <a:latin typeface="Aptos"/>
-              </a:rPr>
-              <a:t>Butonul ajunge la program. Textul incape pe telefon.</a:t>
-            </a:r>
-          </a:p>
-        </p:txBody>
-      </p:sp>
-      <p:sp>
-        <p:nvSpPr>
-          <p:cNvPr id="10" name="TextBox 9"/>
+              <a:rPr sz="2600" b="1">
+                <a:solidFill>
+                  <a:srgbClr val="D6EC79"/>
+                </a:solidFill>
+                <a:latin typeface="Aptos"/>
+              </a:rPr>
+              <a:t>Functioneaza?</a:t>
+            </a:r>
+          </a:p>
+        </p:txBody>
+      </p:sp>
+      <p:sp>
+        <p:nvSpPr>
+          <p:cNvPr id="13" name="Rectangle 12"/>
+          <p:cNvSpPr/>
+          <p:nvPr/>
+        </p:nvSpPr>
+        <p:spPr>
+          <a:xfrm>
+            <a:off x="4709160" y="3246120"/>
+            <a:ext cx="2487168" cy="1060704"/>
+          </a:xfrm>
+          <a:prstGeom prst="rect">
+            <a:avLst/>
+          </a:prstGeom>
+          <a:solidFill>
+            <a:srgbClr val="263B51"/>
+          </a:solidFill>
+          <a:ln>
+            <a:noFill/>
+          </a:ln>
+        </p:spPr>
+        <p:style>
+          <a:lnRef idx="1">
+            <a:schemeClr val="accent1"/>
+          </a:lnRef>
+          <a:fillRef idx="3">
+            <a:schemeClr val="accent1"/>
+          </a:fillRef>
+          <a:effectRef idx="2">
+            <a:schemeClr val="accent1"/>
+          </a:effectRef>
+          <a:fontRef idx="minor">
+            <a:schemeClr val="lt1"/>
+          </a:fontRef>
+        </p:style>
+        <p:txBody>
+          <a:bodyPr rtlCol="0" anchor="ctr"/>
+          <a:lstStyle/>
+          <a:p>
+            <a:pPr algn="ctr"/>
+          </a:p>
+        </p:txBody>
+      </p:sp>
+      <p:sp>
+        <p:nvSpPr>
+          <p:cNvPr id="14" name="TextBox 13"/>
           <p:cNvSpPr txBox="1"/>
           <p:nvPr/>
         </p:nvSpPr>
         <p:spPr>
           <a:xfrm>
-            <a:off x="777240" y="4407408"/>
-            <a:ext cx="3794760" cy="594360"/>
+            <a:off x="4846320" y="3483863"/>
+            <a:ext cx="2212848" cy="594360"/>
           </a:xfrm>
           <a:prstGeom prst="rect">
             <a:avLst/>
@@ -12769,27 +15128,113 @@
               </a:spcAft>
             </a:pPr>
             <a:r>
-              <a:rPr sz="2700" b="1">
-                <a:solidFill>
-                  <a:srgbClr val="D6EC79"/>
-                </a:solidFill>
-                <a:latin typeface="Aptos"/>
-              </a:rPr>
-              <a:t>Informatiile sunt adevarate?</a:t>
-            </a:r>
-          </a:p>
-        </p:txBody>
-      </p:sp>
-      <p:sp>
-        <p:nvSpPr>
-          <p:cNvPr id="11" name="TextBox 10"/>
+              <a:rPr sz="2400" b="1">
+                <a:solidFill>
+                  <a:srgbClr val="FFFFFF"/>
+                </a:solidFill>
+                <a:latin typeface="Aptos"/>
+              </a:rPr>
+              <a:t>Pagina</a:t>
+            </a:r>
+          </a:p>
+        </p:txBody>
+      </p:sp>
+      <p:sp>
+        <p:nvSpPr>
+          <p:cNvPr id="15" name="Rectangle 14"/>
+          <p:cNvSpPr/>
+          <p:nvPr/>
+        </p:nvSpPr>
+        <p:spPr>
+          <a:xfrm>
+            <a:off x="7333488" y="3740403"/>
+            <a:ext cx="576072" cy="35560"/>
+          </a:xfrm>
+          <a:prstGeom prst="rect">
+            <a:avLst/>
+          </a:prstGeom>
+          <a:solidFill>
+            <a:srgbClr val="D6EC79"/>
+          </a:solidFill>
+          <a:ln>
+            <a:noFill/>
+          </a:ln>
+        </p:spPr>
+        <p:style>
+          <a:lnRef idx="1">
+            <a:schemeClr val="accent1"/>
+          </a:lnRef>
+          <a:fillRef idx="3">
+            <a:schemeClr val="accent1"/>
+          </a:fillRef>
+          <a:effectRef idx="2">
+            <a:schemeClr val="accent1"/>
+          </a:effectRef>
+          <a:fontRef idx="minor">
+            <a:schemeClr val="lt1"/>
+          </a:fontRef>
+        </p:style>
+        <p:txBody>
+          <a:bodyPr rtlCol="0" anchor="ctr"/>
+          <a:lstStyle/>
+          <a:p>
+            <a:pPr algn="ctr"/>
+          </a:p>
+        </p:txBody>
+      </p:sp>
+      <p:sp>
+        <p:nvSpPr>
+          <p:cNvPr id="16" name="Isosceles Triangle 15"/>
+          <p:cNvSpPr/>
+          <p:nvPr/>
+        </p:nvSpPr>
+        <p:spPr>
+          <a:xfrm rot="5400000">
+            <a:off x="7827264" y="3675887"/>
+            <a:ext cx="164592" cy="164592"/>
+          </a:xfrm>
+          <a:prstGeom prst="triangle">
+            <a:avLst/>
+          </a:prstGeom>
+          <a:solidFill>
+            <a:srgbClr val="D6EC79"/>
+          </a:solidFill>
+          <a:ln>
+            <a:noFill/>
+          </a:ln>
+        </p:spPr>
+        <p:style>
+          <a:lnRef idx="1">
+            <a:schemeClr val="accent1"/>
+          </a:lnRef>
+          <a:fillRef idx="3">
+            <a:schemeClr val="accent1"/>
+          </a:fillRef>
+          <a:effectRef idx="2">
+            <a:schemeClr val="accent1"/>
+          </a:effectRef>
+          <a:fontRef idx="minor">
+            <a:schemeClr val="lt1"/>
+          </a:fontRef>
+        </p:style>
+        <p:txBody>
+          <a:bodyPr rtlCol="0" anchor="ctr"/>
+          <a:lstStyle/>
+          <a:p>
+            <a:pPr algn="ctr"/>
+          </a:p>
+        </p:txBody>
+      </p:sp>
+      <p:sp>
+        <p:nvSpPr>
+          <p:cNvPr id="17" name="TextBox 16"/>
           <p:cNvSpPr txBox="1"/>
           <p:nvPr/>
         </p:nvSpPr>
         <p:spPr>
           <a:xfrm>
-            <a:off x="4800600" y="4407408"/>
-            <a:ext cx="6492240" cy="877824"/>
+            <a:off x="8129016" y="3291839"/>
+            <a:ext cx="3200400" cy="941832"/>
           </a:xfrm>
           <a:prstGeom prst="rect">
             <a:avLst/>
@@ -12808,13 +15253,291 @@
               </a:spcAft>
             </a:pPr>
             <a:r>
-              <a:rPr sz="2500" b="0">
+              <a:rPr sz="2400" b="0">
                 <a:solidFill>
                   <a:srgbClr val="FFFFFF"/>
                 </a:solidFill>
                 <a:latin typeface="Aptos"/>
               </a:rPr>
-              <a:t>Pentru un eveniment real, le confirmam cu organizatorul.</a:t>
+              <a:t>Testeaza butonul</a:t>
+            </a:r>
+          </a:p>
+          <a:p>
+            <a:pPr>
+              <a:spcAft>
+                <a:spcPts val="800"/>
+              </a:spcAft>
+            </a:pPr>
+            <a:r>
+              <a:rPr sz="2400" b="0">
+                <a:solidFill>
+                  <a:srgbClr val="FFFFFF"/>
+                </a:solidFill>
+                <a:latin typeface="Aptos"/>
+              </a:rPr>
+              <a:t>si afisarea pe telefon.</a:t>
+            </a:r>
+          </a:p>
+        </p:txBody>
+      </p:sp>
+      <p:sp>
+        <p:nvSpPr>
+          <p:cNvPr id="18" name="TextBox 17"/>
+          <p:cNvSpPr txBox="1"/>
+          <p:nvPr/>
+        </p:nvSpPr>
+        <p:spPr>
+          <a:xfrm>
+            <a:off x="777240" y="4745736"/>
+            <a:ext cx="3657600" cy="731520"/>
+          </a:xfrm>
+          <a:prstGeom prst="rect">
+            <a:avLst/>
+          </a:prstGeom>
+          <a:noFill/>
+        </p:spPr>
+        <p:txBody>
+          <a:bodyPr wrap="square" lIns="22860" rIns="22860" tIns="22860" bIns="22860">
+            <a:spAutoFit/>
+          </a:bodyPr>
+          <a:lstStyle/>
+          <a:p>
+            <a:pPr>
+              <a:spcAft>
+                <a:spcPts val="800"/>
+              </a:spcAft>
+            </a:pPr>
+            <a:r>
+              <a:rPr sz="2600" b="1">
+                <a:solidFill>
+                  <a:srgbClr val="D6EC79"/>
+                </a:solidFill>
+                <a:latin typeface="Aptos"/>
+              </a:rPr>
+              <a:t>Este adevarat?</a:t>
+            </a:r>
+          </a:p>
+        </p:txBody>
+      </p:sp>
+      <p:sp>
+        <p:nvSpPr>
+          <p:cNvPr id="19" name="Rectangle 18"/>
+          <p:cNvSpPr/>
+          <p:nvPr/>
+        </p:nvSpPr>
+        <p:spPr>
+          <a:xfrm>
+            <a:off x="4709160" y="4590288"/>
+            <a:ext cx="2487168" cy="1060704"/>
+          </a:xfrm>
+          <a:prstGeom prst="rect">
+            <a:avLst/>
+          </a:prstGeom>
+          <a:solidFill>
+            <a:srgbClr val="263B51"/>
+          </a:solidFill>
+          <a:ln>
+            <a:noFill/>
+          </a:ln>
+        </p:spPr>
+        <p:style>
+          <a:lnRef idx="1">
+            <a:schemeClr val="accent1"/>
+          </a:lnRef>
+          <a:fillRef idx="3">
+            <a:schemeClr val="accent1"/>
+          </a:fillRef>
+          <a:effectRef idx="2">
+            <a:schemeClr val="accent1"/>
+          </a:effectRef>
+          <a:fontRef idx="minor">
+            <a:schemeClr val="lt1"/>
+          </a:fontRef>
+        </p:style>
+        <p:txBody>
+          <a:bodyPr rtlCol="0" anchor="ctr"/>
+          <a:lstStyle/>
+          <a:p>
+            <a:pPr algn="ctr"/>
+          </a:p>
+        </p:txBody>
+      </p:sp>
+      <p:sp>
+        <p:nvSpPr>
+          <p:cNvPr id="20" name="TextBox 19"/>
+          <p:cNvSpPr txBox="1"/>
+          <p:nvPr/>
+        </p:nvSpPr>
+        <p:spPr>
+          <a:xfrm>
+            <a:off x="4846320" y="4828031"/>
+            <a:ext cx="2212848" cy="594360"/>
+          </a:xfrm>
+          <a:prstGeom prst="rect">
+            <a:avLst/>
+          </a:prstGeom>
+          <a:noFill/>
+        </p:spPr>
+        <p:txBody>
+          <a:bodyPr wrap="square" lIns="22860" rIns="22860" tIns="22860" bIns="22860">
+            <a:spAutoFit/>
+          </a:bodyPr>
+          <a:lstStyle/>
+          <a:p>
+            <a:pPr>
+              <a:spcAft>
+                <a:spcPts val="800"/>
+              </a:spcAft>
+            </a:pPr>
+            <a:r>
+              <a:rPr sz="2400" b="1">
+                <a:solidFill>
+                  <a:srgbClr val="FFFFFF"/>
+                </a:solidFill>
+                <a:latin typeface="Aptos"/>
+              </a:rPr>
+              <a:t>Eveniment real</a:t>
+            </a:r>
+          </a:p>
+        </p:txBody>
+      </p:sp>
+      <p:sp>
+        <p:nvSpPr>
+          <p:cNvPr id="21" name="Rectangle 20"/>
+          <p:cNvSpPr/>
+          <p:nvPr/>
+        </p:nvSpPr>
+        <p:spPr>
+          <a:xfrm>
+            <a:off x="7333488" y="5084572"/>
+            <a:ext cx="576072" cy="35560"/>
+          </a:xfrm>
+          <a:prstGeom prst="rect">
+            <a:avLst/>
+          </a:prstGeom>
+          <a:solidFill>
+            <a:srgbClr val="D6EC79"/>
+          </a:solidFill>
+          <a:ln>
+            <a:noFill/>
+          </a:ln>
+        </p:spPr>
+        <p:style>
+          <a:lnRef idx="1">
+            <a:schemeClr val="accent1"/>
+          </a:lnRef>
+          <a:fillRef idx="3">
+            <a:schemeClr val="accent1"/>
+          </a:fillRef>
+          <a:effectRef idx="2">
+            <a:schemeClr val="accent1"/>
+          </a:effectRef>
+          <a:fontRef idx="minor">
+            <a:schemeClr val="lt1"/>
+          </a:fontRef>
+        </p:style>
+        <p:txBody>
+          <a:bodyPr rtlCol="0" anchor="ctr"/>
+          <a:lstStyle/>
+          <a:p>
+            <a:pPr algn="ctr"/>
+          </a:p>
+        </p:txBody>
+      </p:sp>
+      <p:sp>
+        <p:nvSpPr>
+          <p:cNvPr id="22" name="Isosceles Triangle 21"/>
+          <p:cNvSpPr/>
+          <p:nvPr/>
+        </p:nvSpPr>
+        <p:spPr>
+          <a:xfrm rot="5400000">
+            <a:off x="7827264" y="5020056"/>
+            <a:ext cx="164592" cy="164592"/>
+          </a:xfrm>
+          <a:prstGeom prst="triangle">
+            <a:avLst/>
+          </a:prstGeom>
+          <a:solidFill>
+            <a:srgbClr val="D6EC79"/>
+          </a:solidFill>
+          <a:ln>
+            <a:noFill/>
+          </a:ln>
+        </p:spPr>
+        <p:style>
+          <a:lnRef idx="1">
+            <a:schemeClr val="accent1"/>
+          </a:lnRef>
+          <a:fillRef idx="3">
+            <a:schemeClr val="accent1"/>
+          </a:fillRef>
+          <a:effectRef idx="2">
+            <a:schemeClr val="accent1"/>
+          </a:effectRef>
+          <a:fontRef idx="minor">
+            <a:schemeClr val="lt1"/>
+          </a:fontRef>
+        </p:style>
+        <p:txBody>
+          <a:bodyPr rtlCol="0" anchor="ctr"/>
+          <a:lstStyle/>
+          <a:p>
+            <a:pPr algn="ctr"/>
+          </a:p>
+        </p:txBody>
+      </p:sp>
+      <p:sp>
+        <p:nvSpPr>
+          <p:cNvPr id="23" name="TextBox 22"/>
+          <p:cNvSpPr txBox="1"/>
+          <p:nvPr/>
+        </p:nvSpPr>
+        <p:spPr>
+          <a:xfrm>
+            <a:off x="8129016" y="4636007"/>
+            <a:ext cx="3200400" cy="941832"/>
+          </a:xfrm>
+          <a:prstGeom prst="rect">
+            <a:avLst/>
+          </a:prstGeom>
+          <a:noFill/>
+        </p:spPr>
+        <p:txBody>
+          <a:bodyPr wrap="square" lIns="22860" rIns="22860" tIns="22860" bIns="22860">
+            <a:spAutoFit/>
+          </a:bodyPr>
+          <a:lstStyle/>
+          <a:p>
+            <a:pPr>
+              <a:spcAft>
+                <a:spcPts val="800"/>
+              </a:spcAft>
+            </a:pPr>
+            <a:r>
+              <a:rPr sz="2400" b="0">
+                <a:solidFill>
+                  <a:srgbClr val="FFFFFF"/>
+                </a:solidFill>
+                <a:latin typeface="Aptos"/>
+              </a:rPr>
+              <a:t>Confirma cu</a:t>
+            </a:r>
+          </a:p>
+          <a:p>
+            <a:pPr>
+              <a:spcAft>
+                <a:spcPts val="800"/>
+              </a:spcAft>
+            </a:pPr>
+            <a:r>
+              <a:rPr sz="2400" b="0">
+                <a:solidFill>
+                  <a:srgbClr val="FFFFFF"/>
+                </a:solidFill>
+                <a:latin typeface="Aptos"/>
+              </a:rPr>
+              <a:t>organizatorul.</a:t>
             </a:r>
           </a:p>
         </p:txBody>

</xml_diff>

<commit_message>
Remove speaker notes from the public presentation
Keep the public viewer, slide manifest and PowerPoint slide-only. Full notes remain in the private Professional project.

Co-authored-by: Copilot App <223556219+Copilot@users.noreply.github.com>

Copilot-Session: 1eb2797f-3b87-49f8-85d2-d57d82049b02
</commit_message>
<xml_diff>
--- a/downloads/cartea-daliei-ai.pptx
+++ b/downloads/cartea-daliei-ai.pptx
@@ -118,1819 +118,6 @@
     </ns2:lvl9pPr>
   </ns0:defaultTextStyle>
 </ns0:presentation>
-</file>
-
-<file path=ppt/notesMasters/notesMaster1.xml><?xml version="1.0" encoding="utf-8"?>
-<p:notesMaster xmlns:a="http://schemas.openxmlformats.org/drawingml/2006/main" xmlns:p="http://schemas.openxmlformats.org/presentationml/2006/main" xmlns:r="http://schemas.openxmlformats.org/officeDocument/2006/relationships">
-  <p:cSld>
-    <p:bg>
-      <p:bgRef idx="1001">
-        <a:schemeClr val="bg1"/>
-      </p:bgRef>
-    </p:bg>
-    <p:spTree>
-      <p:nvGrpSpPr>
-        <p:cNvPr id="1" name=""/>
-        <p:cNvGrpSpPr/>
-        <p:nvPr/>
-      </p:nvGrpSpPr>
-      <p:grpSpPr>
-        <a:xfrm>
-          <a:off x="0" y="0"/>
-          <a:ext cx="0" cy="0"/>
-          <a:chOff x="0" y="0"/>
-          <a:chExt cx="0" cy="0"/>
-        </a:xfrm>
-      </p:grpSpPr>
-      <p:sp>
-        <p:nvSpPr>
-          <p:cNvPr id="2" name="Header Placeholder 1"/>
-          <p:cNvSpPr>
-            <a:spLocks noGrp="1"/>
-          </p:cNvSpPr>
-          <p:nvPr>
-            <p:ph type="hdr" sz="quarter"/>
-          </p:nvPr>
-        </p:nvSpPr>
-        <p:spPr>
-          <a:xfrm>
-            <a:off x="0" y="0"/>
-            <a:ext cx="2971800" cy="457200"/>
-          </a:xfrm>
-          <a:prstGeom prst="rect">
-            <a:avLst/>
-          </a:prstGeom>
-        </p:spPr>
-        <p:txBody>
-          <a:bodyPr vert="horz" lIns="91440" tIns="45720" rIns="91440" bIns="45720" rtlCol="0"/>
-          <a:lstStyle>
-            <a:lvl1pPr algn="l">
-              <a:defRPr sz="1200"/>
-            </a:lvl1pPr>
-          </a:lstStyle>
-          <a:p>
-            <a:endParaRPr lang="en-US"/>
-          </a:p>
-        </p:txBody>
-      </p:sp>
-      <p:sp>
-        <p:nvSpPr>
-          <p:cNvPr id="3" name="Date Placeholder 2"/>
-          <p:cNvSpPr>
-            <a:spLocks noGrp="1"/>
-          </p:cNvSpPr>
-          <p:nvPr>
-            <p:ph type="dt" idx="1"/>
-          </p:nvPr>
-        </p:nvSpPr>
-        <p:spPr>
-          <a:xfrm>
-            <a:off x="3884613" y="0"/>
-            <a:ext cx="2971800" cy="457200"/>
-          </a:xfrm>
-          <a:prstGeom prst="rect">
-            <a:avLst/>
-          </a:prstGeom>
-        </p:spPr>
-        <p:txBody>
-          <a:bodyPr vert="horz" lIns="91440" tIns="45720" rIns="91440" bIns="45720" rtlCol="0"/>
-          <a:lstStyle>
-            <a:lvl1pPr algn="r">
-              <a:defRPr sz="1200"/>
-            </a:lvl1pPr>
-          </a:lstStyle>
-          <a:p>
-            <a:fld id="{0F89C1C7-3DCD-1040-A9CF-14679D8B5DDD}" type="datetimeFigureOut">
-              <a:rPr lang="en-US" smtClean="0"/>
-              <a:t>10/17/16</a:t>
-            </a:fld>
-            <a:endParaRPr lang="en-US"/>
-          </a:p>
-        </p:txBody>
-      </p:sp>
-      <p:sp>
-        <p:nvSpPr>
-          <p:cNvPr id="4" name="Slide Image Placeholder 3"/>
-          <p:cNvSpPr>
-            <a:spLocks noGrp="1" noRot="1" noChangeAspect="1"/>
-          </p:cNvSpPr>
-          <p:nvPr>
-            <p:ph type="sldImg" idx="2"/>
-          </p:nvPr>
-        </p:nvSpPr>
-        <p:spPr>
-          <a:xfrm>
-            <a:off x="1143000" y="685800"/>
-            <a:ext cx="4572000" cy="3429000"/>
-          </a:xfrm>
-          <a:prstGeom prst="rect">
-            <a:avLst/>
-          </a:prstGeom>
-          <a:noFill/>
-          <a:ln w="12700">
-            <a:solidFill>
-              <a:prstClr val="black"/>
-            </a:solidFill>
-          </a:ln>
-        </p:spPr>
-        <p:txBody>
-          <a:bodyPr vert="horz" lIns="91440" tIns="45720" rIns="91440" bIns="45720" rtlCol="0" anchor="ctr"/>
-          <a:lstStyle/>
-          <a:p>
-            <a:endParaRPr lang="en-US"/>
-          </a:p>
-        </p:txBody>
-      </p:sp>
-      <p:sp>
-        <p:nvSpPr>
-          <p:cNvPr id="5" name="Notes Placeholder 4"/>
-          <p:cNvSpPr>
-            <a:spLocks noGrp="1"/>
-          </p:cNvSpPr>
-          <p:nvPr>
-            <p:ph type="body" sz="quarter" idx="3"/>
-          </p:nvPr>
-        </p:nvSpPr>
-        <p:spPr>
-          <a:xfrm>
-            <a:off x="685800" y="4343400"/>
-            <a:ext cx="5486400" cy="4114800"/>
-          </a:xfrm>
-          <a:prstGeom prst="rect">
-            <a:avLst/>
-          </a:prstGeom>
-        </p:spPr>
-        <p:txBody>
-          <a:bodyPr vert="horz" lIns="91440" tIns="45720" rIns="91440" bIns="45720" rtlCol="0"/>
-          <a:lstStyle/>
-          <a:p>
-            <a:pPr lvl="0"/>
-            <a:r>
-              <a:rPr lang="en-US" smtClean="0"/>
-              <a:t>Click to edit Master text styles</a:t>
-            </a:r>
-          </a:p>
-          <a:p>
-            <a:pPr lvl="1"/>
-            <a:r>
-              <a:rPr lang="en-US" smtClean="0"/>
-              <a:t>Second level</a:t>
-            </a:r>
-          </a:p>
-          <a:p>
-            <a:pPr lvl="2"/>
-            <a:r>
-              <a:rPr lang="en-US" smtClean="0"/>
-              <a:t>Third level</a:t>
-            </a:r>
-          </a:p>
-          <a:p>
-            <a:pPr lvl="3"/>
-            <a:r>
-              <a:rPr lang="en-US" smtClean="0"/>
-              <a:t>Fourth level</a:t>
-            </a:r>
-          </a:p>
-          <a:p>
-            <a:pPr lvl="4"/>
-            <a:r>
-              <a:rPr lang="en-US" smtClean="0"/>
-              <a:t>Fifth level</a:t>
-            </a:r>
-            <a:endParaRPr lang="en-US"/>
-          </a:p>
-        </p:txBody>
-      </p:sp>
-      <p:sp>
-        <p:nvSpPr>
-          <p:cNvPr id="6" name="Footer Placeholder 5"/>
-          <p:cNvSpPr>
-            <a:spLocks noGrp="1"/>
-          </p:cNvSpPr>
-          <p:nvPr>
-            <p:ph type="ftr" sz="quarter" idx="4"/>
-          </p:nvPr>
-        </p:nvSpPr>
-        <p:spPr>
-          <a:xfrm>
-            <a:off x="0" y="8685213"/>
-            <a:ext cx="2971800" cy="457200"/>
-          </a:xfrm>
-          <a:prstGeom prst="rect">
-            <a:avLst/>
-          </a:prstGeom>
-        </p:spPr>
-        <p:txBody>
-          <a:bodyPr vert="horz" lIns="91440" tIns="45720" rIns="91440" bIns="45720" rtlCol="0" anchor="b"/>
-          <a:lstStyle>
-            <a:lvl1pPr algn="l">
-              <a:defRPr sz="1200"/>
-            </a:lvl1pPr>
-          </a:lstStyle>
-          <a:p>
-            <a:endParaRPr lang="en-US"/>
-          </a:p>
-        </p:txBody>
-      </p:sp>
-      <p:sp>
-        <p:nvSpPr>
-          <p:cNvPr id="7" name="Slide Number Placeholder 6"/>
-          <p:cNvSpPr>
-            <a:spLocks noGrp="1"/>
-          </p:cNvSpPr>
-          <p:nvPr>
-            <p:ph type="sldNum" sz="quarter" idx="5"/>
-          </p:nvPr>
-        </p:nvSpPr>
-        <p:spPr>
-          <a:xfrm>
-            <a:off x="3884613" y="8685213"/>
-            <a:ext cx="2971800" cy="457200"/>
-          </a:xfrm>
-          <a:prstGeom prst="rect">
-            <a:avLst/>
-          </a:prstGeom>
-        </p:spPr>
-        <p:txBody>
-          <a:bodyPr vert="horz" lIns="91440" tIns="45720" rIns="91440" bIns="45720" rtlCol="0" anchor="b"/>
-          <a:lstStyle>
-            <a:lvl1pPr algn="r">
-              <a:defRPr sz="1200"/>
-            </a:lvl1pPr>
-          </a:lstStyle>
-          <a:p>
-            <a:fld id="{BB5E49A5-4136-284D-997B-48E1D791AD67}" type="slidenum">
-              <a:rPr lang="en-US" smtClean="0"/>
-              <a:t>‹#›</a:t>
-            </a:fld>
-            <a:endParaRPr lang="en-US"/>
-          </a:p>
-        </p:txBody>
-      </p:sp>
-    </p:spTree>
-    <p:extLst>
-      <p:ext uri="{BB962C8B-B14F-4D97-AF65-F5344CB8AC3E}">
-        <p14:creationId xmlns:p14="http://schemas.microsoft.com/office/powerpoint/2010/main" val="2623252185"/>
-      </p:ext>
-    </p:extLst>
-  </p:cSld>
-  <p:clrMap bg1="lt1" tx1="dk1" bg2="lt2" tx2="dk2" accent1="accent1" accent2="accent2" accent3="accent3" accent4="accent4" accent5="accent5" accent6="accent6" hlink="hlink" folHlink="folHlink"/>
-  <p:notesStyle>
-    <a:lvl1pPr marL="0" algn="l" defTabSz="457200" rtl="0" eaLnBrk="1" latinLnBrk="0" hangingPunct="1">
-      <a:defRPr sz="1200" kern="1200">
-        <a:solidFill>
-          <a:schemeClr val="tx1"/>
-        </a:solidFill>
-        <a:latin typeface="+mn-lt"/>
-        <a:ea typeface="+mn-ea"/>
-        <a:cs typeface="+mn-cs"/>
-      </a:defRPr>
-    </a:lvl1pPr>
-    <a:lvl2pPr marL="457200" algn="l" defTabSz="457200" rtl="0" eaLnBrk="1" latinLnBrk="0" hangingPunct="1">
-      <a:defRPr sz="1200" kern="1200">
-        <a:solidFill>
-          <a:schemeClr val="tx1"/>
-        </a:solidFill>
-        <a:latin typeface="+mn-lt"/>
-        <a:ea typeface="+mn-ea"/>
-        <a:cs typeface="+mn-cs"/>
-      </a:defRPr>
-    </a:lvl2pPr>
-    <a:lvl3pPr marL="914400" algn="l" defTabSz="457200" rtl="0" eaLnBrk="1" latinLnBrk="0" hangingPunct="1">
-      <a:defRPr sz="1200" kern="1200">
-        <a:solidFill>
-          <a:schemeClr val="tx1"/>
-        </a:solidFill>
-        <a:latin typeface="+mn-lt"/>
-        <a:ea typeface="+mn-ea"/>
-        <a:cs typeface="+mn-cs"/>
-      </a:defRPr>
-    </a:lvl3pPr>
-    <a:lvl4pPr marL="1371600" algn="l" defTabSz="457200" rtl="0" eaLnBrk="1" latinLnBrk="0" hangingPunct="1">
-      <a:defRPr sz="1200" kern="1200">
-        <a:solidFill>
-          <a:schemeClr val="tx1"/>
-        </a:solidFill>
-        <a:latin typeface="+mn-lt"/>
-        <a:ea typeface="+mn-ea"/>
-        <a:cs typeface="+mn-cs"/>
-      </a:defRPr>
-    </a:lvl4pPr>
-    <a:lvl5pPr marL="1828800" algn="l" defTabSz="457200" rtl="0" eaLnBrk="1" latinLnBrk="0" hangingPunct="1">
-      <a:defRPr sz="1200" kern="1200">
-        <a:solidFill>
-          <a:schemeClr val="tx1"/>
-        </a:solidFill>
-        <a:latin typeface="+mn-lt"/>
-        <a:ea typeface="+mn-ea"/>
-        <a:cs typeface="+mn-cs"/>
-      </a:defRPr>
-    </a:lvl5pPr>
-    <a:lvl6pPr marL="2286000" algn="l" defTabSz="457200" rtl="0" eaLnBrk="1" latinLnBrk="0" hangingPunct="1">
-      <a:defRPr sz="1200" kern="1200">
-        <a:solidFill>
-          <a:schemeClr val="tx1"/>
-        </a:solidFill>
-        <a:latin typeface="+mn-lt"/>
-        <a:ea typeface="+mn-ea"/>
-        <a:cs typeface="+mn-cs"/>
-      </a:defRPr>
-    </a:lvl6pPr>
-    <a:lvl7pPr marL="2743200" algn="l" defTabSz="457200" rtl="0" eaLnBrk="1" latinLnBrk="0" hangingPunct="1">
-      <a:defRPr sz="1200" kern="1200">
-        <a:solidFill>
-          <a:schemeClr val="tx1"/>
-        </a:solidFill>
-        <a:latin typeface="+mn-lt"/>
-        <a:ea typeface="+mn-ea"/>
-        <a:cs typeface="+mn-cs"/>
-      </a:defRPr>
-    </a:lvl7pPr>
-    <a:lvl8pPr marL="3200400" algn="l" defTabSz="457200" rtl="0" eaLnBrk="1" latinLnBrk="0" hangingPunct="1">
-      <a:defRPr sz="1200" kern="1200">
-        <a:solidFill>
-          <a:schemeClr val="tx1"/>
-        </a:solidFill>
-        <a:latin typeface="+mn-lt"/>
-        <a:ea typeface="+mn-ea"/>
-        <a:cs typeface="+mn-cs"/>
-      </a:defRPr>
-    </a:lvl8pPr>
-    <a:lvl9pPr marL="3657600" algn="l" defTabSz="457200" rtl="0" eaLnBrk="1" latinLnBrk="0" hangingPunct="1">
-      <a:defRPr sz="1200" kern="1200">
-        <a:solidFill>
-          <a:schemeClr val="tx1"/>
-        </a:solidFill>
-        <a:latin typeface="+mn-lt"/>
-        <a:ea typeface="+mn-ea"/>
-        <a:cs typeface="+mn-cs"/>
-      </a:defRPr>
-    </a:lvl9pPr>
-  </p:notesStyle>
-</p:notesMaster>
-</file>
-
-<file path=ppt/notesSlides/notesSlide1.xml><?xml version="1.0" encoding="utf-8"?>
-<p:notes xmlns:a="http://schemas.openxmlformats.org/drawingml/2006/main" xmlns:p="http://schemas.openxmlformats.org/presentationml/2006/main" xmlns:r="http://schemas.openxmlformats.org/officeDocument/2006/relationships">
-  <p:cSld>
-    <p:spTree>
-      <p:nvGrpSpPr>
-        <p:cNvPr id="1" name=""/>
-        <p:cNvGrpSpPr/>
-        <p:nvPr/>
-      </p:nvGrpSpPr>
-      <p:grpSpPr>
-        <a:xfrm>
-          <a:off x="0" y="0"/>
-          <a:ext cx="0" cy="0"/>
-          <a:chOff x="0" y="0"/>
-          <a:chExt cx="0" cy="0"/>
-        </a:xfrm>
-      </p:grpSpPr>
-      <p:sp>
-        <p:nvSpPr>
-          <p:cNvPr id="2" name="Slide Image Placeholder 1"/>
-          <p:cNvSpPr>
-            <a:spLocks noGrp="1"/>
-          </p:cNvSpPr>
-          <p:nvPr>
-            <p:ph type="sldImg" idx="2"/>
-          </p:nvPr>
-        </p:nvSpPr>
-        <p:spPr/>
-      </p:sp>
-      <p:sp>
-        <p:nvSpPr>
-          <p:cNvPr id="3" name="Notes Placeholder 2"/>
-          <p:cNvSpPr>
-            <a:spLocks noGrp="1"/>
-          </p:cNvSpPr>
-          <p:nvPr>
-            <p:ph type="body" idx="3" sz="quarter"/>
-          </p:nvPr>
-        </p:nvSpPr>
-        <p:spPr/>
-        <p:txBody>
-          <a:bodyPr/>
-          <a:lstStyle/>
-          <a:p>
-            <a:r>
-              <a:t>SLIDE 1</a:t>
-            </a:r>
-          </a:p>
-          <a:p/>
-          <a:p>
-            <a:r>
-              <a:t>Cand eram de varsta voastra, auzeam despre calculatoare de la alti copii care aveau unul. Eu nu aveam, dar la un moment dat am primit o foaie cu comenzile unui limbaj de programare, BASIC.</a:t>
-            </a:r>
-          </a:p>
-          <a:p>
-            <a:r>
-              <a:t>Am inceput sa scriu programe pe hartie. Le dadeam unui prieten care avea calculator, iar a doua zi imi aducea notite sau imi povestea ce nu mersese. Eu corectam si incercam din nou. Faceam un fel de remote debugging, doar ca raspunsul venea a doua zi.</a:t>
-            </a:r>
-          </a:p>
-          <a:p>
-            <a:r>
-              <a:t>In timp am avut si eu calculatorul meu si, de atunci, calculatoarele au ramas parte din viata mea.</a:t>
-            </a:r>
-          </a:p>
-          <a:p>
-            <a:r>
-              <a:t>Astazi putem incerca idei mult mai repede. Dar partea care imi place a ramas aceeasi: ai o idee, incerci ceva, observi ce nu merge si imbunatatesti. Astazi o sa facem impreuna exact asta, cu ajutorul AI.</a:t>
-            </a:r>
-          </a:p>
-          <a:p/>
-          <a:p>
-            <a:r>
-              <a:t>SURSE</a:t>
-            </a:r>
-          </a:p>
-          <a:p>
-            <a:r>
-              <a:t>Poveste oferita de Dragos sau exemplu educational original.</a:t>
-            </a:r>
-          </a:p>
-        </p:txBody>
-      </p:sp>
-      <p:sp>
-        <p:nvSpPr>
-          <p:cNvPr id="4" name="Slide Number Placeholder 3"/>
-          <p:cNvSpPr>
-            <a:spLocks noGrp="1"/>
-          </p:cNvSpPr>
-          <p:nvPr>
-            <p:ph type="sldNum" idx="5" sz="quarter"/>
-          </p:nvPr>
-        </p:nvSpPr>
-        <p:spPr/>
-      </p:sp>
-    </p:spTree>
-  </p:cSld>
-  <p:clrMapOvr>
-    <a:masterClrMapping/>
-  </p:clrMapOvr>
-</p:notes>
-</file>
-
-<file path=ppt/notesSlides/notesSlide10.xml><?xml version="1.0" encoding="utf-8"?>
-<p:notes xmlns:a="http://schemas.openxmlformats.org/drawingml/2006/main" xmlns:p="http://schemas.openxmlformats.org/presentationml/2006/main" xmlns:r="http://schemas.openxmlformats.org/officeDocument/2006/relationships">
-  <p:cSld>
-    <p:spTree>
-      <p:nvGrpSpPr>
-        <p:cNvPr id="1" name=""/>
-        <p:cNvGrpSpPr/>
-        <p:nvPr/>
-      </p:nvGrpSpPr>
-      <p:grpSpPr>
-        <a:xfrm>
-          <a:off x="0" y="0"/>
-          <a:ext cx="0" cy="0"/>
-          <a:chOff x="0" y="0"/>
-          <a:chExt cx="0" cy="0"/>
-        </a:xfrm>
-      </p:grpSpPr>
-      <p:sp>
-        <p:nvSpPr>
-          <p:cNvPr id="2" name="Slide Image Placeholder 1"/>
-          <p:cNvSpPr>
-            <a:spLocks noGrp="1"/>
-          </p:cNvSpPr>
-          <p:nvPr>
-            <p:ph type="sldImg" idx="2"/>
-          </p:nvPr>
-        </p:nvSpPr>
-        <p:spPr/>
-      </p:sp>
-      <p:sp>
-        <p:nvSpPr>
-          <p:cNvPr id="3" name="Notes Placeholder 2"/>
-          <p:cNvSpPr>
-            <a:spLocks noGrp="1"/>
-          </p:cNvSpPr>
-          <p:nvPr>
-            <p:ph type="body" idx="3" sz="quarter"/>
-          </p:nvPr>
-        </p:nvSpPr>
-        <p:spPr/>
-        <p:txBody>
-          <a:bodyPr/>
-          <a:lstStyle/>
-          <a:p>
-            <a:r>
-              <a:t>SLIDE 10</a:t>
-            </a:r>
-          </a:p>
-          <a:p/>
-          <a:p>
-            <a:r>
-              <a:t>Din tot ce am facut, as pastra cinci obiceiuri.</a:t>
-            </a:r>
-          </a:p>
-          <a:p>
-            <a:r>
-              <a:t>Protejeaza-ti datele: nu ai nevoie sa trimiti parole, acte sau informatii despre colegi ca sa explorezi o idee.</a:t>
-            </a:r>
-          </a:p>
-          <a:p>
-            <a:r>
-              <a:t>Verifica ce conteaza. Nu verificam la fel culoarea unui buton si o afirmatie despre sanatate.</a:t>
-            </a:r>
-          </a:p>
-          <a:p>
-            <a:r>
-              <a:t>Nu confunda tonul sigur cu adevarul. Ati vazut ca aspectul si corectitudinea sunt lucruri diferite.</a:t>
-            </a:r>
-          </a:p>
-          <a:p>
-            <a:r>
-              <a:t>Spune unde te-a ajutat AI si respecta regulile scolii. Contributia ta poate fi ideea, selectia, verificarea si ceea ce ai schimbat.</a:t>
-            </a:r>
-          </a:p>
-          <a:p>
-            <a:r>
-              <a:t>Si pastreaza decizia la tine. Daca nu intelegi rezultatul sau consecintele, opreste-te si cere sprijin. A folosi AI responsabil inseamna sa stii si cand sa nu te bazezi pe el.</a:t>
-            </a:r>
-          </a:p>
-          <a:p/>
-          <a:p>
-            <a:r>
-              <a:t>SURSE</a:t>
-            </a:r>
-          </a:p>
-          <a:p>
-            <a:r>
-              <a:t>https://dayofai.org/units/truth-tricks-and-ai-learning-to-verify-information</a:t>
-            </a:r>
-          </a:p>
-        </p:txBody>
-      </p:sp>
-      <p:sp>
-        <p:nvSpPr>
-          <p:cNvPr id="4" name="Slide Number Placeholder 3"/>
-          <p:cNvSpPr>
-            <a:spLocks noGrp="1"/>
-          </p:cNvSpPr>
-          <p:nvPr>
-            <p:ph type="sldNum" idx="5" sz="quarter"/>
-          </p:nvPr>
-        </p:nvSpPr>
-        <p:spPr/>
-      </p:sp>
-    </p:spTree>
-  </p:cSld>
-  <p:clrMapOvr>
-    <a:masterClrMapping/>
-  </p:clrMapOvr>
-</p:notes>
-</file>
-
-<file path=ppt/notesSlides/notesSlide11.xml><?xml version="1.0" encoding="utf-8"?>
-<p:notes xmlns:a="http://schemas.openxmlformats.org/drawingml/2006/main" xmlns:p="http://schemas.openxmlformats.org/presentationml/2006/main" xmlns:r="http://schemas.openxmlformats.org/officeDocument/2006/relationships">
-  <p:cSld>
-    <p:spTree>
-      <p:nvGrpSpPr>
-        <p:cNvPr id="1" name=""/>
-        <p:cNvGrpSpPr/>
-        <p:nvPr/>
-      </p:nvGrpSpPr>
-      <p:grpSpPr>
-        <a:xfrm>
-          <a:off x="0" y="0"/>
-          <a:ext cx="0" cy="0"/>
-          <a:chOff x="0" y="0"/>
-          <a:chExt cx="0" cy="0"/>
-        </a:xfrm>
-      </p:grpSpPr>
-      <p:sp>
-        <p:nvSpPr>
-          <p:cNvPr id="2" name="Slide Image Placeholder 1"/>
-          <p:cNvSpPr>
-            <a:spLocks noGrp="1"/>
-          </p:cNvSpPr>
-          <p:nvPr>
-            <p:ph type="sldImg" idx="2"/>
-          </p:nvPr>
-        </p:nvSpPr>
-        <p:spPr/>
-      </p:sp>
-      <p:sp>
-        <p:nvSpPr>
-          <p:cNvPr id="3" name="Notes Placeholder 2"/>
-          <p:cNvSpPr>
-            <a:spLocks noGrp="1"/>
-          </p:cNvSpPr>
-          <p:nvPr>
-            <p:ph type="body" idx="3" sz="quarter"/>
-          </p:nvPr>
-        </p:nvSpPr>
-        <p:spPr/>
-        <p:txBody>
-          <a:bodyPr/>
-          <a:lstStyle/>
-          <a:p>
-            <a:r>
-              <a:t>SLIDE 11</a:t>
-            </a:r>
-          </a:p>
-          <a:p/>
-          <a:p>
-            <a:r>
-              <a:t>Poate ca partea de cod v-a atras. Sau poate v-ati uitat mai degraba la cum arata pagina, la ce lipseste din program ori la cine poate participa.</a:t>
-            </a:r>
-          </a:p>
-          <a:p>
-            <a:r>
-              <a:t>Toate acestea au legatura cu munca in tech. Un software engineer construieste aplicatia. Cineva din cybersecurity se intreaba cum poate fi folosita gresit si cum o protejam. Data si AI inseamna sa lucrezi cu date si sa verifici ce concluzii poti trage.</a:t>
-            </a:r>
-          </a:p>
-          <a:p>
-            <a:r>
-              <a:t>UX inseamna sa intelegi oamenii si sa faci produsul usor de folosit. Product inseamna sa alegi problema si prioritatile. Responsible AI inseamna sa te gandesti la efecte, riscuri si echitate.</a:t>
-            </a:r>
-          </a:p>
-          <a:p>
-            <a:r>
-              <a:t>Nu trebuie sa va alegeti acum o meserie. Puteti observa ce fel de intrebari va place sa puneti si sa incercati proiecte mici in directia aceea.</a:t>
-            </a:r>
-          </a:p>
-          <a:p/>
-          <a:p>
-            <a:r>
-              <a:t>SURSE</a:t>
-            </a:r>
-          </a:p>
-          <a:p>
-            <a:r>
-              <a:t>Poveste oferita de Dragos sau exemplu educational original.</a:t>
-            </a:r>
-          </a:p>
-        </p:txBody>
-      </p:sp>
-      <p:sp>
-        <p:nvSpPr>
-          <p:cNvPr id="4" name="Slide Number Placeholder 3"/>
-          <p:cNvSpPr>
-            <a:spLocks noGrp="1"/>
-          </p:cNvSpPr>
-          <p:nvPr>
-            <p:ph type="sldNum" idx="5" sz="quarter"/>
-          </p:nvPr>
-        </p:nvSpPr>
-        <p:spPr/>
-      </p:sp>
-    </p:spTree>
-  </p:cSld>
-  <p:clrMapOvr>
-    <a:masterClrMapping/>
-  </p:clrMapOvr>
-</p:notes>
-</file>
-
-<file path=ppt/notesSlides/notesSlide12.xml><?xml version="1.0" encoding="utf-8"?>
-<p:notes xmlns:a="http://schemas.openxmlformats.org/drawingml/2006/main" xmlns:p="http://schemas.openxmlformats.org/presentationml/2006/main" xmlns:r="http://schemas.openxmlformats.org/officeDocument/2006/relationships">
-  <p:cSld>
-    <p:spTree>
-      <p:nvGrpSpPr>
-        <p:cNvPr id="1" name=""/>
-        <p:cNvGrpSpPr/>
-        <p:nvPr/>
-      </p:nvGrpSpPr>
-      <p:grpSpPr>
-        <a:xfrm>
-          <a:off x="0" y="0"/>
-          <a:ext cx="0" cy="0"/>
-          <a:chOff x="0" y="0"/>
-          <a:chExt cx="0" cy="0"/>
-        </a:xfrm>
-      </p:grpSpPr>
-      <p:sp>
-        <p:nvSpPr>
-          <p:cNvPr id="2" name="Slide Image Placeholder 1"/>
-          <p:cNvSpPr>
-            <a:spLocks noGrp="1"/>
-          </p:cNvSpPr>
-          <p:nvPr>
-            <p:ph type="sldImg" idx="2"/>
-          </p:nvPr>
-        </p:nvSpPr>
-        <p:spPr/>
-      </p:sp>
-      <p:sp>
-        <p:nvSpPr>
-          <p:cNvPr id="3" name="Notes Placeholder 2"/>
-          <p:cNvSpPr>
-            <a:spLocks noGrp="1"/>
-          </p:cNvSpPr>
-          <p:nvPr>
-            <p:ph type="body" idx="3" sz="quarter"/>
-          </p:nvPr>
-        </p:nvSpPr>
-        <p:spPr/>
-        <p:txBody>
-          <a:bodyPr/>
-          <a:lstStyle/>
-          <a:p>
-            <a:r>
-              <a:t>SLIDE 12</a:t>
-            </a:r>
-          </a:p>
-          <a:p/>
-          <a:p>
-            <a:r>
-              <a:t>Sa luam un rol de Product: te ocupi ca pagina sa rezolve o problema pentru oameni. AI iti poate propune texte, schite si un program.</a:t>
-            </a:r>
-          </a:p>
-          <a:p>
-            <a:r>
-              <a:t>Dar daca participantii nu pot ramane dupa o anumita ora? Daca unii nu au laptop? Daca sala nu poate fi folosita atunci? Ai nevoie sa cunosti situatia, sa asculti si sa alegi ce este fezabil. O pagina convingatoare nu rezolva singura aceste lucruri.</a:t>
-            </a:r>
-          </a:p>
-          <a:p>
-            <a:r>
-              <a:t>Unele sisteme pot deja folosi mai multe instrumente. In viitor am putea vedea mai multe activitati legate automat, dar nu stim exact ritmul, costul sau cat de fiabile vor deveni.</a:t>
-            </a:r>
-          </a:p>
-          <a:p>
-            <a:r>
-              <a:t>De aceea este mai util sa ne uitam la activitati decat sa spunem ca o meserie dispare sau este complet sigura. Cunostintele va ajuta sa observati greselile. Curiozitatea va ajuta sa explorati. Comunicarea si judecata va ajuta sa lucrati cu ceilalti si sa alegeti ce merita facut.</a:t>
-            </a:r>
-          </a:p>
-          <a:p/>
-          <a:p>
-            <a:r>
-              <a:t>SURSE</a:t>
-            </a:r>
-          </a:p>
-          <a:p>
-            <a:r>
-              <a:t>https://www.ilo.org/publications/generative-ai-and-jobs-2025-update</a:t>
-            </a:r>
-          </a:p>
-        </p:txBody>
-      </p:sp>
-      <p:sp>
-        <p:nvSpPr>
-          <p:cNvPr id="4" name="Slide Number Placeholder 3"/>
-          <p:cNvSpPr>
-            <a:spLocks noGrp="1"/>
-          </p:cNvSpPr>
-          <p:nvPr>
-            <p:ph type="sldNum" idx="5" sz="quarter"/>
-          </p:nvPr>
-        </p:nvSpPr>
-        <p:spPr/>
-      </p:sp>
-    </p:spTree>
-  </p:cSld>
-  <p:clrMapOvr>
-    <a:masterClrMapping/>
-  </p:clrMapOvr>
-</p:notes>
-</file>
-
-<file path=ppt/notesSlides/notesSlide13.xml><?xml version="1.0" encoding="utf-8"?>
-<p:notes xmlns:a="http://schemas.openxmlformats.org/drawingml/2006/main" xmlns:p="http://schemas.openxmlformats.org/presentationml/2006/main" xmlns:r="http://schemas.openxmlformats.org/officeDocument/2006/relationships">
-  <p:cSld>
-    <p:spTree>
-      <p:nvGrpSpPr>
-        <p:cNvPr id="1" name=""/>
-        <p:cNvGrpSpPr/>
-        <p:nvPr/>
-      </p:nvGrpSpPr>
-      <p:grpSpPr>
-        <a:xfrm>
-          <a:off x="0" y="0"/>
-          <a:ext cx="0" cy="0"/>
-          <a:chOff x="0" y="0"/>
-          <a:chExt cx="0" cy="0"/>
-        </a:xfrm>
-      </p:grpSpPr>
-      <p:sp>
-        <p:nvSpPr>
-          <p:cNvPr id="2" name="Slide Image Placeholder 1"/>
-          <p:cNvSpPr>
-            <a:spLocks noGrp="1"/>
-          </p:cNvSpPr>
-          <p:nvPr>
-            <p:ph type="sldImg" idx="2"/>
-          </p:nvPr>
-        </p:nvSpPr>
-        <p:spPr/>
-      </p:sp>
-      <p:sp>
-        <p:nvSpPr>
-          <p:cNvPr id="3" name="Notes Placeholder 2"/>
-          <p:cNvSpPr>
-            <a:spLocks noGrp="1"/>
-          </p:cNvSpPr>
-          <p:nvPr>
-            <p:ph type="body" idx="3" sz="quarter"/>
-          </p:nvPr>
-        </p:nvSpPr>
-        <p:spPr/>
-        <p:txBody>
-          <a:bodyPr/>
-          <a:lstStyle/>
-          <a:p>
-            <a:r>
-              <a:t>SLIDE 13</a:t>
-            </a:r>
-          </a:p>
-          <a:p/>
-          <a:p>
-            <a:r>
-              <a:t>Pentru cei care vor sa incerce, GitHub Copilot are o varianta Free, cu limite, si exista beneficii GitHub Education pentru elevii eligibili.</a:t>
-            </a:r>
-          </a:p>
-          <a:p>
-            <a:r>
-              <a:t>Nu trebuie sa facem conturi acum. Puteti incepe si cu o idee pe hartie: ce vreti sa obtineti si cum veti sti ca a functionat?</a:t>
-            </a:r>
-          </a:p>
-          <a:p>
-            <a:r>
-              <a:t>Mi-ar placea sa alegeti ceva care va intereseaza, nu ceva ce credeti ca trebuie sa impresioneze. Un inceput mic va da ceva real de imbunatatit.</a:t>
-            </a:r>
-          </a:p>
-          <a:p/>
-          <a:p>
-            <a:r>
-              <a:t>SURSE</a:t>
-            </a:r>
-          </a:p>
-          <a:p>
-            <a:r>
-              <a:t>https://docs.github.com/en/copilot/get-started/plans</a:t>
-            </a:r>
-          </a:p>
-          <a:p>
-            <a:r>
-              <a:t>https://docs.github.com/en/copilot/concepts/billing-and-usage/individuals/billing</a:t>
-            </a:r>
-          </a:p>
-          <a:p>
-            <a:r>
-              <a:t>https://education.github.com/pack</a:t>
-            </a:r>
-          </a:p>
-          <a:p>
-            <a:r>
-              <a:t>https://docs.github.com/en/education/about-github-education/github-education-for-students/apply-to-github-education-as-a-student</a:t>
-            </a:r>
-          </a:p>
-          <a:p>
-            <a:r>
-              <a:t>https://www.3blue1brown.com/lessons/mini-llm/</a:t>
-            </a:r>
-          </a:p>
-        </p:txBody>
-      </p:sp>
-      <p:sp>
-        <p:nvSpPr>
-          <p:cNvPr id="4" name="Slide Number Placeholder 3"/>
-          <p:cNvSpPr>
-            <a:spLocks noGrp="1"/>
-          </p:cNvSpPr>
-          <p:nvPr>
-            <p:ph type="sldNum" idx="5" sz="quarter"/>
-          </p:nvPr>
-        </p:nvSpPr>
-        <p:spPr/>
-      </p:sp>
-    </p:spTree>
-  </p:cSld>
-  <p:clrMapOvr>
-    <a:masterClrMapping/>
-  </p:clrMapOvr>
-</p:notes>
-</file>
-
-<file path=ppt/notesSlides/notesSlide14.xml><?xml version="1.0" encoding="utf-8"?>
-<p:notes xmlns:a="http://schemas.openxmlformats.org/drawingml/2006/main" xmlns:p="http://schemas.openxmlformats.org/presentationml/2006/main" xmlns:r="http://schemas.openxmlformats.org/officeDocument/2006/relationships">
-  <p:cSld>
-    <p:spTree>
-      <p:nvGrpSpPr>
-        <p:cNvPr id="1" name=""/>
-        <p:cNvGrpSpPr/>
-        <p:nvPr/>
-      </p:nvGrpSpPr>
-      <p:grpSpPr>
-        <a:xfrm>
-          <a:off x="0" y="0"/>
-          <a:ext cx="0" cy="0"/>
-          <a:chOff x="0" y="0"/>
-          <a:chExt cx="0" cy="0"/>
-        </a:xfrm>
-      </p:grpSpPr>
-      <p:sp>
-        <p:nvSpPr>
-          <p:cNvPr id="2" name="Slide Image Placeholder 1"/>
-          <p:cNvSpPr>
-            <a:spLocks noGrp="1"/>
-          </p:cNvSpPr>
-          <p:nvPr>
-            <p:ph type="sldImg" idx="2"/>
-          </p:nvPr>
-        </p:nvSpPr>
-        <p:spPr/>
-      </p:sp>
-      <p:sp>
-        <p:nvSpPr>
-          <p:cNvPr id="3" name="Notes Placeholder 2"/>
-          <p:cNvSpPr>
-            <a:spLocks noGrp="1"/>
-          </p:cNvSpPr>
-          <p:nvPr>
-            <p:ph type="body" idx="3" sz="quarter"/>
-          </p:nvPr>
-        </p:nvSpPr>
-        <p:spPr/>
-        <p:txBody>
-          <a:bodyPr/>
-          <a:lstStyle/>
-          <a:p>
-            <a:r>
-              <a:t>SLIDE 14</a:t>
-            </a:r>
-          </a:p>
-          <a:p/>
-          <a:p>
-            <a:r>
-              <a:t>As vrea sa ramaneti cu trei lucruri.</a:t>
-            </a:r>
-          </a:p>
-          <a:p>
-            <a:r>
-              <a:t>AI este un instrument foarte puternic, dar nu este infailibil.</a:t>
-            </a:r>
-          </a:p>
-          <a:p>
-            <a:r>
-              <a:t>Valoarea voastra ramane in intrebarile pe care le puneti, in alegeri si in felul in care ganditi.</a:t>
-            </a:r>
-          </a:p>
-          <a:p>
-            <a:r>
-              <a:t>Si nu trebuie sa stiti deja totul ca sa incepeti sa explorati si sa construiti.</a:t>
-            </a:r>
-          </a:p>
-          <a:p>
-            <a:r>
-              <a:t>Eu am inceput cu o foaie de comenzi si programe pe hartie. Provocarea mea pentru voi: alegeti o idee, incercati-o si aratati ce ati schimbat, verificat si invatat. Puteti incepe si pe hartie.</a:t>
-            </a:r>
-          </a:p>
-          <a:p>
-            <a:r>
-              <a:t>Acum sunt curios ce intrebari aveti.</a:t>
-            </a:r>
-          </a:p>
-          <a:p/>
-          <a:p>
-            <a:r>
-              <a:t>SURSE</a:t>
-            </a:r>
-          </a:p>
-          <a:p>
-            <a:r>
-              <a:t>Poveste oferita de Dragos sau exemplu educational original.</a:t>
-            </a:r>
-          </a:p>
-        </p:txBody>
-      </p:sp>
-      <p:sp>
-        <p:nvSpPr>
-          <p:cNvPr id="4" name="Slide Number Placeholder 3"/>
-          <p:cNvSpPr>
-            <a:spLocks noGrp="1"/>
-          </p:cNvSpPr>
-          <p:nvPr>
-            <p:ph type="sldNum" idx="5" sz="quarter"/>
-          </p:nvPr>
-        </p:nvSpPr>
-        <p:spPr/>
-      </p:sp>
-    </p:spTree>
-  </p:cSld>
-  <p:clrMapOvr>
-    <a:masterClrMapping/>
-  </p:clrMapOvr>
-</p:notes>
-</file>
-
-<file path=ppt/notesSlides/notesSlide2.xml><?xml version="1.0" encoding="utf-8"?>
-<p:notes xmlns:a="http://schemas.openxmlformats.org/drawingml/2006/main" xmlns:p="http://schemas.openxmlformats.org/presentationml/2006/main" xmlns:r="http://schemas.openxmlformats.org/officeDocument/2006/relationships">
-  <p:cSld>
-    <p:spTree>
-      <p:nvGrpSpPr>
-        <p:cNvPr id="1" name=""/>
-        <p:cNvGrpSpPr/>
-        <p:nvPr/>
-      </p:nvGrpSpPr>
-      <p:grpSpPr>
-        <a:xfrm>
-          <a:off x="0" y="0"/>
-          <a:ext cx="0" cy="0"/>
-          <a:chOff x="0" y="0"/>
-          <a:chExt cx="0" cy="0"/>
-        </a:xfrm>
-      </p:grpSpPr>
-      <p:sp>
-        <p:nvSpPr>
-          <p:cNvPr id="2" name="Slide Image Placeholder 1"/>
-          <p:cNvSpPr>
-            <a:spLocks noGrp="1"/>
-          </p:cNvSpPr>
-          <p:nvPr>
-            <p:ph type="sldImg" idx="2"/>
-          </p:nvPr>
-        </p:nvSpPr>
-        <p:spPr/>
-      </p:sp>
-      <p:sp>
-        <p:nvSpPr>
-          <p:cNvPr id="3" name="Notes Placeholder 2"/>
-          <p:cNvSpPr>
-            <a:spLocks noGrp="1"/>
-          </p:cNvSpPr>
-          <p:nvPr>
-            <p:ph type="body" idx="3" sz="quarter"/>
-          </p:nvPr>
-        </p:nvSpPr>
-        <p:spPr/>
-        <p:txBody>
-          <a:bodyPr/>
-          <a:lstStyle/>
-          <a:p>
-            <a:r>
-              <a:t>SLIDE 2</a:t>
-            </a:r>
-          </a:p>
-          <a:p/>
-          <a:p>
-            <a:r>
-              <a:t>Inainte sa va arat ceva, sunt curios de unde pornim. Pentru ce ati folosit AI pana acum? Alegeti varianta cea mai apropiata de voi; si 'inca nu' este un raspuns foarte bun.</a:t>
-            </a:r>
-          </a:p>
-          <a:p>
-            <a:r>
-              <a:t>Probabil avem experiente diferite. Pana la final vreau sa puteti face doua lucruri: sa formulati mai bine o cerere si sa verificati un rezultat fara sa va bazati doar pe AI.</a:t>
-            </a:r>
-          </a:p>
-          <a:p/>
-          <a:p>
-            <a:r>
-              <a:t>SURSE</a:t>
-            </a:r>
-          </a:p>
-          <a:p>
-            <a:r>
-              <a:t>Poveste oferita de Dragos sau exemplu educational original.</a:t>
-            </a:r>
-          </a:p>
-        </p:txBody>
-      </p:sp>
-      <p:sp>
-        <p:nvSpPr>
-          <p:cNvPr id="4" name="Slide Number Placeholder 3"/>
-          <p:cNvSpPr>
-            <a:spLocks noGrp="1"/>
-          </p:cNvSpPr>
-          <p:nvPr>
-            <p:ph type="sldNum" idx="5" sz="quarter"/>
-          </p:nvPr>
-        </p:nvSpPr>
-        <p:spPr/>
-      </p:sp>
-    </p:spTree>
-  </p:cSld>
-  <p:clrMapOvr>
-    <a:masterClrMapping/>
-  </p:clrMapOvr>
-</p:notes>
-</file>
-
-<file path=ppt/notesSlides/notesSlide3.xml><?xml version="1.0" encoding="utf-8"?>
-<p:notes xmlns:a="http://schemas.openxmlformats.org/drawingml/2006/main" xmlns:p="http://schemas.openxmlformats.org/presentationml/2006/main" xmlns:r="http://schemas.openxmlformats.org/officeDocument/2006/relationships">
-  <p:cSld>
-    <p:spTree>
-      <p:nvGrpSpPr>
-        <p:cNvPr id="1" name=""/>
-        <p:cNvGrpSpPr/>
-        <p:nvPr/>
-      </p:nvGrpSpPr>
-      <p:grpSpPr>
-        <a:xfrm>
-          <a:off x="0" y="0"/>
-          <a:ext cx="0" cy="0"/>
-          <a:chOff x="0" y="0"/>
-          <a:chExt cx="0" cy="0"/>
-        </a:xfrm>
-      </p:grpSpPr>
-      <p:sp>
-        <p:nvSpPr>
-          <p:cNvPr id="2" name="Slide Image Placeholder 1"/>
-          <p:cNvSpPr>
-            <a:spLocks noGrp="1"/>
-          </p:cNvSpPr>
-          <p:nvPr>
-            <p:ph type="sldImg" idx="2"/>
-          </p:nvPr>
-        </p:nvSpPr>
-        <p:spPr/>
-      </p:sp>
-      <p:sp>
-        <p:nvSpPr>
-          <p:cNvPr id="3" name="Notes Placeholder 2"/>
-          <p:cNvSpPr>
-            <a:spLocks noGrp="1"/>
-          </p:cNvSpPr>
-          <p:nvPr>
-            <p:ph type="body" idx="3" sz="quarter"/>
-          </p:nvPr>
-        </p:nvSpPr>
-        <p:spPr/>
-        <p:txBody>
-          <a:bodyPr/>
-          <a:lstStyle/>
-          <a:p>
-            <a:r>
-              <a:t>SLIDE 3</a:t>
-            </a:r>
-          </a:p>
-          <a:p/>
-          <a:p>
-            <a:r>
-              <a:t>AI nu a aparut odata cu aplicatiile pe care le folosim astazi. In 1950, Claude Shannon construia un soricel electromecanic care invata traseul printr-un labirint. La inceput explora. Apoi sistemul putea folosi drumul retinut.</a:t>
-            </a:r>
-          </a:p>
-          <a:p>
-            <a:r>
-              <a:t>In schema din stanga, traseul albastru reprezinta drumul retinut. Este o ilustratie a ideii, nu planul aparatului original.</a:t>
-            </a:r>
-          </a:p>
-          <a:p>
-            <a:r>
-              <a:t>In 1966, ELIZA putea parea un partener de conversatie folosind reguli si tipare. Parea ca intelege, desi mecanismul era foarte diferit de cel al asistentilor de azi.</a:t>
-            </a:r>
-          </a:p>
-          <a:p>
-            <a:r>
-              <a:t>Intre aceste experimente si ChatGPT au trecut decenii de cercetare. Lansarea publica din 2022 a adus o schimbare vizibila: mult mai multi oameni au putut incerca direct o conversatie cu AI.</a:t>
-            </a:r>
-          </a:p>
-          <a:p/>
-          <a:p>
-            <a:r>
-              <a:t>SURSE</a:t>
-            </a:r>
-          </a:p>
-          <a:p>
-            <a:r>
-              <a:t>https://www.technologyreview.com/2018/12/19/138508/mighty-mouse/</a:t>
-            </a:r>
-          </a:p>
-          <a:p>
-            <a:r>
-              <a:t>https://www-formal.stanford.edu/jmc/history/dartmouth/dartmouth.html</a:t>
-            </a:r>
-          </a:p>
-          <a:p>
-            <a:r>
-              <a:t>https://www.csail.mit.edu/news/eliza-wins-peabody-award</a:t>
-            </a:r>
-          </a:p>
-          <a:p>
-            <a:r>
-              <a:t>https://openai.com/index/chatgpt/</a:t>
-            </a:r>
-          </a:p>
-        </p:txBody>
-      </p:sp>
-      <p:sp>
-        <p:nvSpPr>
-          <p:cNvPr id="4" name="Slide Number Placeholder 3"/>
-          <p:cNvSpPr>
-            <a:spLocks noGrp="1"/>
-          </p:cNvSpPr>
-          <p:nvPr>
-            <p:ph type="sldNum" idx="5" sz="quarter"/>
-          </p:nvPr>
-        </p:nvSpPr>
-        <p:spPr/>
-      </p:sp>
-    </p:spTree>
-  </p:cSld>
-  <p:clrMapOvr>
-    <a:masterClrMapping/>
-  </p:clrMapOvr>
-</p:notes>
-</file>
-
-<file path=ppt/notesSlides/notesSlide4.xml><?xml version="1.0" encoding="utf-8"?>
-<p:notes xmlns:a="http://schemas.openxmlformats.org/drawingml/2006/main" xmlns:p="http://schemas.openxmlformats.org/presentationml/2006/main" xmlns:r="http://schemas.openxmlformats.org/officeDocument/2006/relationships">
-  <p:cSld>
-    <p:spTree>
-      <p:nvGrpSpPr>
-        <p:cNvPr id="1" name=""/>
-        <p:cNvGrpSpPr/>
-        <p:nvPr/>
-      </p:nvGrpSpPr>
-      <p:grpSpPr>
-        <a:xfrm>
-          <a:off x="0" y="0"/>
-          <a:ext cx="0" cy="0"/>
-          <a:chOff x="0" y="0"/>
-          <a:chExt cx="0" cy="0"/>
-        </a:xfrm>
-      </p:grpSpPr>
-      <p:sp>
-        <p:nvSpPr>
-          <p:cNvPr id="2" name="Slide Image Placeholder 1"/>
-          <p:cNvSpPr>
-            <a:spLocks noGrp="1"/>
-          </p:cNvSpPr>
-          <p:nvPr>
-            <p:ph type="sldImg" idx="2"/>
-          </p:nvPr>
-        </p:nvSpPr>
-        <p:spPr/>
-      </p:sp>
-      <p:sp>
-        <p:nvSpPr>
-          <p:cNvPr id="3" name="Notes Placeholder 2"/>
-          <p:cNvSpPr>
-            <a:spLocks noGrp="1"/>
-          </p:cNvSpPr>
-          <p:nvPr>
-            <p:ph type="body" idx="3" sz="quarter"/>
-          </p:nvPr>
-        </p:nvSpPr>
-        <p:spPr/>
-        <p:txBody>
-          <a:bodyPr/>
-          <a:lstStyle/>
-          <a:p>
-            <a:r>
-              <a:t>SLIDE 4</a:t>
-            </a:r>
-          </a:p>
-          <a:p/>
-          <a:p>
-            <a:r>
-              <a:t>La biblioteca am deschis... Ce ati pune mai departe: o carte, un laptop sau o umbrela?</a:t>
-            </a:r>
-          </a:p>
-          <a:p>
-            <a:r>
-              <a:t>Acum adaug ceva: aveam de terminat un proiect digital. Poate ca unii dintre voi ati schimba alegerea.</a:t>
-            </a:r>
-          </a:p>
-          <a:p>
-            <a:r>
-              <a:t>Nu exista un singur raspuns obligatoriu. Ce observam este ca informatia noua schimba continuarea la care ne asteptam. Acesta este un punct de plecare ca sa intelegem modelele de limbaj.</a:t>
-            </a:r>
-          </a:p>
-          <a:p>
-            <a:r>
-              <a:t>Voturile noastre nu sunt probabilitatile unui model. Modelul a invatat tipare din multe exemple si le foloseste impreuna cu contextul. Iar o continuare plauzibila poate fi totusi falsa.</a:t>
-            </a:r>
-          </a:p>
-          <a:p/>
-          <a:p>
-            <a:r>
-              <a:t>SURSE</a:t>
-            </a:r>
-          </a:p>
-          <a:p>
-            <a:r>
-              <a:t>https://www.3blue1brown.com/lessons/mini-llm/</a:t>
-            </a:r>
-          </a:p>
-        </p:txBody>
-      </p:sp>
-      <p:sp>
-        <p:nvSpPr>
-          <p:cNvPr id="4" name="Slide Number Placeholder 3"/>
-          <p:cNvSpPr>
-            <a:spLocks noGrp="1"/>
-          </p:cNvSpPr>
-          <p:nvPr>
-            <p:ph type="sldNum" idx="5" sz="quarter"/>
-          </p:nvPr>
-        </p:nvSpPr>
-        <p:spPr/>
-      </p:sp>
-    </p:spTree>
-  </p:cSld>
-  <p:clrMapOvr>
-    <a:masterClrMapping/>
-  </p:clrMapOvr>
-</p:notes>
-</file>
-
-<file path=ppt/notesSlides/notesSlide5.xml><?xml version="1.0" encoding="utf-8"?>
-<p:notes xmlns:a="http://schemas.openxmlformats.org/drawingml/2006/main" xmlns:p="http://schemas.openxmlformats.org/presentationml/2006/main" xmlns:r="http://schemas.openxmlformats.org/officeDocument/2006/relationships">
-  <p:cSld>
-    <p:spTree>
-      <p:nvGrpSpPr>
-        <p:cNvPr id="1" name=""/>
-        <p:cNvGrpSpPr/>
-        <p:nvPr/>
-      </p:nvGrpSpPr>
-      <p:grpSpPr>
-        <a:xfrm>
-          <a:off x="0" y="0"/>
-          <a:ext cx="0" cy="0"/>
-          <a:chOff x="0" y="0"/>
-          <a:chExt cx="0" cy="0"/>
-        </a:xfrm>
-      </p:grpSpPr>
-      <p:sp>
-        <p:nvSpPr>
-          <p:cNvPr id="2" name="Slide Image Placeholder 1"/>
-          <p:cNvSpPr>
-            <a:spLocks noGrp="1"/>
-          </p:cNvSpPr>
-          <p:nvPr>
-            <p:ph type="sldImg" idx="2"/>
-          </p:nvPr>
-        </p:nvSpPr>
-        <p:spPr/>
-      </p:sp>
-      <p:sp>
-        <p:nvSpPr>
-          <p:cNvPr id="3" name="Notes Placeholder 2"/>
-          <p:cNvSpPr>
-            <a:spLocks noGrp="1"/>
-          </p:cNvSpPr>
-          <p:nvPr>
-            <p:ph type="body" idx="3" sz="quarter"/>
-          </p:nvPr>
-        </p:nvSpPr>
-        <p:spPr/>
-        <p:txBody>
-          <a:bodyPr/>
-          <a:lstStyle/>
-          <a:p>
-            <a:r>
-              <a:t>SLIDE 5</a:t>
-            </a:r>
-          </a:p>
-          <a:p/>
-          <a:p>
-            <a:r>
-              <a:t>Un LLM genereaza textul pas cu pas. Priveste contextul, atribuie probabilitati unor continuari si selecteaza un token, adica un fragment de text. Uneori este un cuvant, alteori doar o parte. Fragmentul se adauga si procesul continua.</a:t>
-            </a:r>
-          </a:p>
-          <a:p>
-            <a:r>
-              <a:t>De ce poate face mai mult decat completarea unei propozitii? In antrenare, modelul isi ajusteaza predictiile pe foarte multe exemple. Metodele si calculul au progresat. Alte etape de antrenare il ajuta sa urmeze cerinte si sa raspunda mai util.</a:t>
-            </a:r>
-          </a:p>
-          <a:p>
-            <a:r>
-              <a:t>Un asistent poate folosi si instrumente: cautare, analiza de imagini sau executare de cod. Astfel, de la o idee putem ajunge la o pagina pe care o deschidem si o incercam.</a:t>
-            </a:r>
-          </a:p>
-          <a:p>
-            <a:r>
-              <a:t>Dar faptul ca o poate genera nu inseamna ca a si verificat tot ce a scris.</a:t>
-            </a:r>
-          </a:p>
-          <a:p/>
-          <a:p>
-            <a:r>
-              <a:t>SURSE</a:t>
-            </a:r>
-          </a:p>
-          <a:p>
-            <a:r>
-              <a:t>https://www.3blue1brown.com/lessons/mini-llm/</a:t>
-            </a:r>
-          </a:p>
-        </p:txBody>
-      </p:sp>
-      <p:sp>
-        <p:nvSpPr>
-          <p:cNvPr id="4" name="Slide Number Placeholder 3"/>
-          <p:cNvSpPr>
-            <a:spLocks noGrp="1"/>
-          </p:cNvSpPr>
-          <p:nvPr>
-            <p:ph type="sldNum" idx="5" sz="quarter"/>
-          </p:nvPr>
-        </p:nvSpPr>
-        <p:spPr/>
-      </p:sp>
-    </p:spTree>
-  </p:cSld>
-  <p:clrMapOvr>
-    <a:masterClrMapping/>
-  </p:clrMapOvr>
-</p:notes>
-</file>
-
-<file path=ppt/notesSlides/notesSlide6.xml><?xml version="1.0" encoding="utf-8"?>
-<p:notes xmlns:a="http://schemas.openxmlformats.org/drawingml/2006/main" xmlns:p="http://schemas.openxmlformats.org/presentationml/2006/main" xmlns:r="http://schemas.openxmlformats.org/officeDocument/2006/relationships">
-  <p:cSld>
-    <p:spTree>
-      <p:nvGrpSpPr>
-        <p:cNvPr id="1" name=""/>
-        <p:cNvGrpSpPr/>
-        <p:nvPr/>
-      </p:nvGrpSpPr>
-      <p:grpSpPr>
-        <a:xfrm>
-          <a:off x="0" y="0"/>
-          <a:ext cx="0" cy="0"/>
-          <a:chOff x="0" y="0"/>
-          <a:chExt cx="0" cy="0"/>
-        </a:xfrm>
-      </p:grpSpPr>
-      <p:sp>
-        <p:nvSpPr>
-          <p:cNvPr id="2" name="Slide Image Placeholder 1"/>
-          <p:cNvSpPr>
-            <a:spLocks noGrp="1"/>
-          </p:cNvSpPr>
-          <p:nvPr>
-            <p:ph type="sldImg" idx="2"/>
-          </p:nvPr>
-        </p:nvSpPr>
-        <p:spPr/>
-      </p:sp>
-      <p:sp>
-        <p:nvSpPr>
-          <p:cNvPr id="3" name="Notes Placeholder 2"/>
-          <p:cNvSpPr>
-            <a:spLocks noGrp="1"/>
-          </p:cNvSpPr>
-          <p:nvPr>
-            <p:ph type="body" idx="3" sz="quarter"/>
-          </p:nvPr>
-        </p:nvSpPr>
-        <p:spPr/>
-        <p:txBody>
-          <a:bodyPr/>
-          <a:lstStyle/>
-          <a:p>
-            <a:r>
-              <a:t>SLIDE 6</a:t>
-            </a:r>
-          </a:p>
-          <a:p/>
-          <a:p>
-            <a:r>
-              <a:t>Sa luam o idee simpla: vrem o pagina pentru un eveniment la liceu. Nu trebuie sa stim deja cum se scrie fiecare linie de cod ca sa putem descrie ce vrem.</a:t>
-            </a:r>
-          </a:p>
-          <a:p>
-            <a:r>
-              <a:t>Priviti pagina: ce ati cauta daca ati fi invitati? Data, ora, locul, activitatile, costul. Exact aceste lucruri vor deveni criteriile noastre.</a:t>
-            </a:r>
-          </a:p>
-          <a:p>
-            <a:r>
-              <a:t>Aceasta captura este un exemplu pregatit pentru sesiune. In Copilot vom vedea ce putem obtine pornind de la o cerere si cum se schimba rezultatul cand o clarificam.</a:t>
-            </a:r>
-          </a:p>
-          <a:p/>
-          <a:p>
-            <a:r>
-              <a:t>SURSE</a:t>
-            </a:r>
-          </a:p>
-          <a:p>
-            <a:r>
-              <a:t>Poveste oferita de Dragos sau exemplu educational original.</a:t>
-            </a:r>
-          </a:p>
-        </p:txBody>
-      </p:sp>
-      <p:sp>
-        <p:nvSpPr>
-          <p:cNvPr id="4" name="Slide Number Placeholder 3"/>
-          <p:cNvSpPr>
-            <a:spLocks noGrp="1"/>
-          </p:cNvSpPr>
-          <p:nvPr>
-            <p:ph type="sldNum" idx="5" sz="quarter"/>
-          </p:nvPr>
-        </p:nvSpPr>
-        <p:spPr/>
-      </p:sp>
-    </p:spTree>
-  </p:cSld>
-  <p:clrMapOvr>
-    <a:masterClrMapping/>
-  </p:clrMapOvr>
-</p:notes>
-</file>
-
-<file path=ppt/notesSlides/notesSlide7.xml><?xml version="1.0" encoding="utf-8"?>
-<p:notes xmlns:a="http://schemas.openxmlformats.org/drawingml/2006/main" xmlns:p="http://schemas.openxmlformats.org/presentationml/2006/main" xmlns:r="http://schemas.openxmlformats.org/officeDocument/2006/relationships">
-  <p:cSld>
-    <p:spTree>
-      <p:nvGrpSpPr>
-        <p:cNvPr id="1" name=""/>
-        <p:cNvGrpSpPr/>
-        <p:nvPr/>
-      </p:nvGrpSpPr>
-      <p:grpSpPr>
-        <a:xfrm>
-          <a:off x="0" y="0"/>
-          <a:ext cx="0" cy="0"/>
-          <a:chOff x="0" y="0"/>
-          <a:chExt cx="0" cy="0"/>
-        </a:xfrm>
-      </p:grpSpPr>
-      <p:sp>
-        <p:nvSpPr>
-          <p:cNvPr id="2" name="Slide Image Placeholder 1"/>
-          <p:cNvSpPr>
-            <a:spLocks noGrp="1"/>
-          </p:cNvSpPr>
-          <p:nvPr>
-            <p:ph type="sldImg" idx="2"/>
-          </p:nvPr>
-        </p:nvSpPr>
-        <p:spPr/>
-      </p:sp>
-      <p:sp>
-        <p:nvSpPr>
-          <p:cNvPr id="3" name="Notes Placeholder 2"/>
-          <p:cNvSpPr>
-            <a:spLocks noGrp="1"/>
-          </p:cNvSpPr>
-          <p:nvPr>
-            <p:ph type="body" idx="3" sz="quarter"/>
-          </p:nvPr>
-        </p:nvSpPr>
-        <p:spPr/>
-        <p:txBody>
-          <a:bodyPr/>
-          <a:lstStyle/>
-          <a:p>
-            <a:r>
-              <a:t>SLIDE 7</a:t>
-            </a:r>
-          </a:p>
-          <a:p/>
-          <a:p>
-            <a:r>
-              <a:t>O sa incep intentionat cu o cerere scurta: fa o pagina pentru un eveniment la liceu.</a:t>
-            </a:r>
-          </a:p>
-          <a:p>
-            <a:r>
-              <a:t>Sa vedem ce intelege din ea. Daca imi cere detalii, foarte bine: a observat ca ii lipsesc informatii. Daca produce direct o pagina, ne uitam la presupunerile pe care le-a facut.</a:t>
-            </a:r>
-          </a:p>
-          <a:p>
-            <a:r>
-              <a:t>Nu cautam sa obtinem ceva perfect din prima. Vrem sa vedem unde trebuie sa intervenim noi. O pagina poate arata bine si totusi sa nu spuna cand are loc evenimentul.</a:t>
-            </a:r>
-          </a:p>
-          <a:p/>
-          <a:p>
-            <a:r>
-              <a:t>SURSE</a:t>
-            </a:r>
-          </a:p>
-          <a:p>
-            <a:r>
-              <a:t>Poveste oferita de Dragos sau exemplu educational original.</a:t>
-            </a:r>
-          </a:p>
-        </p:txBody>
-      </p:sp>
-      <p:sp>
-        <p:nvSpPr>
-          <p:cNvPr id="4" name="Slide Number Placeholder 3"/>
-          <p:cNvSpPr>
-            <a:spLocks noGrp="1"/>
-          </p:cNvSpPr>
-          <p:nvPr>
-            <p:ph type="sldNum" idx="5" sz="quarter"/>
-          </p:nvPr>
-        </p:nvSpPr>
-        <p:spPr/>
-      </p:sp>
-    </p:spTree>
-  </p:cSld>
-  <p:clrMapOvr>
-    <a:masterClrMapping/>
-  </p:clrMapOvr>
-</p:notes>
-</file>
-
-<file path=ppt/notesSlides/notesSlide8.xml><?xml version="1.0" encoding="utf-8"?>
-<p:notes xmlns:a="http://schemas.openxmlformats.org/drawingml/2006/main" xmlns:p="http://schemas.openxmlformats.org/presentationml/2006/main" xmlns:r="http://schemas.openxmlformats.org/officeDocument/2006/relationships">
-  <p:cSld>
-    <p:spTree>
-      <p:nvGrpSpPr>
-        <p:cNvPr id="1" name=""/>
-        <p:cNvGrpSpPr/>
-        <p:nvPr/>
-      </p:nvGrpSpPr>
-      <p:grpSpPr>
-        <a:xfrm>
-          <a:off x="0" y="0"/>
-          <a:ext cx="0" cy="0"/>
-          <a:chOff x="0" y="0"/>
-          <a:chExt cx="0" cy="0"/>
-        </a:xfrm>
-      </p:grpSpPr>
-      <p:sp>
-        <p:nvSpPr>
-          <p:cNvPr id="2" name="Slide Image Placeholder 1"/>
-          <p:cNvSpPr>
-            <a:spLocks noGrp="1"/>
-          </p:cNvSpPr>
-          <p:nvPr>
-            <p:ph type="sldImg" idx="2"/>
-          </p:nvPr>
-        </p:nvSpPr>
-        <p:spPr/>
-      </p:sp>
-      <p:sp>
-        <p:nvSpPr>
-          <p:cNvPr id="3" name="Notes Placeholder 2"/>
-          <p:cNvSpPr>
-            <a:spLocks noGrp="1"/>
-          </p:cNvSpPr>
-          <p:nvPr>
-            <p:ph type="body" idx="3" sz="quarter"/>
-          </p:nvPr>
-        </p:nvSpPr>
-        <p:spPr/>
-        <p:txBody>
-          <a:bodyPr/>
-          <a:lstStyle/>
-          <a:p>
-            <a:r>
-              <a:t>SLIDE 8</a:t>
-            </a:r>
-          </a:p>
-          <a:p/>
-          <a:p>
-            <a:r>
-              <a:t>Ce voiam, de fapt? O pagina care sa ajute un elev sa inteleaga daca vrea sa vina. Acum avem un scop si detalii.</a:t>
-            </a:r>
-          </a:p>
-          <a:p>
-            <a:r>
-              <a:t>Adaugam numele, data, ora, locul, accesul gratuit si faptul ca trebuie sa mearga pe telefon. Cand schimbam cererea, avem si criterii dupa care putem judeca pagina.</a:t>
-            </a:r>
-          </a:p>
-          <a:p>
-            <a:r>
-              <a:t>Puteti scrie in chat un lucru pe care l-ati mai clarifica. Eu am pregatit deja cateva, asa ca putem continua si fara raspunsuri.</a:t>
-            </a:r>
-          </a:p>
-          <a:p>
-            <a:r>
-              <a:t>Gandirea critica incepe chiar din felul in care intrebam. 'De ce AI ii face pe elevi lenesi?' presupune deja concluzia. 'Cand poate AI ajuta sau impiedica invatarea?' ne lasa sa exploram mai multe explicatii.</a:t>
-            </a:r>
-          </a:p>
-          <a:p>
-            <a:r>
-              <a:t>O cerere mai buna poate aduce un rezultat mai util. Nu garanteaza ca fiecare informatie este adevarata.</a:t>
-            </a:r>
-          </a:p>
-          <a:p/>
-          <a:p>
-            <a:r>
-              <a:t>SURSE</a:t>
-            </a:r>
-          </a:p>
-          <a:p>
-            <a:r>
-              <a:t>https://uit.stanford.edu/service/techtraining/ai-demystified/prompt-engineering</a:t>
-            </a:r>
-          </a:p>
-        </p:txBody>
-      </p:sp>
-      <p:sp>
-        <p:nvSpPr>
-          <p:cNvPr id="4" name="Slide Number Placeholder 3"/>
-          <p:cNvSpPr>
-            <a:spLocks noGrp="1"/>
-          </p:cNvSpPr>
-          <p:nvPr>
-            <p:ph type="sldNum" idx="5" sz="quarter"/>
-          </p:nvPr>
-        </p:nvSpPr>
-        <p:spPr/>
-      </p:sp>
-    </p:spTree>
-  </p:cSld>
-  <p:clrMapOvr>
-    <a:masterClrMapping/>
-  </p:clrMapOvr>
-</p:notes>
-</file>
-
-<file path=ppt/notesSlides/notesSlide9.xml><?xml version="1.0" encoding="utf-8"?>
-<p:notes xmlns:a="http://schemas.openxmlformats.org/drawingml/2006/main" xmlns:p="http://schemas.openxmlformats.org/presentationml/2006/main" xmlns:r="http://schemas.openxmlformats.org/officeDocument/2006/relationships">
-  <p:cSld>
-    <p:spTree>
-      <p:nvGrpSpPr>
-        <p:cNvPr id="1" name=""/>
-        <p:cNvGrpSpPr/>
-        <p:nvPr/>
-      </p:nvGrpSpPr>
-      <p:grpSpPr>
-        <a:xfrm>
-          <a:off x="0" y="0"/>
-          <a:ext cx="0" cy="0"/>
-          <a:chOff x="0" y="0"/>
-          <a:chExt cx="0" cy="0"/>
-        </a:xfrm>
-      </p:grpSpPr>
-      <p:sp>
-        <p:nvSpPr>
-          <p:cNvPr id="2" name="Slide Image Placeholder 1"/>
-          <p:cNvSpPr>
-            <a:spLocks noGrp="1"/>
-          </p:cNvSpPr>
-          <p:nvPr>
-            <p:ph type="sldImg" idx="2"/>
-          </p:nvPr>
-        </p:nvSpPr>
-        <p:spPr/>
-      </p:sp>
-      <p:sp>
-        <p:nvSpPr>
-          <p:cNvPr id="3" name="Notes Placeholder 2"/>
-          <p:cNvSpPr>
-            <a:spLocks noGrp="1"/>
-          </p:cNvSpPr>
-          <p:nvPr>
-            <p:ph type="body" idx="3" sz="quarter"/>
-          </p:nvPr>
-        </p:nvSpPr>
-        <p:spPr/>
-        <p:txBody>
-          <a:bodyPr/>
-          <a:lstStyle/>
-          <a:p>
-            <a:r>
-              <a:t>SLIDE 9</a:t>
-            </a:r>
-          </a:p>
-          <a:p/>
-          <a:p>
-            <a:r>
-              <a:t>Acum verificam trei lucruri diferite. Mai intai: respecta ce am cerut? Comparam data si ora cu cererea noastra, nu cu memoria modelului.</a:t>
-            </a:r>
-          </a:p>
-          <a:p>
-            <a:r>
-              <a:t>Apoi: functioneaza? Apasam pe buton si deschidem pagina la latimea unui telefon. Programul incepe la 17 si se termina la 19? Cele trei intervale de 40 de minute dau doua ore?</a:t>
-            </a:r>
-          </a:p>
-          <a:p>
-            <a:r>
-              <a:t>In sfarsit: putem trata informatia drept adevarata? Aici evenimentul este fictiv. Pentru unul real, faptul ca AI a pus o data pe pagina nu o confirma. O verificam cu organizatorul sau cu anuntul oficial.</a:t>
-            </a:r>
-          </a:p>
-          <a:p>
-            <a:r>
-              <a:t>Un raspuns poate suna sigur sau poate fi foarte frumos si totusi sa contina o informatie gresita. Tocmai de aceea trebuie sa alegem verificarea potrivita.</a:t>
-            </a:r>
-          </a:p>
-          <a:p/>
-          <a:p>
-            <a:r>
-              <a:t>SURSE</a:t>
-            </a:r>
-          </a:p>
-          <a:p>
-            <a:r>
-              <a:t>https://dayofai.org/units/truth-tricks-and-ai-learning-to-verify-information</a:t>
-            </a:r>
-          </a:p>
-        </p:txBody>
-      </p:sp>
-      <p:sp>
-        <p:nvSpPr>
-          <p:cNvPr id="4" name="Slide Number Placeholder 3"/>
-          <p:cNvSpPr>
-            <a:spLocks noGrp="1"/>
-          </p:cNvSpPr>
-          <p:nvPr>
-            <p:ph type="sldNum" idx="5" sz="quarter"/>
-          </p:nvPr>
-        </p:nvSpPr>
-        <p:spPr/>
-      </p:sp>
-    </p:spTree>
-  </p:cSld>
-  <p:clrMapOvr>
-    <a:masterClrMapping/>
-  </p:clrMapOvr>
-</p:notes>
 </file>
 
 <file path=ppt/slideLayouts/slideLayout1.xml><?xml version="1.0" encoding="utf-8"?>

</xml_diff>

<commit_message>
Show vague and precise prompt outputs on separate consecutive slides
Use matched screenshots of the tested results, vague first, and retain private-only notes.

Co-authored-by: Copilot App <223556219+Copilot@users.noreply.github.com>

Copilot-Session: 1eb2797f-3b87-49f8-85d2-d57d82049b02
</commit_message>
<xml_diff>
--- a/downloads/cartea-daliei-ai.pptx
+++ b/downloads/cartea-daliei-ai.pptx
@@ -11621,7 +11621,7 @@
                 </a:solidFill>
                 <a:latin typeface="Aptos Display"/>
               </a:rPr>
-              <a:t>O idee poate deveni o pagina.</a:t>
+              <a:t>Cerere vaga. Ce a completat AI?</a:t>
             </a:r>
           </a:p>
         </p:txBody>
@@ -11747,9 +11747,126 @@
           </a:p>
         </p:txBody>
       </p:sp>
+      <p:sp>
+        <p:nvSpPr>
+          <p:cNvPr id="6" name="TextBox 5"/>
+          <p:cNvSpPr txBox="1"/>
+          <p:nvPr/>
+        </p:nvSpPr>
+        <p:spPr>
+          <a:xfrm>
+            <a:off x="731520" y="1810512"/>
+            <a:ext cx="4572000" cy="384048"/>
+          </a:xfrm>
+          <a:prstGeom prst="rect">
+            <a:avLst/>
+          </a:prstGeom>
+          <a:noFill/>
+        </p:spPr>
+        <p:txBody>
+          <a:bodyPr wrap="square" lIns="22860" rIns="22860" tIns="22860" bIns="22860">
+            <a:spAutoFit/>
+          </a:bodyPr>
+          <a:lstStyle/>
+          <a:p>
+            <a:pPr>
+              <a:spcAft>
+                <a:spcPts val="800"/>
+              </a:spcAft>
+            </a:pPr>
+            <a:r>
+              <a:rPr sz="1600" b="1">
+                <a:solidFill>
+                  <a:srgbClr val="244BDD"/>
+                </a:solidFill>
+                <a:latin typeface="Aptos"/>
+              </a:rPr>
+              <a:t>PROMPTUL FOLOSIT</a:t>
+            </a:r>
+          </a:p>
+        </p:txBody>
+      </p:sp>
+      <p:sp>
+        <p:nvSpPr>
+          <p:cNvPr id="7" name="TextBox 6"/>
+          <p:cNvSpPr txBox="1"/>
+          <p:nvPr/>
+        </p:nvSpPr>
+        <p:spPr>
+          <a:xfrm>
+            <a:off x="731520" y="2395728"/>
+            <a:ext cx="4572000" cy="2880360"/>
+          </a:xfrm>
+          <a:prstGeom prst="rect">
+            <a:avLst/>
+          </a:prstGeom>
+          <a:noFill/>
+        </p:spPr>
+        <p:txBody>
+          <a:bodyPr wrap="square" lIns="22860" rIns="22860" tIns="22860" bIns="22860">
+            <a:spAutoFit/>
+          </a:bodyPr>
+          <a:lstStyle/>
+          <a:p>
+            <a:pPr>
+              <a:spcAft>
+                <a:spcPts val="800"/>
+              </a:spcAft>
+            </a:pPr>
+            <a:r>
+              <a:rPr sz="2400" b="0">
+                <a:solidFill>
+                  <a:srgbClr val="182636"/>
+                </a:solidFill>
+                <a:latin typeface="Aptos"/>
+              </a:rPr>
+              <a:t>Creeaza o pagina HTML pentru un eveniment la liceu. Vreau sa arate modern, sa fie interesanta pentru elevi si sa prezinte frumos activitatile, cu un titlu atractiv si un program bine organizat.</a:t>
+            </a:r>
+          </a:p>
+        </p:txBody>
+      </p:sp>
+      <p:sp>
+        <p:nvSpPr>
+          <p:cNvPr id="8" name="TextBox 7"/>
+          <p:cNvSpPr txBox="1"/>
+          <p:nvPr/>
+        </p:nvSpPr>
+        <p:spPr>
+          <a:xfrm>
+            <a:off x="731520" y="5458968"/>
+            <a:ext cx="4572000" cy="594360"/>
+          </a:xfrm>
+          <a:prstGeom prst="rect">
+            <a:avLst/>
+          </a:prstGeom>
+          <a:noFill/>
+        </p:spPr>
+        <p:txBody>
+          <a:bodyPr wrap="square" lIns="22860" rIns="22860" tIns="22860" bIns="22860">
+            <a:spAutoFit/>
+          </a:bodyPr>
+          <a:lstStyle/>
+          <a:p>
+            <a:pPr>
+              <a:spcAft>
+                <a:spcPts val="800"/>
+              </a:spcAft>
+            </a:pPr>
+            <a:r>
+              <a:rPr sz="2600" b="1">
+                <a:solidFill>
+                  <a:srgbClr val="244BDD"/>
+                </a:solidFill>
+                <a:latin typeface="Aptos"/>
+              </a:rPr>
+              <a:t>Ce detalii am lasat nespecificate?</a:t>
+            </a:r>
+          </a:p>
+        </p:txBody>
+      </p:sp>
       <p:pic>
         <p:nvPicPr>
-          <p:cNvPr id="6" name="Picture 5" descr="Captura decupata a paginii pregatite Atelier de idei, cu titlul si ilustratia; nu este output live din Copilot."/>
+          <p:cNvPr id="9" name="Picture 8" descr="Captura rezultatului real al promptului vag: pagina Fara catalog, 15 mai 2027, 10-15, Liceul Orizont. Date fictive completate in generarea pregatita."/>
           <p:cNvPicPr>
             <a:picLocks noChangeAspect="1"/>
           </p:cNvPicPr>
@@ -11763,8 +11880,8 @@
         </p:blipFill>
         <p:spPr>
           <a:xfrm>
-            <a:off x="693911" y="1801368"/>
-            <a:ext cx="6796056" cy="2743200"/>
+            <a:off x="5669280" y="1810512"/>
+            <a:ext cx="5852160" cy="4114800"/>
           </a:xfrm>
           <a:prstGeom prst="rect">
             <a:avLst/>
@@ -11773,134 +11890,39 @@
       </p:pic>
       <p:sp>
         <p:nvSpPr>
-          <p:cNvPr id="7" name="TextBox 6"/>
-          <p:cNvSpPr txBox="1"/>
-          <p:nvPr/>
-        </p:nvSpPr>
-        <p:spPr>
-          <a:xfrm>
-            <a:off x="7909560" y="2029968"/>
-            <a:ext cx="3566160" cy="2121408"/>
-          </a:xfrm>
-          <a:prstGeom prst="rect">
-            <a:avLst/>
-          </a:prstGeom>
-          <a:noFill/>
-        </p:spPr>
-        <p:txBody>
-          <a:bodyPr wrap="square" lIns="22860" rIns="22860" tIns="22860" bIns="22860">
-            <a:spAutoFit/>
-          </a:bodyPr>
-          <a:lstStyle/>
-          <a:p>
-            <a:pPr>
-              <a:spcAft>
-                <a:spcPts val="800"/>
-              </a:spcAft>
-            </a:pPr>
-            <a:r>
-              <a:rPr sz="2700" b="1">
-                <a:solidFill>
-                  <a:srgbClr val="244BDD"/>
-                </a:solidFill>
-                <a:latin typeface="Aptos"/>
-              </a:rPr>
-              <a:t>Ce trebuie sa afli</a:t>
-            </a:r>
-          </a:p>
-          <a:p>
-            <a:pPr>
-              <a:spcAft>
-                <a:spcPts val="800"/>
-              </a:spcAft>
-            </a:pPr>
-            <a:r>
-              <a:rPr sz="2700" b="1">
-                <a:solidFill>
-                  <a:srgbClr val="244BDD"/>
-                </a:solidFill>
-                <a:latin typeface="Aptos"/>
-              </a:rPr>
-              <a:t>ca sa decizi daca</a:t>
-            </a:r>
-          </a:p>
-          <a:p>
-            <a:pPr>
-              <a:spcAft>
-                <a:spcPts val="800"/>
-              </a:spcAft>
-            </a:pPr>
-            <a:r>
-              <a:rPr sz="2700" b="1">
-                <a:solidFill>
-                  <a:srgbClr val="244BDD"/>
-                </a:solidFill>
-                <a:latin typeface="Aptos"/>
-              </a:rPr>
-              <a:t>vrei sa participi?</a:t>
-            </a:r>
-          </a:p>
-        </p:txBody>
-      </p:sp>
-      <p:pic>
-        <p:nvPicPr>
-          <p:cNvPr id="8" name="Picture 7" descr="Detalii din acelasi exemplu fictiv, marite: 30 octombrie 2026, 17-19, sala de festivitati, acces gratuit."/>
-          <p:cNvPicPr>
-            <a:picLocks noChangeAspect="1"/>
-          </p:cNvPicPr>
-          <p:nvPr/>
-        </p:nvPicPr>
-        <p:blipFill>
-          <a:blip r:embed="rId3"/>
-          <a:stretch>
-            <a:fillRect/>
-          </a:stretch>
-        </p:blipFill>
-        <p:spPr>
-          <a:xfrm>
-            <a:off x="731520" y="4619169"/>
-            <a:ext cx="10698480" cy="1304692"/>
-          </a:xfrm>
-          <a:prstGeom prst="rect">
-            <a:avLst/>
-          </a:prstGeom>
-        </p:spPr>
-      </p:pic>
-      <p:sp>
-        <p:nvSpPr>
-          <p:cNvPr id="9" name="TextBox 8"/>
-          <p:cNvSpPr txBox="1"/>
-          <p:nvPr/>
-        </p:nvSpPr>
-        <p:spPr>
-          <a:xfrm>
-            <a:off x="731520" y="5989320"/>
-            <a:ext cx="10424160" cy="256032"/>
-          </a:xfrm>
-          <a:prstGeom prst="rect">
-            <a:avLst/>
-          </a:prstGeom>
-          <a:noFill/>
-        </p:spPr>
-        <p:txBody>
-          <a:bodyPr wrap="square" lIns="22860" rIns="22860" tIns="22860" bIns="22860">
-            <a:spAutoFit/>
-          </a:bodyPr>
-          <a:lstStyle/>
-          <a:p>
-            <a:pPr>
-              <a:spcAft>
-                <a:spcPts val="800"/>
-              </a:spcAft>
-            </a:pPr>
-            <a:r>
-              <a:rPr sz="1500" b="0">
+          <p:cNvPr id="10" name="TextBox 9"/>
+          <p:cNvSpPr txBox="1"/>
+          <p:nvPr/>
+        </p:nvSpPr>
+        <p:spPr>
+          <a:xfrm>
+            <a:off x="5715000" y="6016752"/>
+            <a:ext cx="5669280" cy="256032"/>
+          </a:xfrm>
+          <a:prstGeom prst="rect">
+            <a:avLst/>
+          </a:prstGeom>
+          <a:noFill/>
+        </p:spPr>
+        <p:txBody>
+          <a:bodyPr wrap="square" lIns="22860" rIns="22860" tIns="22860" bIns="22860">
+            <a:spAutoFit/>
+          </a:bodyPr>
+          <a:lstStyle/>
+          <a:p>
+            <a:pPr>
+              <a:spcAft>
+                <a:spcPts val="800"/>
+              </a:spcAft>
+            </a:pPr>
+            <a:r>
+              <a:rPr sz="1200" b="0">
                 <a:solidFill>
                   <a:srgbClr val="526176"/>
                 </a:solidFill>
                 <a:latin typeface="Aptos"/>
               </a:rPr>
-              <a:t>Capturi ale exemplului pregatit, cu detaliile marite. Eveniment fictiv.</a:t>
+              <a:t>Rezultat inregistrat · eveniment fictiv · captura 1280 x 900</a:t>
             </a:r>
           </a:p>
         </p:txBody>
@@ -11919,7 +11941,7 @@
     <p:bg>
       <p:bgPr>
         <a:solidFill>
-          <a:srgbClr val="182636"/>
+          <a:srgbClr val="F5F3EC"/>
         </a:solidFill>
         <a:effectLst/>
       </p:bgPr>
@@ -11961,11 +11983,11 @@
             <a:r>
               <a:rPr sz="3600" b="1">
                 <a:solidFill>
-                  <a:srgbClr val="FFFFFF"/>
+                  <a:srgbClr val="182636"/>
                 </a:solidFill>
                 <a:latin typeface="Aptos Display"/>
               </a:rPr>
-              <a:t>Sa vedem ce intelege dintr-o idee.</a:t>
+              <a:t>Aceeasi idee, cu detalii concrete.</a:t>
             </a:r>
           </a:p>
         </p:txBody>
@@ -11985,7 +12007,7 @@
             <a:avLst/>
           </a:prstGeom>
           <a:solidFill>
-            <a:srgbClr val="8190A2"/>
+            <a:srgbClr val="C7CBC8"/>
           </a:solidFill>
           <a:ln>
             <a:noFill/>
@@ -12043,7 +12065,7 @@
             <a:r>
               <a:rPr sz="900" b="0">
                 <a:solidFill>
-                  <a:srgbClr val="CDD6E1"/>
+                  <a:srgbClr val="526176"/>
                 </a:solidFill>
                 <a:latin typeface="Aptos"/>
               </a:rPr>
@@ -12082,7 +12104,7 @@
             <a:r>
               <a:rPr sz="1400" b="1">
                 <a:solidFill>
-                  <a:srgbClr val="FFFFFF"/>
+                  <a:srgbClr val="526176"/>
                 </a:solidFill>
                 <a:latin typeface="Aptos"/>
               </a:rPr>
@@ -12099,93 +12121,73 @@
         </p:nvSpPr>
         <p:spPr>
           <a:xfrm>
-            <a:off x="777240" y="2057400"/>
-            <a:ext cx="10424160" cy="1417320"/>
-          </a:xfrm>
-          <a:prstGeom prst="rect">
-            <a:avLst/>
-          </a:prstGeom>
-          <a:noFill/>
-        </p:spPr>
-        <p:txBody>
-          <a:bodyPr wrap="square" lIns="22860" rIns="22860" tIns="22860" bIns="22860">
-            <a:spAutoFit/>
-          </a:bodyPr>
-          <a:lstStyle/>
-          <a:p>
-            <a:pPr>
-              <a:spcAft>
-                <a:spcPts val="800"/>
-              </a:spcAft>
-            </a:pPr>
-            <a:r>
-              <a:rPr sz="3800" b="1">
-                <a:solidFill>
-                  <a:srgbClr val="FFFFFF"/>
-                </a:solidFill>
-                <a:latin typeface="Aptos"/>
-              </a:rPr>
-              <a:t>"Fa o pagina pentru</a:t>
-            </a:r>
-          </a:p>
-          <a:p>
-            <a:pPr>
-              <a:spcAft>
-                <a:spcPts val="800"/>
-              </a:spcAft>
-            </a:pPr>
-            <a:r>
-              <a:rPr sz="3800" b="1">
-                <a:solidFill>
-                  <a:srgbClr val="FFFFFF"/>
-                </a:solidFill>
-                <a:latin typeface="Aptos"/>
-              </a:rPr>
-              <a:t>un eveniment la liceu."</a:t>
-            </a:r>
-          </a:p>
-        </p:txBody>
-      </p:sp>
-      <p:sp>
-        <p:nvSpPr>
-          <p:cNvPr id="7" name="Rectangle 6"/>
-          <p:cNvSpPr/>
-          <p:nvPr/>
-        </p:nvSpPr>
-        <p:spPr>
-          <a:xfrm>
-            <a:off x="777240" y="3986784"/>
-            <a:ext cx="10607040" cy="22860"/>
-          </a:xfrm>
-          <a:prstGeom prst="rect">
-            <a:avLst/>
-          </a:prstGeom>
-          <a:solidFill>
-            <a:srgbClr val="8190A2"/>
-          </a:solidFill>
-          <a:ln>
-            <a:noFill/>
-          </a:ln>
-        </p:spPr>
-        <p:style>
-          <a:lnRef idx="1">
-            <a:schemeClr val="accent1"/>
-          </a:lnRef>
-          <a:fillRef idx="3">
-            <a:schemeClr val="accent1"/>
-          </a:fillRef>
-          <a:effectRef idx="2">
-            <a:schemeClr val="accent1"/>
-          </a:effectRef>
-          <a:fontRef idx="minor">
-            <a:schemeClr val="lt1"/>
-          </a:fontRef>
-        </p:style>
-        <p:txBody>
-          <a:bodyPr rtlCol="0" anchor="ctr"/>
-          <a:lstStyle/>
-          <a:p>
-            <a:pPr algn="ctr"/>
+            <a:off x="731520" y="1810512"/>
+            <a:ext cx="4572000" cy="384048"/>
+          </a:xfrm>
+          <a:prstGeom prst="rect">
+            <a:avLst/>
+          </a:prstGeom>
+          <a:noFill/>
+        </p:spPr>
+        <p:txBody>
+          <a:bodyPr wrap="square" lIns="22860" rIns="22860" tIns="22860" bIns="22860">
+            <a:spAutoFit/>
+          </a:bodyPr>
+          <a:lstStyle/>
+          <a:p>
+            <a:pPr>
+              <a:spcAft>
+                <a:spcPts val="800"/>
+              </a:spcAft>
+            </a:pPr>
+            <a:r>
+              <a:rPr sz="1600" b="1">
+                <a:solidFill>
+                  <a:srgbClr val="244BDD"/>
+                </a:solidFill>
+                <a:latin typeface="Aptos"/>
+              </a:rPr>
+              <a:t>PROMPTUL FOLOSIT</a:t>
+            </a:r>
+          </a:p>
+        </p:txBody>
+      </p:sp>
+      <p:sp>
+        <p:nvSpPr>
+          <p:cNvPr id="7" name="TextBox 6"/>
+          <p:cNvSpPr txBox="1"/>
+          <p:nvPr/>
+        </p:nvSpPr>
+        <p:spPr>
+          <a:xfrm>
+            <a:off x="731520" y="2395728"/>
+            <a:ext cx="4572000" cy="2880360"/>
+          </a:xfrm>
+          <a:prstGeom prst="rect">
+            <a:avLst/>
+          </a:prstGeom>
+          <a:noFill/>
+        </p:spPr>
+        <p:txBody>
+          <a:bodyPr wrap="square" lIns="22860" rIns="22860" tIns="22860" bIns="22860">
+            <a:spAutoFit/>
+          </a:bodyPr>
+          <a:lstStyle/>
+          <a:p>
+            <a:pPr>
+              <a:spcAft>
+                <a:spcPts val="800"/>
+              </a:spcAft>
+            </a:pPr>
+            <a:r>
+              <a:rPr sz="2400" b="0">
+                <a:solidFill>
+                  <a:srgbClr val="182636"/>
+                </a:solidFill>
+                <a:latin typeface="Aptos"/>
+              </a:rPr>
+              <a:t>Creeaza o pagina HTML pentru evenimentul fictiv Atelier de idei, la liceu: 30 octombrie, 17-19, sala festiva, gratuit. Include trei activitati de 40 minute, un buton spre program si afisare buna pe telefon.</a:t>
+            </a:r>
           </a:p>
         </p:txBody>
       </p:sp>
@@ -12197,72 +12199,112 @@
         </p:nvSpPr>
         <p:spPr>
           <a:xfrm>
-            <a:off x="777240" y="4517136"/>
-            <a:ext cx="10378440" cy="667512"/>
-          </a:xfrm>
-          <a:prstGeom prst="rect">
-            <a:avLst/>
-          </a:prstGeom>
-          <a:noFill/>
-        </p:spPr>
-        <p:txBody>
-          <a:bodyPr wrap="square" lIns="22860" rIns="22860" tIns="22860" bIns="22860">
-            <a:spAutoFit/>
-          </a:bodyPr>
-          <a:lstStyle/>
-          <a:p>
-            <a:pPr>
-              <a:spcAft>
-                <a:spcPts val="800"/>
-              </a:spcAft>
-            </a:pPr>
-            <a:r>
-              <a:rPr sz="2800" b="1">
-                <a:solidFill>
-                  <a:srgbClr val="D6EC79"/>
-                </a:solidFill>
-                <a:latin typeface="Aptos"/>
-              </a:rPr>
-              <a:t>Ce a presupus? Ce lipseste? Ce trebuie sa decidem noi?</a:t>
-            </a:r>
-          </a:p>
-        </p:txBody>
-      </p:sp>
-      <p:sp>
-        <p:nvSpPr>
-          <p:cNvPr id="9" name="TextBox 8"/>
-          <p:cNvSpPr txBox="1"/>
-          <p:nvPr/>
-        </p:nvSpPr>
-        <p:spPr>
-          <a:xfrm>
-            <a:off x="777240" y="5568696"/>
-            <a:ext cx="10378440" cy="402336"/>
-          </a:xfrm>
-          <a:prstGeom prst="rect">
-            <a:avLst/>
-          </a:prstGeom>
-          <a:noFill/>
-        </p:spPr>
-        <p:txBody>
-          <a:bodyPr wrap="square" lIns="22860" rIns="22860" tIns="22860" bIns="22860">
-            <a:spAutoFit/>
-          </a:bodyPr>
-          <a:lstStyle/>
-          <a:p>
-            <a:pPr>
-              <a:spcAft>
-                <a:spcPts val="800"/>
-              </a:spcAft>
-            </a:pPr>
-            <a:r>
-              <a:rPr sz="2500" b="0">
-                <a:solidFill>
-                  <a:srgbClr val="FFFFFF"/>
-                </a:solidFill>
-                <a:latin typeface="Aptos"/>
-              </a:rPr>
-              <a:t>Idee  &gt;  Cerere  &gt;  Prima versiune</a:t>
+            <a:off x="731520" y="5394960"/>
+            <a:ext cx="4572000" cy="777240"/>
+          </a:xfrm>
+          <a:prstGeom prst="rect">
+            <a:avLst/>
+          </a:prstGeom>
+          <a:noFill/>
+        </p:spPr>
+        <p:txBody>
+          <a:bodyPr wrap="square" lIns="22860" rIns="22860" tIns="22860" bIns="22860">
+            <a:spAutoFit/>
+          </a:bodyPr>
+          <a:lstStyle/>
+          <a:p>
+            <a:pPr>
+              <a:spcAft>
+                <a:spcPts val="800"/>
+              </a:spcAft>
+            </a:pPr>
+            <a:r>
+              <a:rPr sz="2500" b="1">
+                <a:solidFill>
+                  <a:srgbClr val="244BDD"/>
+                </a:solidFill>
+                <a:latin typeface="Aptos"/>
+              </a:rPr>
+              <a:t>Acum avem ce sa comparam</a:t>
+            </a:r>
+          </a:p>
+          <a:p>
+            <a:pPr>
+              <a:spcAft>
+                <a:spcPts val="800"/>
+              </a:spcAft>
+            </a:pPr>
+            <a:r>
+              <a:rPr sz="2500" b="1">
+                <a:solidFill>
+                  <a:srgbClr val="244BDD"/>
+                </a:solidFill>
+                <a:latin typeface="Aptos"/>
+              </a:rPr>
+              <a:t>si sa verificam.</a:t>
+            </a:r>
+          </a:p>
+        </p:txBody>
+      </p:sp>
+      <p:pic>
+        <p:nvPicPr>
+          <p:cNvPr id="9" name="Picture 8" descr="Captura rezultatului real al promptului mai precis: Atelier de idei, 30 octombrie, 17-19, sala festiva, gratuit. Eveniment fictiv."/>
+          <p:cNvPicPr>
+            <a:picLocks noChangeAspect="1"/>
+          </p:cNvPicPr>
+          <p:nvPr/>
+        </p:nvPicPr>
+        <p:blipFill>
+          <a:blip r:embed="rId2"/>
+          <a:stretch>
+            <a:fillRect/>
+          </a:stretch>
+        </p:blipFill>
+        <p:spPr>
+          <a:xfrm>
+            <a:off x="5669280" y="1810512"/>
+            <a:ext cx="5852160" cy="4114800"/>
+          </a:xfrm>
+          <a:prstGeom prst="rect">
+            <a:avLst/>
+          </a:prstGeom>
+        </p:spPr>
+      </p:pic>
+      <p:sp>
+        <p:nvSpPr>
+          <p:cNvPr id="10" name="TextBox 9"/>
+          <p:cNvSpPr txBox="1"/>
+          <p:nvPr/>
+        </p:nvSpPr>
+        <p:spPr>
+          <a:xfrm>
+            <a:off x="5715000" y="6016752"/>
+            <a:ext cx="5669280" cy="256032"/>
+          </a:xfrm>
+          <a:prstGeom prst="rect">
+            <a:avLst/>
+          </a:prstGeom>
+          <a:noFill/>
+        </p:spPr>
+        <p:txBody>
+          <a:bodyPr wrap="square" lIns="22860" rIns="22860" tIns="22860" bIns="22860">
+            <a:spAutoFit/>
+          </a:bodyPr>
+          <a:lstStyle/>
+          <a:p>
+            <a:pPr>
+              <a:spcAft>
+                <a:spcPts val="800"/>
+              </a:spcAft>
+            </a:pPr>
+            <a:r>
+              <a:rPr sz="1200" b="0">
+                <a:solidFill>
+                  <a:srgbClr val="526176"/>
+                </a:solidFill>
+                <a:latin typeface="Aptos"/>
+              </a:rPr>
+              <a:t>Rezultat inregistrat · eveniment fictiv · captura 1280 x 900</a:t>
             </a:r>
           </a:p>
         </p:txBody>

</xml_diff>